<commit_message>
Add Productivite, Nombre d'interventions, Valorisation du stock and Articles a epuisement to SAV/Achat section
Nb interventions and heures d'intervention come from a manual Bilan_Fiches sheet
(fiches papier lues chaque mois via docs/prompt_analyse_fiches_sav.md, pas
recalculable depuis l'historique). Heures travaillees = jours ouvres - absences,
Joel exclu. Mois-1 des interventions lu depuis le PPTX du mois precedent
(comme pour Livraison & Compta) quand fourni.

Co-Authored-By: Claude Sonnet 5 <noreply@anthropic.com>
</commit_message>
<xml_diff>
--- a/templates/KPI_SAV_Achat.pptx
+++ b/templates/KPI_SAV_Achat.pptx
@@ -198,7 +198,7 @@
           <a:p>
             <a:fld id="{787588A7-DD43-45B7-B375-B6CC0BEAB3B4}" type="datetimeFigureOut">
               <a:rPr lang="fr-FR" smtClean="0"/>
-              <a:t>22/09/2026</a:t>
+              <a:t>23/09/2026</a:t>
             </a:fld>
             <a:endParaRPr lang="fr-FR"/>
           </a:p>
@@ -780,7 +780,7 @@
           <a:p>
             <a:fld id="{A5656091-EE6E-465A-9046-2A2EAB629F6D}" type="datetimeFigureOut">
               <a:rPr lang="fr-FR" smtClean="0"/>
-              <a:t>22/09/2026</a:t>
+              <a:t>23/09/2026</a:t>
             </a:fld>
             <a:endParaRPr lang="fr-FR"/>
           </a:p>
@@ -978,7 +978,7 @@
           <a:p>
             <a:fld id="{A5656091-EE6E-465A-9046-2A2EAB629F6D}" type="datetimeFigureOut">
               <a:rPr lang="fr-FR" smtClean="0"/>
-              <a:t>22/09/2026</a:t>
+              <a:t>23/09/2026</a:t>
             </a:fld>
             <a:endParaRPr lang="fr-FR"/>
           </a:p>
@@ -1186,7 +1186,7 @@
           <a:p>
             <a:fld id="{A5656091-EE6E-465A-9046-2A2EAB629F6D}" type="datetimeFigureOut">
               <a:rPr lang="fr-FR" smtClean="0"/>
-              <a:t>22/09/2026</a:t>
+              <a:t>23/09/2026</a:t>
             </a:fld>
             <a:endParaRPr lang="fr-FR"/>
           </a:p>
@@ -1419,7 +1419,7 @@
           <a:p>
             <a:fld id="{A5656091-EE6E-465A-9046-2A2EAB629F6D}" type="datetimeFigureOut">
               <a:rPr lang="fr-FR" smtClean="0"/>
-              <a:t>22/09/2026</a:t>
+              <a:t>23/09/2026</a:t>
             </a:fld>
             <a:endParaRPr lang="fr-FR"/>
           </a:p>
@@ -1694,7 +1694,7 @@
           <a:p>
             <a:fld id="{A5656091-EE6E-465A-9046-2A2EAB629F6D}" type="datetimeFigureOut">
               <a:rPr lang="fr-FR" smtClean="0"/>
-              <a:t>22/09/2026</a:t>
+              <a:t>23/09/2026</a:t>
             </a:fld>
             <a:endParaRPr lang="fr-FR"/>
           </a:p>
@@ -1959,7 +1959,7 @@
           <a:p>
             <a:fld id="{A5656091-EE6E-465A-9046-2A2EAB629F6D}" type="datetimeFigureOut">
               <a:rPr lang="fr-FR" smtClean="0"/>
-              <a:t>22/09/2026</a:t>
+              <a:t>23/09/2026</a:t>
             </a:fld>
             <a:endParaRPr lang="fr-FR"/>
           </a:p>
@@ -2371,7 +2371,7 @@
           <a:p>
             <a:fld id="{A5656091-EE6E-465A-9046-2A2EAB629F6D}" type="datetimeFigureOut">
               <a:rPr lang="fr-FR" smtClean="0"/>
-              <a:t>22/09/2026</a:t>
+              <a:t>23/09/2026</a:t>
             </a:fld>
             <a:endParaRPr lang="fr-FR"/>
           </a:p>
@@ -2512,7 +2512,7 @@
           <a:p>
             <a:fld id="{A5656091-EE6E-465A-9046-2A2EAB629F6D}" type="datetimeFigureOut">
               <a:rPr lang="fr-FR" smtClean="0"/>
-              <a:t>22/09/2026</a:t>
+              <a:t>23/09/2026</a:t>
             </a:fld>
             <a:endParaRPr lang="fr-FR"/>
           </a:p>
@@ -2625,7 +2625,7 @@
           <a:p>
             <a:fld id="{A5656091-EE6E-465A-9046-2A2EAB629F6D}" type="datetimeFigureOut">
               <a:rPr lang="fr-FR" smtClean="0"/>
-              <a:t>22/09/2026</a:t>
+              <a:t>23/09/2026</a:t>
             </a:fld>
             <a:endParaRPr lang="fr-FR"/>
           </a:p>
@@ -2936,7 +2936,7 @@
           <a:p>
             <a:fld id="{A5656091-EE6E-465A-9046-2A2EAB629F6D}" type="datetimeFigureOut">
               <a:rPr lang="fr-FR" smtClean="0"/>
-              <a:t>22/09/2026</a:t>
+              <a:t>23/09/2026</a:t>
             </a:fld>
             <a:endParaRPr lang="fr-FR"/>
           </a:p>
@@ -3224,7 +3224,7 @@
           <a:p>
             <a:fld id="{A5656091-EE6E-465A-9046-2A2EAB629F6D}" type="datetimeFigureOut">
               <a:rPr lang="fr-FR" smtClean="0"/>
-              <a:t>22/09/2026</a:t>
+              <a:t>23/09/2026</a:t>
             </a:fld>
             <a:endParaRPr lang="fr-FR"/>
           </a:p>
@@ -3465,7 +3465,7 @@
           <a:p>
             <a:fld id="{A5656091-EE6E-465A-9046-2A2EAB629F6D}" type="datetimeFigureOut">
               <a:rPr lang="fr-FR" smtClean="0"/>
-              <a:t>22/09/2026</a:t>
+              <a:t>23/09/2026</a:t>
             </a:fld>
             <a:endParaRPr lang="fr-FR"/>
           </a:p>
@@ -9282,7 +9282,7 @@
                 <a:ea typeface="Calibri" pitchFamily="34" charset="-122"/>
                 <a:cs typeface="Calibri" pitchFamily="34" charset="-120"/>
               </a:rPr>
-              <a:t>% vs N-1</a:t>
+              <a:t>vs Mois-1</a:t>
             </a:r>
             <a:endParaRPr lang="en-US" sz="950" dirty="0"/>
           </a:p>
@@ -9505,13 +9505,2669 @@
       </p:sp>
       <p:sp>
         <p:nvSpPr>
-          <p:cNvPr id="13" name="Shape 11"/>
+          <p:cNvPr id="34" name="Text 17">
+            <a:extLst>
+              <a:ext uri="{FF2B5EF4-FFF2-40B4-BE49-F238E27FC236}">
+                <a16:creationId xmlns:a16="http://schemas.microsoft.com/office/drawing/2014/main" id="{59266B79-C43D-98A0-AAC4-CC53BA089B0A}"/>
+              </a:ext>
+            </a:extLst>
+          </p:cNvPr>
           <p:cNvSpPr/>
           <p:nvPr/>
         </p:nvSpPr>
         <p:spPr>
           <a:xfrm>
-            <a:off x="6217920" y="1508760"/>
+            <a:off x="960120" y="2356392"/>
+            <a:ext cx="1263737" cy="530352"/>
+          </a:xfrm>
+          <a:prstGeom prst="rect">
+            <a:avLst/>
+          </a:prstGeom>
+          <a:noFill/>
+          <a:ln/>
+        </p:spPr>
+        <p:txBody>
+          <a:bodyPr wrap="square" lIns="0" tIns="0" rIns="0" bIns="0" rtlCol="0" anchor="ctr">
+            <a:normAutofit/>
+          </a:bodyPr>
+          <a:lstStyle/>
+          <a:p>
+            <a:r>
+              <a:rPr lang="en-US" sz="2400" b="1" dirty="0">
+                <a:solidFill>
+                  <a:srgbClr val="0E7C86"/>
+                </a:solidFill>
+                <a:latin typeface="Cambria" pitchFamily="34" charset="0"/>
+                <a:ea typeface="Cambria" pitchFamily="34" charset="-122"/>
+                <a:cs typeface="Cambria" pitchFamily="34" charset="-120"/>
+              </a:rPr>
+              <a:t>749 k€</a:t>
+            </a:r>
+          </a:p>
+        </p:txBody>
+      </p:sp>
+      <p:graphicFrame>
+        <p:nvGraphicFramePr>
+          <p:cNvPr id="27" name="Tableau 26">
+            <a:extLst>
+              <a:ext uri="{FF2B5EF4-FFF2-40B4-BE49-F238E27FC236}">
+                <a16:creationId xmlns:a16="http://schemas.microsoft.com/office/drawing/2014/main" id="{917EA9C5-D578-5FEA-F14B-D47468219B9C}"/>
+              </a:ext>
+            </a:extLst>
+          </p:cNvPr>
+          <p:cNvGraphicFramePr>
+            <a:graphicFrameLocks noGrp="1"/>
+          </p:cNvGraphicFramePr>
+          <p:nvPr>
+            <p:extLst>
+              <p:ext uri="{D42A27DB-BD31-4B8C-83A1-F6EECF244321}">
+                <p14:modId xmlns:p14="http://schemas.microsoft.com/office/powerpoint/2010/main" val="3276674984"/>
+              </p:ext>
+            </p:extLst>
+          </p:nvPr>
+        </p:nvGraphicFramePr>
+        <p:xfrm>
+          <a:off x="6778979" y="249303"/>
+          <a:ext cx="4663213" cy="3934963"/>
+        </p:xfrm>
+        <a:graphic>
+          <a:graphicData uri="http://schemas.openxmlformats.org/drawingml/2006/table">
+            <a:tbl>
+              <a:tblPr>
+                <a:tableStyleId>{7DF18680-E054-41AD-8BC1-D1AEF772440D}</a:tableStyleId>
+              </a:tblPr>
+              <a:tblGrid>
+                <a:gridCol w="1923209">
+                  <a:extLst>
+                    <a:ext uri="{9D8B030D-6E8A-4147-A177-3AD203B41FA5}">
+                      <a16:colId xmlns:a16="http://schemas.microsoft.com/office/drawing/2014/main" val="1003669027"/>
+                    </a:ext>
+                  </a:extLst>
+                </a:gridCol>
+                <a:gridCol w="804682">
+                  <a:extLst>
+                    <a:ext uri="{9D8B030D-6E8A-4147-A177-3AD203B41FA5}">
+                      <a16:colId xmlns:a16="http://schemas.microsoft.com/office/drawing/2014/main" val="189703816"/>
+                    </a:ext>
+                  </a:extLst>
+                </a:gridCol>
+                <a:gridCol w="1413864">
+                  <a:extLst>
+                    <a:ext uri="{9D8B030D-6E8A-4147-A177-3AD203B41FA5}">
+                      <a16:colId xmlns:a16="http://schemas.microsoft.com/office/drawing/2014/main" val="2090279100"/>
+                    </a:ext>
+                  </a:extLst>
+                </a:gridCol>
+                <a:gridCol w="521458">
+                  <a:extLst>
+                    <a:ext uri="{9D8B030D-6E8A-4147-A177-3AD203B41FA5}">
+                      <a16:colId xmlns:a16="http://schemas.microsoft.com/office/drawing/2014/main" val="1425829101"/>
+                    </a:ext>
+                  </a:extLst>
+                </a:gridCol>
+              </a:tblGrid>
+              <a:tr h="325639">
+                <a:tc>
+                  <a:txBody>
+                    <a:bodyPr/>
+                    <a:lstStyle/>
+                    <a:p>
+                      <a:pPr algn="ctr" fontAlgn="b">
+                        <a:buNone/>
+                      </a:pPr>
+                      <a:r>
+                        <a:rPr lang="fr-FR" sz="1400" b="1" u="none" strike="noStrike" dirty="0">
+                          <a:solidFill>
+                            <a:srgbClr val="065A82"/>
+                          </a:solidFill>
+                          <a:effectLst/>
+                          <a:latin typeface="Cambria" panose="02040503050406030204" pitchFamily="18" charset="0"/>
+                          <a:ea typeface="Cambria" panose="02040503050406030204" pitchFamily="18" charset="0"/>
+                        </a:rPr>
+                        <a:t>Valo / FAMILLES</a:t>
+                      </a:r>
+                      <a:endParaRPr lang="fr-FR" sz="1400" b="0" i="0" u="none" strike="noStrike" dirty="0">
+                        <a:solidFill>
+                          <a:srgbClr val="000000"/>
+                        </a:solidFill>
+                        <a:effectLst/>
+                        <a:latin typeface="Cambria" panose="02040503050406030204" pitchFamily="18" charset="0"/>
+                        <a:ea typeface="Cambria" panose="02040503050406030204" pitchFamily="18" charset="0"/>
+                      </a:endParaRPr>
+                    </a:p>
+                  </a:txBody>
+                  <a:tcPr marL="7620" marR="7620" marT="7620" marB="0" anchor="b">
+                    <a:lnL w="12700" cap="flat" cmpd="sng" algn="ctr">
+                      <a:solidFill>
+                        <a:schemeClr val="tx1"/>
+                      </a:solidFill>
+                      <a:prstDash val="solid"/>
+                      <a:round/>
+                      <a:headEnd type="none" w="med" len="med"/>
+                      <a:tailEnd type="none" w="med" len="med"/>
+                    </a:lnL>
+                    <a:lnR w="12700" cmpd="sng">
+                      <a:noFill/>
+                    </a:lnR>
+                    <a:lnT w="12700" cap="flat" cmpd="sng" algn="ctr">
+                      <a:solidFill>
+                        <a:schemeClr val="tx1"/>
+                      </a:solidFill>
+                      <a:prstDash val="solid"/>
+                      <a:round/>
+                      <a:headEnd type="none" w="med" len="med"/>
+                      <a:tailEnd type="none" w="med" len="med"/>
+                    </a:lnT>
+                    <a:lnB w="12700" cmpd="sng">
+                      <a:noFill/>
+                    </a:lnB>
+                    <a:lnTlToBr w="12700" cmpd="sng">
+                      <a:noFill/>
+                      <a:prstDash val="solid"/>
+                    </a:lnTlToBr>
+                    <a:lnBlToTr w="12700" cmpd="sng">
+                      <a:noFill/>
+                      <a:prstDash val="solid"/>
+                    </a:lnBlToTr>
+                  </a:tcPr>
+                </a:tc>
+                <a:tc>
+                  <a:txBody>
+                    <a:bodyPr/>
+                    <a:lstStyle/>
+                    <a:p>
+                      <a:pPr algn="ctr" fontAlgn="ctr">
+                        <a:buNone/>
+                      </a:pPr>
+                      <a:r>
+                        <a:rPr lang="fr-FR" sz="1400" b="1" u="none" strike="noStrike" dirty="0">
+                          <a:solidFill>
+                            <a:srgbClr val="065A82"/>
+                          </a:solidFill>
+                          <a:effectLst/>
+                          <a:latin typeface="Cambria" panose="02040503050406030204" pitchFamily="18" charset="0"/>
+                          <a:ea typeface="Cambria" panose="02040503050406030204" pitchFamily="18" charset="0"/>
+                        </a:rPr>
+                        <a:t>DEPOT (k€)</a:t>
+                      </a:r>
+                      <a:endParaRPr lang="fr-FR" sz="1400" b="1" i="0" u="none" strike="noStrike" dirty="0">
+                        <a:solidFill>
+                          <a:srgbClr val="065A82"/>
+                        </a:solidFill>
+                        <a:effectLst/>
+                        <a:latin typeface="Cambria" panose="02040503050406030204" pitchFamily="18" charset="0"/>
+                        <a:ea typeface="Cambria" panose="02040503050406030204" pitchFamily="18" charset="0"/>
+                      </a:endParaRPr>
+                    </a:p>
+                  </a:txBody>
+                  <a:tcPr marL="7620" marR="7620" marT="7620" marB="0" anchor="ctr">
+                    <a:lnL w="12700" cmpd="sng">
+                      <a:noFill/>
+                    </a:lnL>
+                    <a:lnR w="12700" cmpd="sng">
+                      <a:noFill/>
+                    </a:lnR>
+                    <a:lnT w="12700" cap="flat" cmpd="sng" algn="ctr">
+                      <a:solidFill>
+                        <a:schemeClr val="tx1"/>
+                      </a:solidFill>
+                      <a:prstDash val="solid"/>
+                      <a:round/>
+                      <a:headEnd type="none" w="med" len="med"/>
+                      <a:tailEnd type="none" w="med" len="med"/>
+                    </a:lnT>
+                    <a:lnB w="12700" cmpd="sng">
+                      <a:noFill/>
+                    </a:lnB>
+                    <a:lnTlToBr w="12700" cmpd="sng">
+                      <a:noFill/>
+                      <a:prstDash val="solid"/>
+                    </a:lnTlToBr>
+                    <a:lnBlToTr w="12700" cmpd="sng">
+                      <a:noFill/>
+                      <a:prstDash val="solid"/>
+                    </a:lnBlToTr>
+                  </a:tcPr>
+                </a:tc>
+                <a:tc>
+                  <a:txBody>
+                    <a:bodyPr/>
+                    <a:lstStyle/>
+                    <a:p>
+                      <a:pPr algn="ctr" fontAlgn="ctr">
+                        <a:buNone/>
+                      </a:pPr>
+                      <a:r>
+                        <a:rPr lang="fr-FR" sz="1400" b="1" u="none" strike="noStrike" dirty="0">
+                          <a:solidFill>
+                            <a:srgbClr val="065A82"/>
+                          </a:solidFill>
+                          <a:effectLst/>
+                          <a:latin typeface="Cambria" panose="02040503050406030204" pitchFamily="18" charset="0"/>
+                          <a:ea typeface="Cambria" panose="02040503050406030204" pitchFamily="18" charset="0"/>
+                        </a:rPr>
+                        <a:t>SHOWROOM (k€)</a:t>
+                      </a:r>
+                      <a:endParaRPr lang="fr-FR" sz="1400" b="1" i="0" u="none" strike="noStrike" dirty="0">
+                        <a:solidFill>
+                          <a:srgbClr val="065A82"/>
+                        </a:solidFill>
+                        <a:effectLst/>
+                        <a:latin typeface="Cambria" panose="02040503050406030204" pitchFamily="18" charset="0"/>
+                        <a:ea typeface="Cambria" panose="02040503050406030204" pitchFamily="18" charset="0"/>
+                      </a:endParaRPr>
+                    </a:p>
+                  </a:txBody>
+                  <a:tcPr marL="7620" marR="7620" marT="7620" marB="0" anchor="ctr">
+                    <a:lnL w="12700" cmpd="sng">
+                      <a:noFill/>
+                    </a:lnL>
+                    <a:lnR w="12700" cmpd="sng">
+                      <a:noFill/>
+                    </a:lnR>
+                    <a:lnT w="12700" cap="flat" cmpd="sng" algn="ctr">
+                      <a:solidFill>
+                        <a:schemeClr val="tx1"/>
+                      </a:solidFill>
+                      <a:prstDash val="solid"/>
+                      <a:round/>
+                      <a:headEnd type="none" w="med" len="med"/>
+                      <a:tailEnd type="none" w="med" len="med"/>
+                    </a:lnT>
+                    <a:lnB w="12700" cmpd="sng">
+                      <a:noFill/>
+                    </a:lnB>
+                    <a:lnTlToBr w="12700" cmpd="sng">
+                      <a:noFill/>
+                      <a:prstDash val="solid"/>
+                    </a:lnTlToBr>
+                    <a:lnBlToTr w="12700" cmpd="sng">
+                      <a:noFill/>
+                      <a:prstDash val="solid"/>
+                    </a:lnBlToTr>
+                  </a:tcPr>
+                </a:tc>
+                <a:tc>
+                  <a:txBody>
+                    <a:bodyPr/>
+                    <a:lstStyle/>
+                    <a:p>
+                      <a:pPr algn="ctr" fontAlgn="ctr">
+                        <a:buNone/>
+                      </a:pPr>
+                      <a:r>
+                        <a:rPr lang="fr-FR" sz="1400" b="1" u="none" strike="noStrike" dirty="0">
+                          <a:solidFill>
+                            <a:srgbClr val="065A82"/>
+                          </a:solidFill>
+                          <a:effectLst/>
+                          <a:latin typeface="Cambria" panose="02040503050406030204" pitchFamily="18" charset="0"/>
+                          <a:ea typeface="Cambria" panose="02040503050406030204" pitchFamily="18" charset="0"/>
+                        </a:rPr>
+                        <a:t>TOT (k€)</a:t>
+                      </a:r>
+                      <a:endParaRPr lang="fr-FR" sz="1400" b="1" i="0" u="none" strike="noStrike" dirty="0">
+                        <a:solidFill>
+                          <a:srgbClr val="065A82"/>
+                        </a:solidFill>
+                        <a:effectLst/>
+                        <a:latin typeface="Cambria" panose="02040503050406030204" pitchFamily="18" charset="0"/>
+                        <a:ea typeface="Cambria" panose="02040503050406030204" pitchFamily="18" charset="0"/>
+                      </a:endParaRPr>
+                    </a:p>
+                  </a:txBody>
+                  <a:tcPr marL="7620" marR="7620" marT="7620" marB="0" anchor="ctr">
+                    <a:lnL w="12700" cmpd="sng">
+                      <a:noFill/>
+                    </a:lnL>
+                    <a:lnR w="12700" cap="flat" cmpd="sng" algn="ctr">
+                      <a:solidFill>
+                        <a:schemeClr val="tx1"/>
+                      </a:solidFill>
+                      <a:prstDash val="solid"/>
+                      <a:round/>
+                      <a:headEnd type="none" w="med" len="med"/>
+                      <a:tailEnd type="none" w="med" len="med"/>
+                    </a:lnR>
+                    <a:lnT w="12700" cap="flat" cmpd="sng" algn="ctr">
+                      <a:solidFill>
+                        <a:schemeClr val="tx1"/>
+                      </a:solidFill>
+                      <a:prstDash val="solid"/>
+                      <a:round/>
+                      <a:headEnd type="none" w="med" len="med"/>
+                      <a:tailEnd type="none" w="med" len="med"/>
+                    </a:lnT>
+                    <a:lnB w="12700" cmpd="sng">
+                      <a:noFill/>
+                    </a:lnB>
+                    <a:lnTlToBr w="12700" cmpd="sng">
+                      <a:noFill/>
+                      <a:prstDash val="solid"/>
+                    </a:lnTlToBr>
+                    <a:lnBlToTr w="12700" cmpd="sng">
+                      <a:noFill/>
+                      <a:prstDash val="solid"/>
+                    </a:lnBlToTr>
+                  </a:tcPr>
+                </a:tc>
+                <a:extLst>
+                  <a:ext uri="{0D108BD9-81ED-4DB2-BD59-A6C34878D82A}">
+                    <a16:rowId xmlns:a16="http://schemas.microsoft.com/office/drawing/2014/main" val="2220367888"/>
+                  </a:ext>
+                </a:extLst>
+              </a:tr>
+              <a:tr h="610575">
+                <a:tc>
+                  <a:txBody>
+                    <a:bodyPr/>
+                    <a:lstStyle/>
+                    <a:p>
+                      <a:pPr algn="ctr" fontAlgn="b">
+                        <a:buNone/>
+                      </a:pPr>
+                      <a:r>
+                        <a:rPr lang="fr-FR" sz="1400" b="1" u="none" strike="noStrike" dirty="0">
+                          <a:solidFill>
+                            <a:srgbClr val="065A82"/>
+                          </a:solidFill>
+                          <a:effectLst/>
+                          <a:latin typeface="Cambria" panose="02040503050406030204" pitchFamily="18" charset="0"/>
+                          <a:ea typeface="Cambria" panose="02040503050406030204" pitchFamily="18" charset="0"/>
+                        </a:rPr>
+                        <a:t>Machine de nettoyage</a:t>
+                      </a:r>
+                      <a:endParaRPr lang="fr-FR" sz="1400" b="1" i="0" u="none" strike="noStrike" dirty="0">
+                        <a:solidFill>
+                          <a:srgbClr val="065A82"/>
+                        </a:solidFill>
+                        <a:effectLst/>
+                        <a:latin typeface="Cambria" panose="02040503050406030204" pitchFamily="18" charset="0"/>
+                        <a:ea typeface="Cambria" panose="02040503050406030204" pitchFamily="18" charset="0"/>
+                      </a:endParaRPr>
+                    </a:p>
+                  </a:txBody>
+                  <a:tcPr marL="7620" marR="7620" marT="7620" marB="0" anchor="ctr">
+                    <a:lnL w="12700" cap="flat" cmpd="sng" algn="ctr">
+                      <a:solidFill>
+                        <a:schemeClr val="tx1"/>
+                      </a:solidFill>
+                      <a:prstDash val="solid"/>
+                      <a:round/>
+                      <a:headEnd type="none" w="med" len="med"/>
+                      <a:tailEnd type="none" w="med" len="med"/>
+                    </a:lnL>
+                    <a:lnR w="12700" cmpd="sng">
+                      <a:noFill/>
+                    </a:lnR>
+                    <a:lnT w="12700" cmpd="sng">
+                      <a:noFill/>
+                    </a:lnT>
+                    <a:lnB w="12700" cmpd="sng">
+                      <a:noFill/>
+                    </a:lnB>
+                    <a:lnTlToBr w="12700" cmpd="sng">
+                      <a:noFill/>
+                      <a:prstDash val="solid"/>
+                    </a:lnTlToBr>
+                    <a:lnBlToTr w="12700" cmpd="sng">
+                      <a:noFill/>
+                      <a:prstDash val="solid"/>
+                    </a:lnBlToTr>
+                  </a:tcPr>
+                </a:tc>
+                <a:tc>
+                  <a:txBody>
+                    <a:bodyPr/>
+                    <a:lstStyle/>
+                    <a:p>
+                      <a:pPr algn="ctr" fontAlgn="b">
+                        <a:buNone/>
+                      </a:pPr>
+                      <a:r>
+                        <a:rPr lang="fr-FR" sz="1400" b="0" i="0" u="none" strike="noStrike" dirty="0">
+                          <a:solidFill>
+                            <a:srgbClr val="065A82"/>
+                          </a:solidFill>
+                          <a:effectLst/>
+                          <a:latin typeface="Aptos Narrow" panose="020B0004020202020204" pitchFamily="34" charset="0"/>
+                        </a:rPr>
+                        <a:t>75,5</a:t>
+                      </a:r>
+                    </a:p>
+                  </a:txBody>
+                  <a:tcPr marL="7620" marR="7620" marT="7620" marB="0" anchor="ctr">
+                    <a:lnL w="12700" cmpd="sng">
+                      <a:noFill/>
+                    </a:lnL>
+                    <a:lnR w="12700" cmpd="sng">
+                      <a:noFill/>
+                    </a:lnR>
+                    <a:lnT w="12700" cmpd="sng">
+                      <a:noFill/>
+                    </a:lnT>
+                    <a:lnB w="12700" cmpd="sng">
+                      <a:noFill/>
+                    </a:lnB>
+                    <a:lnTlToBr w="12700" cmpd="sng">
+                      <a:noFill/>
+                      <a:prstDash val="solid"/>
+                    </a:lnTlToBr>
+                    <a:lnBlToTr w="12700" cmpd="sng">
+                      <a:noFill/>
+                      <a:prstDash val="solid"/>
+                    </a:lnBlToTr>
+                  </a:tcPr>
+                </a:tc>
+                <a:tc>
+                  <a:txBody>
+                    <a:bodyPr/>
+                    <a:lstStyle/>
+                    <a:p>
+                      <a:pPr algn="ctr" fontAlgn="b">
+                        <a:buNone/>
+                      </a:pPr>
+                      <a:r>
+                        <a:rPr lang="fr-FR" sz="1400" b="0" i="0" u="none" strike="noStrike" dirty="0">
+                          <a:solidFill>
+                            <a:srgbClr val="065A82"/>
+                          </a:solidFill>
+                          <a:effectLst/>
+                          <a:latin typeface="Aptos Narrow" panose="020B0004020202020204" pitchFamily="34" charset="0"/>
+                        </a:rPr>
+                        <a:t>0,8</a:t>
+                      </a:r>
+                    </a:p>
+                  </a:txBody>
+                  <a:tcPr marL="7620" marR="7620" marT="7620" marB="0" anchor="ctr">
+                    <a:lnL w="12700" cmpd="sng">
+                      <a:noFill/>
+                    </a:lnL>
+                    <a:lnR w="12700" cmpd="sng">
+                      <a:noFill/>
+                    </a:lnR>
+                    <a:lnT w="12700" cmpd="sng">
+                      <a:noFill/>
+                    </a:lnT>
+                    <a:lnB w="12700" cmpd="sng">
+                      <a:noFill/>
+                    </a:lnB>
+                    <a:lnTlToBr w="12700" cmpd="sng">
+                      <a:noFill/>
+                      <a:prstDash val="solid"/>
+                    </a:lnTlToBr>
+                    <a:lnBlToTr w="12700" cmpd="sng">
+                      <a:noFill/>
+                      <a:prstDash val="solid"/>
+                    </a:lnBlToTr>
+                  </a:tcPr>
+                </a:tc>
+                <a:tc>
+                  <a:txBody>
+                    <a:bodyPr/>
+                    <a:lstStyle/>
+                    <a:p>
+                      <a:pPr algn="ctr" fontAlgn="b">
+                        <a:buNone/>
+                      </a:pPr>
+                      <a:r>
+                        <a:rPr lang="fr-FR" sz="1400" b="0" i="0" u="none" strike="noStrike" dirty="0">
+                          <a:solidFill>
+                            <a:srgbClr val="065A82"/>
+                          </a:solidFill>
+                          <a:effectLst/>
+                          <a:latin typeface="Aptos Narrow" panose="020B0004020202020204" pitchFamily="34" charset="0"/>
+                        </a:rPr>
+                        <a:t>209</a:t>
+                      </a:r>
+                    </a:p>
+                  </a:txBody>
+                  <a:tcPr marL="7620" marR="7620" marT="7620" marB="0" anchor="ctr">
+                    <a:lnL w="12700" cmpd="sng">
+                      <a:noFill/>
+                    </a:lnL>
+                    <a:lnR w="12700" cap="flat" cmpd="sng" algn="ctr">
+                      <a:solidFill>
+                        <a:schemeClr val="tx1"/>
+                      </a:solidFill>
+                      <a:prstDash val="solid"/>
+                      <a:round/>
+                      <a:headEnd type="none" w="med" len="med"/>
+                      <a:tailEnd type="none" w="med" len="med"/>
+                    </a:lnR>
+                    <a:lnT w="12700" cmpd="sng">
+                      <a:noFill/>
+                    </a:lnT>
+                    <a:lnB w="12700" cmpd="sng">
+                      <a:noFill/>
+                    </a:lnB>
+                    <a:lnTlToBr w="12700" cmpd="sng">
+                      <a:noFill/>
+                      <a:prstDash val="solid"/>
+                    </a:lnTlToBr>
+                    <a:lnBlToTr w="12700" cmpd="sng">
+                      <a:noFill/>
+                      <a:prstDash val="solid"/>
+                    </a:lnBlToTr>
+                  </a:tcPr>
+                </a:tc>
+                <a:extLst>
+                  <a:ext uri="{0D108BD9-81ED-4DB2-BD59-A6C34878D82A}">
+                    <a16:rowId xmlns:a16="http://schemas.microsoft.com/office/drawing/2014/main" val="1036300375"/>
+                  </a:ext>
+                </a:extLst>
+              </a:tr>
+              <a:tr h="610575">
+                <a:tc>
+                  <a:txBody>
+                    <a:bodyPr/>
+                    <a:lstStyle/>
+                    <a:p>
+                      <a:pPr algn="ctr" fontAlgn="b">
+                        <a:buNone/>
+                      </a:pPr>
+                      <a:r>
+                        <a:rPr lang="fr-FR" sz="1400" b="1" u="none" strike="noStrike" dirty="0">
+                          <a:solidFill>
+                            <a:srgbClr val="065A82"/>
+                          </a:solidFill>
+                          <a:effectLst/>
+                          <a:latin typeface="Cambria" panose="02040503050406030204" pitchFamily="18" charset="0"/>
+                          <a:ea typeface="Cambria" panose="02040503050406030204" pitchFamily="18" charset="0"/>
+                        </a:rPr>
+                        <a:t>Produits de Nettoyage</a:t>
+                      </a:r>
+                      <a:endParaRPr lang="fr-FR" sz="1400" b="1" i="0" u="none" strike="noStrike" dirty="0">
+                        <a:solidFill>
+                          <a:srgbClr val="065A82"/>
+                        </a:solidFill>
+                        <a:effectLst/>
+                        <a:latin typeface="Cambria" panose="02040503050406030204" pitchFamily="18" charset="0"/>
+                        <a:ea typeface="Cambria" panose="02040503050406030204" pitchFamily="18" charset="0"/>
+                      </a:endParaRPr>
+                    </a:p>
+                  </a:txBody>
+                  <a:tcPr marL="7620" marR="7620" marT="7620" marB="0" anchor="ctr">
+                    <a:lnL w="12700" cap="flat" cmpd="sng" algn="ctr">
+                      <a:solidFill>
+                        <a:schemeClr val="tx1"/>
+                      </a:solidFill>
+                      <a:prstDash val="solid"/>
+                      <a:round/>
+                      <a:headEnd type="none" w="med" len="med"/>
+                      <a:tailEnd type="none" w="med" len="med"/>
+                    </a:lnL>
+                    <a:lnR w="12700" cmpd="sng">
+                      <a:noFill/>
+                    </a:lnR>
+                    <a:lnT w="12700" cmpd="sng">
+                      <a:noFill/>
+                    </a:lnT>
+                    <a:lnB w="12700" cmpd="sng">
+                      <a:noFill/>
+                    </a:lnB>
+                    <a:lnTlToBr w="12700" cmpd="sng">
+                      <a:noFill/>
+                      <a:prstDash val="solid"/>
+                    </a:lnTlToBr>
+                    <a:lnBlToTr w="12700" cmpd="sng">
+                      <a:noFill/>
+                      <a:prstDash val="solid"/>
+                    </a:lnBlToTr>
+                  </a:tcPr>
+                </a:tc>
+                <a:tc>
+                  <a:txBody>
+                    <a:bodyPr/>
+                    <a:lstStyle/>
+                    <a:p>
+                      <a:pPr algn="ctr" fontAlgn="b">
+                        <a:buNone/>
+                      </a:pPr>
+                      <a:r>
+                        <a:rPr lang="fr-FR" sz="1400" b="0" i="0" u="none" strike="noStrike" dirty="0">
+                          <a:solidFill>
+                            <a:srgbClr val="065A82"/>
+                          </a:solidFill>
+                          <a:effectLst/>
+                          <a:latin typeface="Aptos Narrow" panose="020B0004020202020204" pitchFamily="34" charset="0"/>
+                        </a:rPr>
+                        <a:t>7,0</a:t>
+                      </a:r>
+                    </a:p>
+                  </a:txBody>
+                  <a:tcPr marL="7620" marR="7620" marT="7620" marB="0" anchor="ctr">
+                    <a:lnL w="12700" cmpd="sng">
+                      <a:noFill/>
+                    </a:lnL>
+                    <a:lnR w="12700" cmpd="sng">
+                      <a:noFill/>
+                    </a:lnR>
+                    <a:lnT w="12700" cmpd="sng">
+                      <a:noFill/>
+                    </a:lnT>
+                    <a:lnB w="12700" cmpd="sng">
+                      <a:noFill/>
+                    </a:lnB>
+                    <a:lnTlToBr w="12700" cmpd="sng">
+                      <a:noFill/>
+                      <a:prstDash val="solid"/>
+                    </a:lnTlToBr>
+                    <a:lnBlToTr w="12700" cmpd="sng">
+                      <a:noFill/>
+                      <a:prstDash val="solid"/>
+                    </a:lnBlToTr>
+                  </a:tcPr>
+                </a:tc>
+                <a:tc>
+                  <a:txBody>
+                    <a:bodyPr/>
+                    <a:lstStyle/>
+                    <a:p>
+                      <a:pPr algn="ctr" fontAlgn="b">
+                        <a:buNone/>
+                      </a:pPr>
+                      <a:r>
+                        <a:rPr lang="fr-FR" sz="1400" b="0" i="0" u="none" strike="noStrike" dirty="0">
+                          <a:solidFill>
+                            <a:srgbClr val="065A82"/>
+                          </a:solidFill>
+                          <a:effectLst/>
+                          <a:latin typeface="Aptos Narrow" panose="020B0004020202020204" pitchFamily="34" charset="0"/>
+                        </a:rPr>
+                        <a:t>0,0</a:t>
+                      </a:r>
+                    </a:p>
+                  </a:txBody>
+                  <a:tcPr marL="7620" marR="7620" marT="7620" marB="0" anchor="ctr">
+                    <a:lnL w="12700" cmpd="sng">
+                      <a:noFill/>
+                    </a:lnL>
+                    <a:lnR w="12700" cmpd="sng">
+                      <a:noFill/>
+                    </a:lnR>
+                    <a:lnT w="12700" cmpd="sng">
+                      <a:noFill/>
+                    </a:lnT>
+                    <a:lnB w="12700" cmpd="sng">
+                      <a:noFill/>
+                    </a:lnB>
+                    <a:lnTlToBr w="12700" cmpd="sng">
+                      <a:noFill/>
+                      <a:prstDash val="solid"/>
+                    </a:lnTlToBr>
+                    <a:lnBlToTr w="12700" cmpd="sng">
+                      <a:noFill/>
+                      <a:prstDash val="solid"/>
+                    </a:lnBlToTr>
+                  </a:tcPr>
+                </a:tc>
+                <a:tc>
+                  <a:txBody>
+                    <a:bodyPr/>
+                    <a:lstStyle/>
+                    <a:p>
+                      <a:pPr algn="ctr" fontAlgn="b">
+                        <a:buNone/>
+                      </a:pPr>
+                      <a:r>
+                        <a:rPr lang="fr-FR" sz="1400" b="0" i="0" u="none" strike="noStrike" dirty="0">
+                          <a:solidFill>
+                            <a:srgbClr val="065A82"/>
+                          </a:solidFill>
+                          <a:effectLst/>
+                          <a:latin typeface="Aptos Narrow" panose="020B0004020202020204" pitchFamily="34" charset="0"/>
+                        </a:rPr>
+                        <a:t>220</a:t>
+                      </a:r>
+                    </a:p>
+                  </a:txBody>
+                  <a:tcPr marL="7620" marR="7620" marT="7620" marB="0" anchor="ctr">
+                    <a:lnL w="12700" cmpd="sng">
+                      <a:noFill/>
+                    </a:lnL>
+                    <a:lnR w="12700" cap="flat" cmpd="sng" algn="ctr">
+                      <a:solidFill>
+                        <a:schemeClr val="tx1"/>
+                      </a:solidFill>
+                      <a:prstDash val="solid"/>
+                      <a:round/>
+                      <a:headEnd type="none" w="med" len="med"/>
+                      <a:tailEnd type="none" w="med" len="med"/>
+                    </a:lnR>
+                    <a:lnT w="12700" cmpd="sng">
+                      <a:noFill/>
+                    </a:lnT>
+                    <a:lnB w="12700" cmpd="sng">
+                      <a:noFill/>
+                    </a:lnB>
+                    <a:lnTlToBr w="12700" cmpd="sng">
+                      <a:noFill/>
+                      <a:prstDash val="solid"/>
+                    </a:lnTlToBr>
+                    <a:lnBlToTr w="12700" cmpd="sng">
+                      <a:noFill/>
+                      <a:prstDash val="solid"/>
+                    </a:lnBlToTr>
+                  </a:tcPr>
+                </a:tc>
+                <a:extLst>
+                  <a:ext uri="{0D108BD9-81ED-4DB2-BD59-A6C34878D82A}">
+                    <a16:rowId xmlns:a16="http://schemas.microsoft.com/office/drawing/2014/main" val="1037391207"/>
+                  </a:ext>
+                </a:extLst>
+              </a:tr>
+              <a:tr h="325639">
+                <a:tc>
+                  <a:txBody>
+                    <a:bodyPr/>
+                    <a:lstStyle/>
+                    <a:p>
+                      <a:pPr algn="ctr" fontAlgn="b">
+                        <a:buNone/>
+                      </a:pPr>
+                      <a:r>
+                        <a:rPr lang="fr-FR" sz="1400" b="1" u="none" strike="noStrike" dirty="0">
+                          <a:solidFill>
+                            <a:srgbClr val="065A82"/>
+                          </a:solidFill>
+                          <a:effectLst/>
+                          <a:latin typeface="Cambria" panose="02040503050406030204" pitchFamily="18" charset="0"/>
+                          <a:ea typeface="Cambria" panose="02040503050406030204" pitchFamily="18" charset="0"/>
+                        </a:rPr>
+                        <a:t>Papier</a:t>
+                      </a:r>
+                      <a:endParaRPr lang="fr-FR" sz="1400" b="1" i="0" u="none" strike="noStrike" dirty="0">
+                        <a:solidFill>
+                          <a:srgbClr val="065A82"/>
+                        </a:solidFill>
+                        <a:effectLst/>
+                        <a:latin typeface="Cambria" panose="02040503050406030204" pitchFamily="18" charset="0"/>
+                        <a:ea typeface="Cambria" panose="02040503050406030204" pitchFamily="18" charset="0"/>
+                      </a:endParaRPr>
+                    </a:p>
+                  </a:txBody>
+                  <a:tcPr marL="7620" marR="7620" marT="7620" marB="0" anchor="ctr">
+                    <a:lnL w="12700" cap="flat" cmpd="sng" algn="ctr">
+                      <a:solidFill>
+                        <a:schemeClr val="tx1"/>
+                      </a:solidFill>
+                      <a:prstDash val="solid"/>
+                      <a:round/>
+                      <a:headEnd type="none" w="med" len="med"/>
+                      <a:tailEnd type="none" w="med" len="med"/>
+                    </a:lnL>
+                    <a:lnR w="12700" cmpd="sng">
+                      <a:noFill/>
+                    </a:lnR>
+                    <a:lnT w="12700" cmpd="sng">
+                      <a:noFill/>
+                    </a:lnT>
+                    <a:lnB w="12700" cap="flat" cmpd="sng" algn="ctr">
+                      <a:noFill/>
+                      <a:prstDash val="solid"/>
+                      <a:round/>
+                      <a:headEnd type="none" w="med" len="med"/>
+                      <a:tailEnd type="none" w="med" len="med"/>
+                    </a:lnB>
+                    <a:lnTlToBr w="12700" cmpd="sng">
+                      <a:noFill/>
+                      <a:prstDash val="solid"/>
+                    </a:lnTlToBr>
+                    <a:lnBlToTr w="12700" cmpd="sng">
+                      <a:noFill/>
+                      <a:prstDash val="solid"/>
+                    </a:lnBlToTr>
+                  </a:tcPr>
+                </a:tc>
+                <a:tc>
+                  <a:txBody>
+                    <a:bodyPr/>
+                    <a:lstStyle/>
+                    <a:p>
+                      <a:pPr marL="0" marR="0" lvl="0" indent="0" algn="ctr" defTabSz="914400" rtl="0" eaLnBrk="1" fontAlgn="b" latinLnBrk="0" hangingPunct="1">
+                        <a:lnSpc>
+                          <a:spcPct val="100000"/>
+                        </a:lnSpc>
+                        <a:spcBef>
+                          <a:spcPts val="0"/>
+                        </a:spcBef>
+                        <a:spcAft>
+                          <a:spcPts val="0"/>
+                        </a:spcAft>
+                        <a:buClrTx/>
+                        <a:buSzTx/>
+                        <a:buFontTx/>
+                        <a:buNone/>
+                        <a:tabLst/>
+                        <a:defRPr/>
+                      </a:pPr>
+                      <a:r>
+                        <a:rPr kumimoji="0" lang="fr-FR" sz="1400" b="0" i="0" u="none" strike="noStrike" kern="1200" cap="none" spc="0" normalizeH="0" baseline="0" noProof="0" dirty="0">
+                          <a:ln>
+                            <a:noFill/>
+                          </a:ln>
+                          <a:solidFill>
+                            <a:srgbClr val="065A82"/>
+                          </a:solidFill>
+                          <a:effectLst/>
+                          <a:uLnTx/>
+                          <a:uFillTx/>
+                          <a:latin typeface="Aptos Narrow" panose="020B0004020202020204" pitchFamily="34" charset="0"/>
+                          <a:ea typeface="+mn-ea"/>
+                          <a:cs typeface="+mn-cs"/>
+                        </a:rPr>
+                        <a:t>6,9</a:t>
+                      </a:r>
+                    </a:p>
+                  </a:txBody>
+                  <a:tcPr marL="7620" marR="7620" marT="7620" marB="0" anchor="ctr">
+                    <a:lnL w="12700" cmpd="sng">
+                      <a:noFill/>
+                    </a:lnL>
+                    <a:lnR w="12700" cmpd="sng">
+                      <a:noFill/>
+                    </a:lnR>
+                    <a:lnT w="12700" cmpd="sng">
+                      <a:noFill/>
+                    </a:lnT>
+                    <a:lnB w="12700" cap="flat" cmpd="sng" algn="ctr">
+                      <a:noFill/>
+                      <a:prstDash val="solid"/>
+                      <a:round/>
+                      <a:headEnd type="none" w="med" len="med"/>
+                      <a:tailEnd type="none" w="med" len="med"/>
+                    </a:lnB>
+                    <a:lnTlToBr w="12700" cmpd="sng">
+                      <a:noFill/>
+                      <a:prstDash val="solid"/>
+                    </a:lnTlToBr>
+                    <a:lnBlToTr w="12700" cmpd="sng">
+                      <a:noFill/>
+                      <a:prstDash val="solid"/>
+                    </a:lnBlToTr>
+                  </a:tcPr>
+                </a:tc>
+                <a:tc>
+                  <a:txBody>
+                    <a:bodyPr/>
+                    <a:lstStyle/>
+                    <a:p>
+                      <a:pPr marL="0" marR="0" lvl="0" indent="0" algn="ctr" defTabSz="914400" rtl="0" eaLnBrk="1" fontAlgn="b" latinLnBrk="0" hangingPunct="1">
+                        <a:lnSpc>
+                          <a:spcPct val="100000"/>
+                        </a:lnSpc>
+                        <a:spcBef>
+                          <a:spcPts val="0"/>
+                        </a:spcBef>
+                        <a:spcAft>
+                          <a:spcPts val="0"/>
+                        </a:spcAft>
+                        <a:buClrTx/>
+                        <a:buSzTx/>
+                        <a:buFontTx/>
+                        <a:buNone/>
+                        <a:tabLst/>
+                        <a:defRPr/>
+                      </a:pPr>
+                      <a:r>
+                        <a:rPr kumimoji="0" lang="fr-FR" sz="1400" b="0" i="0" u="none" strike="noStrike" kern="1200" cap="none" spc="0" normalizeH="0" baseline="0" noProof="0" dirty="0">
+                          <a:ln>
+                            <a:noFill/>
+                          </a:ln>
+                          <a:solidFill>
+                            <a:srgbClr val="065A82"/>
+                          </a:solidFill>
+                          <a:effectLst/>
+                          <a:uLnTx/>
+                          <a:uFillTx/>
+                          <a:latin typeface="Aptos Narrow" panose="020B0004020202020204" pitchFamily="34" charset="0"/>
+                          <a:ea typeface="+mn-ea"/>
+                          <a:cs typeface="+mn-cs"/>
+                        </a:rPr>
+                        <a:t>1,1</a:t>
+                      </a:r>
+                    </a:p>
+                  </a:txBody>
+                  <a:tcPr marL="7620" marR="7620" marT="7620" marB="0" anchor="ctr">
+                    <a:lnL w="12700" cmpd="sng">
+                      <a:noFill/>
+                    </a:lnL>
+                    <a:lnR w="12700" cmpd="sng">
+                      <a:noFill/>
+                    </a:lnR>
+                    <a:lnT w="12700" cmpd="sng">
+                      <a:noFill/>
+                    </a:lnT>
+                    <a:lnB w="12700" cap="flat" cmpd="sng" algn="ctr">
+                      <a:noFill/>
+                      <a:prstDash val="solid"/>
+                      <a:round/>
+                      <a:headEnd type="none" w="med" len="med"/>
+                      <a:tailEnd type="none" w="med" len="med"/>
+                    </a:lnB>
+                    <a:lnTlToBr w="12700" cmpd="sng">
+                      <a:noFill/>
+                      <a:prstDash val="solid"/>
+                    </a:lnTlToBr>
+                    <a:lnBlToTr w="12700" cmpd="sng">
+                      <a:noFill/>
+                      <a:prstDash val="solid"/>
+                    </a:lnBlToTr>
+                  </a:tcPr>
+                </a:tc>
+                <a:tc>
+                  <a:txBody>
+                    <a:bodyPr/>
+                    <a:lstStyle/>
+                    <a:p>
+                      <a:pPr algn="ctr" fontAlgn="b">
+                        <a:buNone/>
+                      </a:pPr>
+                      <a:r>
+                        <a:rPr lang="fr-FR" sz="1400" b="0" i="0" u="none" strike="noStrike" dirty="0">
+                          <a:solidFill>
+                            <a:srgbClr val="065A82"/>
+                          </a:solidFill>
+                          <a:effectLst/>
+                          <a:latin typeface="Aptos Narrow" panose="020B0004020202020204" pitchFamily="34" charset="0"/>
+                        </a:rPr>
+                        <a:t>137</a:t>
+                      </a:r>
+                    </a:p>
+                  </a:txBody>
+                  <a:tcPr marL="7620" marR="7620" marT="7620" marB="0" anchor="ctr">
+                    <a:lnL w="12700" cmpd="sng">
+                      <a:noFill/>
+                    </a:lnL>
+                    <a:lnR w="12700" cap="flat" cmpd="sng" algn="ctr">
+                      <a:solidFill>
+                        <a:schemeClr val="tx1"/>
+                      </a:solidFill>
+                      <a:prstDash val="solid"/>
+                      <a:round/>
+                      <a:headEnd type="none" w="med" len="med"/>
+                      <a:tailEnd type="none" w="med" len="med"/>
+                    </a:lnR>
+                    <a:lnT w="12700" cmpd="sng">
+                      <a:noFill/>
+                    </a:lnT>
+                    <a:lnB w="12700" cap="flat" cmpd="sng" algn="ctr">
+                      <a:noFill/>
+                      <a:prstDash val="solid"/>
+                      <a:round/>
+                      <a:headEnd type="none" w="med" len="med"/>
+                      <a:tailEnd type="none" w="med" len="med"/>
+                    </a:lnB>
+                    <a:lnTlToBr w="12700" cmpd="sng">
+                      <a:noFill/>
+                      <a:prstDash val="solid"/>
+                    </a:lnTlToBr>
+                    <a:lnBlToTr w="12700" cmpd="sng">
+                      <a:noFill/>
+                      <a:prstDash val="solid"/>
+                    </a:lnBlToTr>
+                  </a:tcPr>
+                </a:tc>
+                <a:extLst>
+                  <a:ext uri="{0D108BD9-81ED-4DB2-BD59-A6C34878D82A}">
+                    <a16:rowId xmlns:a16="http://schemas.microsoft.com/office/drawing/2014/main" val="3289839779"/>
+                  </a:ext>
+                </a:extLst>
+              </a:tr>
+              <a:tr h="325639">
+                <a:tc>
+                  <a:txBody>
+                    <a:bodyPr/>
+                    <a:lstStyle/>
+                    <a:p>
+                      <a:pPr algn="ctr" fontAlgn="b">
+                        <a:buNone/>
+                      </a:pPr>
+                      <a:r>
+                        <a:rPr lang="fr-FR" sz="1400" b="1" i="0" u="none" strike="noStrike" dirty="0">
+                          <a:solidFill>
+                            <a:srgbClr val="065A82"/>
+                          </a:solidFill>
+                          <a:effectLst/>
+                          <a:latin typeface="Cambria" panose="02040503050406030204" pitchFamily="18" charset="0"/>
+                          <a:ea typeface="Cambria" panose="02040503050406030204" pitchFamily="18" charset="0"/>
+                        </a:rPr>
+                        <a:t>Matériel Manuel</a:t>
+                      </a:r>
+                    </a:p>
+                  </a:txBody>
+                  <a:tcPr marL="7620" marR="7620" marT="7620" marB="0" anchor="ctr">
+                    <a:lnL w="12700" cap="flat" cmpd="sng" algn="ctr">
+                      <a:solidFill>
+                        <a:schemeClr val="tx1"/>
+                      </a:solidFill>
+                      <a:prstDash val="solid"/>
+                      <a:round/>
+                      <a:headEnd type="none" w="med" len="med"/>
+                      <a:tailEnd type="none" w="med" len="med"/>
+                    </a:lnL>
+                    <a:lnR w="12700" cmpd="sng">
+                      <a:noFill/>
+                    </a:lnR>
+                    <a:lnT w="12700" cmpd="sng">
+                      <a:noFill/>
+                    </a:lnT>
+                    <a:lnB w="12700" cap="flat" cmpd="sng" algn="ctr">
+                      <a:noFill/>
+                      <a:prstDash val="solid"/>
+                      <a:round/>
+                      <a:headEnd type="none" w="med" len="med"/>
+                      <a:tailEnd type="none" w="med" len="med"/>
+                    </a:lnB>
+                    <a:lnTlToBr w="12700" cmpd="sng">
+                      <a:noFill/>
+                      <a:prstDash val="solid"/>
+                    </a:lnTlToBr>
+                    <a:lnBlToTr w="12700" cmpd="sng">
+                      <a:noFill/>
+                      <a:prstDash val="solid"/>
+                    </a:lnBlToTr>
+                  </a:tcPr>
+                </a:tc>
+                <a:tc>
+                  <a:txBody>
+                    <a:bodyPr/>
+                    <a:lstStyle/>
+                    <a:p>
+                      <a:pPr marL="0" marR="0" lvl="0" indent="0" algn="ctr" defTabSz="914400" rtl="0" eaLnBrk="1" fontAlgn="b" latinLnBrk="0" hangingPunct="1">
+                        <a:lnSpc>
+                          <a:spcPct val="100000"/>
+                        </a:lnSpc>
+                        <a:spcBef>
+                          <a:spcPts val="0"/>
+                        </a:spcBef>
+                        <a:spcAft>
+                          <a:spcPts val="0"/>
+                        </a:spcAft>
+                        <a:buClrTx/>
+                        <a:buSzTx/>
+                        <a:buFontTx/>
+                        <a:buNone/>
+                        <a:tabLst/>
+                        <a:defRPr/>
+                      </a:pPr>
+                      <a:r>
+                        <a:rPr kumimoji="0" lang="fr-FR" sz="1400" b="0" i="0" u="none" strike="noStrike" kern="1200" cap="none" spc="0" normalizeH="0" baseline="0" noProof="0" dirty="0">
+                          <a:ln>
+                            <a:noFill/>
+                          </a:ln>
+                          <a:solidFill>
+                            <a:srgbClr val="065A82"/>
+                          </a:solidFill>
+                          <a:effectLst/>
+                          <a:uLnTx/>
+                          <a:uFillTx/>
+                          <a:latin typeface="Aptos Narrow" panose="020B0004020202020204" pitchFamily="34" charset="0"/>
+                          <a:ea typeface="+mn-ea"/>
+                          <a:cs typeface="+mn-cs"/>
+                        </a:rPr>
+                        <a:t>3,1</a:t>
+                      </a:r>
+                    </a:p>
+                  </a:txBody>
+                  <a:tcPr marL="7620" marR="7620" marT="7620" marB="0" anchor="ctr">
+                    <a:lnL w="12700" cmpd="sng">
+                      <a:noFill/>
+                    </a:lnL>
+                    <a:lnR w="12700" cmpd="sng">
+                      <a:noFill/>
+                    </a:lnR>
+                    <a:lnT w="12700" cmpd="sng">
+                      <a:noFill/>
+                    </a:lnT>
+                    <a:lnB w="12700" cap="flat" cmpd="sng" algn="ctr">
+                      <a:noFill/>
+                      <a:prstDash val="solid"/>
+                      <a:round/>
+                      <a:headEnd type="none" w="med" len="med"/>
+                      <a:tailEnd type="none" w="med" len="med"/>
+                    </a:lnB>
+                    <a:lnTlToBr w="12700" cmpd="sng">
+                      <a:noFill/>
+                      <a:prstDash val="solid"/>
+                    </a:lnTlToBr>
+                    <a:lnBlToTr w="12700" cmpd="sng">
+                      <a:noFill/>
+                      <a:prstDash val="solid"/>
+                    </a:lnBlToTr>
+                  </a:tcPr>
+                </a:tc>
+                <a:tc>
+                  <a:txBody>
+                    <a:bodyPr/>
+                    <a:lstStyle/>
+                    <a:p>
+                      <a:pPr marL="0" marR="0" lvl="0" indent="0" algn="ctr" defTabSz="914400" rtl="0" eaLnBrk="1" fontAlgn="b" latinLnBrk="0" hangingPunct="1">
+                        <a:lnSpc>
+                          <a:spcPct val="100000"/>
+                        </a:lnSpc>
+                        <a:spcBef>
+                          <a:spcPts val="0"/>
+                        </a:spcBef>
+                        <a:spcAft>
+                          <a:spcPts val="0"/>
+                        </a:spcAft>
+                        <a:buClrTx/>
+                        <a:buSzTx/>
+                        <a:buFontTx/>
+                        <a:buNone/>
+                        <a:tabLst/>
+                        <a:defRPr/>
+                      </a:pPr>
+                      <a:r>
+                        <a:rPr kumimoji="0" lang="fr-FR" sz="1400" b="0" i="0" u="none" strike="noStrike" kern="1200" cap="none" spc="0" normalizeH="0" baseline="0" noProof="0" dirty="0">
+                          <a:ln>
+                            <a:noFill/>
+                          </a:ln>
+                          <a:solidFill>
+                            <a:srgbClr val="065A82"/>
+                          </a:solidFill>
+                          <a:effectLst/>
+                          <a:uLnTx/>
+                          <a:uFillTx/>
+                          <a:latin typeface="Aptos Narrow" panose="020B0004020202020204" pitchFamily="34" charset="0"/>
+                          <a:ea typeface="+mn-ea"/>
+                          <a:cs typeface="+mn-cs"/>
+                        </a:rPr>
+                        <a:t>0,1</a:t>
+                      </a:r>
+                    </a:p>
+                  </a:txBody>
+                  <a:tcPr marL="7620" marR="7620" marT="7620" marB="0" anchor="ctr">
+                    <a:lnL w="12700" cmpd="sng">
+                      <a:noFill/>
+                    </a:lnL>
+                    <a:lnR w="12700" cmpd="sng">
+                      <a:noFill/>
+                    </a:lnR>
+                    <a:lnT w="12700" cmpd="sng">
+                      <a:noFill/>
+                    </a:lnT>
+                    <a:lnB w="12700" cap="flat" cmpd="sng" algn="ctr">
+                      <a:noFill/>
+                      <a:prstDash val="solid"/>
+                      <a:round/>
+                      <a:headEnd type="none" w="med" len="med"/>
+                      <a:tailEnd type="none" w="med" len="med"/>
+                    </a:lnB>
+                    <a:lnTlToBr w="12700" cmpd="sng">
+                      <a:noFill/>
+                      <a:prstDash val="solid"/>
+                    </a:lnTlToBr>
+                    <a:lnBlToTr w="12700" cmpd="sng">
+                      <a:noFill/>
+                      <a:prstDash val="solid"/>
+                    </a:lnBlToTr>
+                  </a:tcPr>
+                </a:tc>
+                <a:tc>
+                  <a:txBody>
+                    <a:bodyPr/>
+                    <a:lstStyle/>
+                    <a:p>
+                      <a:pPr marL="0" marR="0" lvl="0" indent="0" algn="ctr" defTabSz="914400" rtl="0" eaLnBrk="1" fontAlgn="b" latinLnBrk="0" hangingPunct="1">
+                        <a:lnSpc>
+                          <a:spcPct val="100000"/>
+                        </a:lnSpc>
+                        <a:spcBef>
+                          <a:spcPts val="0"/>
+                        </a:spcBef>
+                        <a:spcAft>
+                          <a:spcPts val="0"/>
+                        </a:spcAft>
+                        <a:buClrTx/>
+                        <a:buSzTx/>
+                        <a:buFontTx/>
+                        <a:buNone/>
+                        <a:tabLst/>
+                        <a:defRPr/>
+                      </a:pPr>
+                      <a:r>
+                        <a:rPr kumimoji="0" lang="fr-FR" sz="1400" b="0" i="0" u="none" strike="noStrike" kern="1200" cap="none" spc="0" normalizeH="0" baseline="0" noProof="0" dirty="0">
+                          <a:ln>
+                            <a:noFill/>
+                          </a:ln>
+                          <a:solidFill>
+                            <a:srgbClr val="065A82"/>
+                          </a:solidFill>
+                          <a:effectLst/>
+                          <a:uLnTx/>
+                          <a:uFillTx/>
+                          <a:latin typeface="Aptos Narrow" panose="020B0004020202020204" pitchFamily="34" charset="0"/>
+                          <a:ea typeface="+mn-ea"/>
+                          <a:cs typeface="+mn-cs"/>
+                        </a:rPr>
+                        <a:t>88</a:t>
+                      </a:r>
+                    </a:p>
+                  </a:txBody>
+                  <a:tcPr marL="7620" marR="7620" marT="7620" marB="0" anchor="ctr">
+                    <a:lnL w="12700" cmpd="sng">
+                      <a:noFill/>
+                    </a:lnL>
+                    <a:lnR w="12700" cap="flat" cmpd="sng" algn="ctr">
+                      <a:solidFill>
+                        <a:schemeClr val="tx1"/>
+                      </a:solidFill>
+                      <a:prstDash val="solid"/>
+                      <a:round/>
+                      <a:headEnd type="none" w="med" len="med"/>
+                      <a:tailEnd type="none" w="med" len="med"/>
+                    </a:lnR>
+                    <a:lnT w="12700" cmpd="sng">
+                      <a:noFill/>
+                    </a:lnT>
+                    <a:lnB w="12700" cap="flat" cmpd="sng" algn="ctr">
+                      <a:noFill/>
+                      <a:prstDash val="solid"/>
+                      <a:round/>
+                      <a:headEnd type="none" w="med" len="med"/>
+                      <a:tailEnd type="none" w="med" len="med"/>
+                    </a:lnB>
+                    <a:lnTlToBr w="12700" cmpd="sng">
+                      <a:noFill/>
+                      <a:prstDash val="solid"/>
+                    </a:lnTlToBr>
+                    <a:lnBlToTr w="12700" cmpd="sng">
+                      <a:noFill/>
+                      <a:prstDash val="solid"/>
+                    </a:lnBlToTr>
+                  </a:tcPr>
+                </a:tc>
+                <a:extLst>
+                  <a:ext uri="{0D108BD9-81ED-4DB2-BD59-A6C34878D82A}">
+                    <a16:rowId xmlns:a16="http://schemas.microsoft.com/office/drawing/2014/main" val="337409520"/>
+                  </a:ext>
+                </a:extLst>
+              </a:tr>
+              <a:tr h="325639">
+                <a:tc>
+                  <a:txBody>
+                    <a:bodyPr/>
+                    <a:lstStyle/>
+                    <a:p>
+                      <a:pPr algn="ctr" fontAlgn="b">
+                        <a:buNone/>
+                      </a:pPr>
+                      <a:r>
+                        <a:rPr lang="fr-FR" sz="1400" b="1" i="0" u="none" strike="noStrike" dirty="0">
+                          <a:solidFill>
+                            <a:srgbClr val="065A82"/>
+                          </a:solidFill>
+                          <a:effectLst/>
+                          <a:latin typeface="Cambria" panose="02040503050406030204" pitchFamily="18" charset="0"/>
+                          <a:ea typeface="Cambria" panose="02040503050406030204" pitchFamily="18" charset="0"/>
+                        </a:rPr>
+                        <a:t>Accessoires Manuel</a:t>
+                      </a:r>
+                    </a:p>
+                  </a:txBody>
+                  <a:tcPr marL="7620" marR="7620" marT="7620" marB="0" anchor="ctr">
+                    <a:lnL w="12700" cap="flat" cmpd="sng" algn="ctr">
+                      <a:solidFill>
+                        <a:schemeClr val="tx1"/>
+                      </a:solidFill>
+                      <a:prstDash val="solid"/>
+                      <a:round/>
+                      <a:headEnd type="none" w="med" len="med"/>
+                      <a:tailEnd type="none" w="med" len="med"/>
+                    </a:lnL>
+                    <a:lnR w="12700" cmpd="sng">
+                      <a:noFill/>
+                    </a:lnR>
+                    <a:lnT w="12700" cmpd="sng">
+                      <a:noFill/>
+                    </a:lnT>
+                    <a:lnB w="12700" cap="flat" cmpd="sng" algn="ctr">
+                      <a:noFill/>
+                      <a:prstDash val="solid"/>
+                      <a:round/>
+                      <a:headEnd type="none" w="med" len="med"/>
+                      <a:tailEnd type="none" w="med" len="med"/>
+                    </a:lnB>
+                    <a:lnTlToBr w="12700" cmpd="sng">
+                      <a:noFill/>
+                      <a:prstDash val="solid"/>
+                    </a:lnTlToBr>
+                    <a:lnBlToTr w="12700" cmpd="sng">
+                      <a:noFill/>
+                      <a:prstDash val="solid"/>
+                    </a:lnBlToTr>
+                  </a:tcPr>
+                </a:tc>
+                <a:tc>
+                  <a:txBody>
+                    <a:bodyPr/>
+                    <a:lstStyle/>
+                    <a:p>
+                      <a:pPr marL="0" marR="0" lvl="0" indent="0" algn="ctr" defTabSz="914400" rtl="0" eaLnBrk="1" fontAlgn="b" latinLnBrk="0" hangingPunct="1">
+                        <a:lnSpc>
+                          <a:spcPct val="100000"/>
+                        </a:lnSpc>
+                        <a:spcBef>
+                          <a:spcPts val="0"/>
+                        </a:spcBef>
+                        <a:spcAft>
+                          <a:spcPts val="0"/>
+                        </a:spcAft>
+                        <a:buClrTx/>
+                        <a:buSzTx/>
+                        <a:buFontTx/>
+                        <a:buNone/>
+                        <a:tabLst/>
+                        <a:defRPr/>
+                      </a:pPr>
+                      <a:r>
+                        <a:rPr kumimoji="0" lang="fr-FR" sz="1400" b="0" i="0" u="none" strike="noStrike" kern="1200" cap="none" spc="0" normalizeH="0" baseline="0" noProof="0" dirty="0">
+                          <a:ln>
+                            <a:noFill/>
+                          </a:ln>
+                          <a:solidFill>
+                            <a:srgbClr val="065A82"/>
+                          </a:solidFill>
+                          <a:effectLst/>
+                          <a:uLnTx/>
+                          <a:uFillTx/>
+                          <a:latin typeface="Aptos Narrow" panose="020B0004020202020204" pitchFamily="34" charset="0"/>
+                          <a:ea typeface="+mn-ea"/>
+                          <a:cs typeface="+mn-cs"/>
+                        </a:rPr>
+                        <a:t>163,6</a:t>
+                      </a:r>
+                    </a:p>
+                  </a:txBody>
+                  <a:tcPr marL="7620" marR="7620" marT="7620" marB="0" anchor="ctr">
+                    <a:lnL w="12700" cmpd="sng">
+                      <a:noFill/>
+                    </a:lnL>
+                    <a:lnR w="12700" cmpd="sng">
+                      <a:noFill/>
+                    </a:lnR>
+                    <a:lnT w="12700" cmpd="sng">
+                      <a:noFill/>
+                    </a:lnT>
+                    <a:lnB w="12700" cap="flat" cmpd="sng" algn="ctr">
+                      <a:noFill/>
+                      <a:prstDash val="solid"/>
+                      <a:round/>
+                      <a:headEnd type="none" w="med" len="med"/>
+                      <a:tailEnd type="none" w="med" len="med"/>
+                    </a:lnB>
+                    <a:lnTlToBr w="12700" cmpd="sng">
+                      <a:noFill/>
+                      <a:prstDash val="solid"/>
+                    </a:lnTlToBr>
+                    <a:lnBlToTr w="12700" cmpd="sng">
+                      <a:noFill/>
+                      <a:prstDash val="solid"/>
+                    </a:lnBlToTr>
+                  </a:tcPr>
+                </a:tc>
+                <a:tc>
+                  <a:txBody>
+                    <a:bodyPr/>
+                    <a:lstStyle/>
+                    <a:p>
+                      <a:pPr marL="0" marR="0" lvl="0" indent="0" algn="ctr" defTabSz="914400" rtl="0" eaLnBrk="1" fontAlgn="b" latinLnBrk="0" hangingPunct="1">
+                        <a:lnSpc>
+                          <a:spcPct val="100000"/>
+                        </a:lnSpc>
+                        <a:spcBef>
+                          <a:spcPts val="0"/>
+                        </a:spcBef>
+                        <a:spcAft>
+                          <a:spcPts val="0"/>
+                        </a:spcAft>
+                        <a:buClrTx/>
+                        <a:buSzTx/>
+                        <a:buFontTx/>
+                        <a:buNone/>
+                        <a:tabLst/>
+                        <a:defRPr/>
+                      </a:pPr>
+                      <a:r>
+                        <a:rPr kumimoji="0" lang="fr-FR" sz="1400" b="0" i="0" u="none" strike="noStrike" kern="1200" cap="none" spc="0" normalizeH="0" baseline="0" noProof="0" dirty="0">
+                          <a:ln>
+                            <a:noFill/>
+                          </a:ln>
+                          <a:solidFill>
+                            <a:srgbClr val="065A82"/>
+                          </a:solidFill>
+                          <a:effectLst/>
+                          <a:uLnTx/>
+                          <a:uFillTx/>
+                          <a:latin typeface="Aptos Narrow" panose="020B0004020202020204" pitchFamily="34" charset="0"/>
+                          <a:ea typeface="+mn-ea"/>
+                          <a:cs typeface="+mn-cs"/>
+                        </a:rPr>
+                        <a:t>45,9</a:t>
+                      </a:r>
+                    </a:p>
+                  </a:txBody>
+                  <a:tcPr marL="7620" marR="7620" marT="7620" marB="0" anchor="ctr">
+                    <a:lnL w="12700" cmpd="sng">
+                      <a:noFill/>
+                    </a:lnL>
+                    <a:lnR w="12700" cmpd="sng">
+                      <a:noFill/>
+                    </a:lnR>
+                    <a:lnT w="12700" cmpd="sng">
+                      <a:noFill/>
+                    </a:lnT>
+                    <a:lnB w="12700" cap="flat" cmpd="sng" algn="ctr">
+                      <a:noFill/>
+                      <a:prstDash val="solid"/>
+                      <a:round/>
+                      <a:headEnd type="none" w="med" len="med"/>
+                      <a:tailEnd type="none" w="med" len="med"/>
+                    </a:lnB>
+                    <a:lnTlToBr w="12700" cmpd="sng">
+                      <a:noFill/>
+                      <a:prstDash val="solid"/>
+                    </a:lnTlToBr>
+                    <a:lnBlToTr w="12700" cmpd="sng">
+                      <a:noFill/>
+                      <a:prstDash val="solid"/>
+                    </a:lnBlToTr>
+                  </a:tcPr>
+                </a:tc>
+                <a:tc>
+                  <a:txBody>
+                    <a:bodyPr/>
+                    <a:lstStyle/>
+                    <a:p>
+                      <a:pPr marL="0" marR="0" lvl="0" indent="0" algn="ctr" defTabSz="914400" rtl="0" eaLnBrk="1" fontAlgn="b" latinLnBrk="0" hangingPunct="1">
+                        <a:lnSpc>
+                          <a:spcPct val="100000"/>
+                        </a:lnSpc>
+                        <a:spcBef>
+                          <a:spcPts val="0"/>
+                        </a:spcBef>
+                        <a:spcAft>
+                          <a:spcPts val="0"/>
+                        </a:spcAft>
+                        <a:buClrTx/>
+                        <a:buSzTx/>
+                        <a:buFontTx/>
+                        <a:buNone/>
+                        <a:tabLst/>
+                        <a:defRPr/>
+                      </a:pPr>
+                      <a:r>
+                        <a:rPr kumimoji="0" lang="fr-FR" sz="1400" b="0" i="0" u="none" strike="noStrike" kern="1200" cap="none" spc="0" normalizeH="0" baseline="0" noProof="0" dirty="0">
+                          <a:ln>
+                            <a:noFill/>
+                          </a:ln>
+                          <a:solidFill>
+                            <a:srgbClr val="065A82"/>
+                          </a:solidFill>
+                          <a:effectLst/>
+                          <a:uLnTx/>
+                          <a:uFillTx/>
+                          <a:latin typeface="Aptos Narrow" panose="020B0004020202020204" pitchFamily="34" charset="0"/>
+                          <a:ea typeface="+mn-ea"/>
+                          <a:cs typeface="+mn-cs"/>
+                        </a:rPr>
+                        <a:t>76</a:t>
+                      </a:r>
+                    </a:p>
+                  </a:txBody>
+                  <a:tcPr marL="7620" marR="7620" marT="7620" marB="0" anchor="ctr">
+                    <a:lnL w="12700" cmpd="sng">
+                      <a:noFill/>
+                    </a:lnL>
+                    <a:lnR w="12700" cap="flat" cmpd="sng" algn="ctr">
+                      <a:solidFill>
+                        <a:schemeClr val="tx1"/>
+                      </a:solidFill>
+                      <a:prstDash val="solid"/>
+                      <a:round/>
+                      <a:headEnd type="none" w="med" len="med"/>
+                      <a:tailEnd type="none" w="med" len="med"/>
+                    </a:lnR>
+                    <a:lnT w="12700" cmpd="sng">
+                      <a:noFill/>
+                    </a:lnT>
+                    <a:lnB w="12700" cap="flat" cmpd="sng" algn="ctr">
+                      <a:noFill/>
+                      <a:prstDash val="solid"/>
+                      <a:round/>
+                      <a:headEnd type="none" w="med" len="med"/>
+                      <a:tailEnd type="none" w="med" len="med"/>
+                    </a:lnB>
+                    <a:lnTlToBr w="12700" cmpd="sng">
+                      <a:noFill/>
+                      <a:prstDash val="solid"/>
+                    </a:lnTlToBr>
+                    <a:lnBlToTr w="12700" cmpd="sng">
+                      <a:noFill/>
+                      <a:prstDash val="solid"/>
+                    </a:lnBlToTr>
+                  </a:tcPr>
+                </a:tc>
+                <a:extLst>
+                  <a:ext uri="{0D108BD9-81ED-4DB2-BD59-A6C34878D82A}">
+                    <a16:rowId xmlns:a16="http://schemas.microsoft.com/office/drawing/2014/main" val="2040137925"/>
+                  </a:ext>
+                </a:extLst>
+              </a:tr>
+              <a:tr h="325639">
+                <a:tc>
+                  <a:txBody>
+                    <a:bodyPr/>
+                    <a:lstStyle/>
+                    <a:p>
+                      <a:pPr algn="ctr" fontAlgn="b">
+                        <a:buNone/>
+                      </a:pPr>
+                      <a:r>
+                        <a:rPr lang="fr-FR" sz="1400" b="1" i="0" u="none" strike="noStrike" dirty="0">
+                          <a:solidFill>
+                            <a:srgbClr val="065A82"/>
+                          </a:solidFill>
+                          <a:effectLst/>
+                          <a:latin typeface="Cambria" panose="02040503050406030204" pitchFamily="18" charset="0"/>
+                          <a:ea typeface="Cambria" panose="02040503050406030204" pitchFamily="18" charset="0"/>
+                        </a:rPr>
+                        <a:t>Brosserie</a:t>
+                      </a:r>
+                    </a:p>
+                  </a:txBody>
+                  <a:tcPr marL="7620" marR="7620" marT="7620" marB="0" anchor="ctr">
+                    <a:lnL w="12700" cap="flat" cmpd="sng" algn="ctr">
+                      <a:solidFill>
+                        <a:schemeClr val="tx1"/>
+                      </a:solidFill>
+                      <a:prstDash val="solid"/>
+                      <a:round/>
+                      <a:headEnd type="none" w="med" len="med"/>
+                      <a:tailEnd type="none" w="med" len="med"/>
+                    </a:lnL>
+                    <a:lnR w="12700" cmpd="sng">
+                      <a:noFill/>
+                    </a:lnR>
+                    <a:lnT w="12700" cmpd="sng">
+                      <a:noFill/>
+                    </a:lnT>
+                    <a:lnB w="12700" cap="flat" cmpd="sng" algn="ctr">
+                      <a:noFill/>
+                      <a:prstDash val="solid"/>
+                      <a:round/>
+                      <a:headEnd type="none" w="med" len="med"/>
+                      <a:tailEnd type="none" w="med" len="med"/>
+                    </a:lnB>
+                    <a:lnTlToBr w="12700" cmpd="sng">
+                      <a:noFill/>
+                      <a:prstDash val="solid"/>
+                    </a:lnTlToBr>
+                    <a:lnBlToTr w="12700" cmpd="sng">
+                      <a:noFill/>
+                      <a:prstDash val="solid"/>
+                    </a:lnBlToTr>
+                  </a:tcPr>
+                </a:tc>
+                <a:tc>
+                  <a:txBody>
+                    <a:bodyPr/>
+                    <a:lstStyle/>
+                    <a:p>
+                      <a:pPr marL="0" marR="0" lvl="0" indent="0" algn="ctr" defTabSz="914400" rtl="0" eaLnBrk="1" fontAlgn="b" latinLnBrk="0" hangingPunct="1">
+                        <a:lnSpc>
+                          <a:spcPct val="100000"/>
+                        </a:lnSpc>
+                        <a:spcBef>
+                          <a:spcPts val="0"/>
+                        </a:spcBef>
+                        <a:spcAft>
+                          <a:spcPts val="0"/>
+                        </a:spcAft>
+                        <a:buClrTx/>
+                        <a:buSzTx/>
+                        <a:buFontTx/>
+                        <a:buNone/>
+                        <a:tabLst/>
+                        <a:defRPr/>
+                      </a:pPr>
+                      <a:r>
+                        <a:rPr kumimoji="0" lang="fr-FR" sz="1400" b="0" i="0" u="none" strike="noStrike" kern="1200" cap="none" spc="0" normalizeH="0" baseline="0" noProof="0" dirty="0">
+                          <a:ln>
+                            <a:noFill/>
+                          </a:ln>
+                          <a:solidFill>
+                            <a:srgbClr val="065A82"/>
+                          </a:solidFill>
+                          <a:effectLst/>
+                          <a:uLnTx/>
+                          <a:uFillTx/>
+                          <a:latin typeface="Aptos Narrow" panose="020B0004020202020204" pitchFamily="34" charset="0"/>
+                          <a:ea typeface="+mn-ea"/>
+                          <a:cs typeface="+mn-cs"/>
+                        </a:rPr>
+                        <a:t>81,9</a:t>
+                      </a:r>
+                    </a:p>
+                  </a:txBody>
+                  <a:tcPr marL="7620" marR="7620" marT="7620" marB="0" anchor="ctr">
+                    <a:lnL w="12700" cmpd="sng">
+                      <a:noFill/>
+                    </a:lnL>
+                    <a:lnR w="12700" cmpd="sng">
+                      <a:noFill/>
+                    </a:lnR>
+                    <a:lnT w="12700" cmpd="sng">
+                      <a:noFill/>
+                    </a:lnT>
+                    <a:lnB w="12700" cap="flat" cmpd="sng" algn="ctr">
+                      <a:noFill/>
+                      <a:prstDash val="solid"/>
+                      <a:round/>
+                      <a:headEnd type="none" w="med" len="med"/>
+                      <a:tailEnd type="none" w="med" len="med"/>
+                    </a:lnB>
+                    <a:lnTlToBr w="12700" cmpd="sng">
+                      <a:noFill/>
+                      <a:prstDash val="solid"/>
+                    </a:lnTlToBr>
+                    <a:lnBlToTr w="12700" cmpd="sng">
+                      <a:noFill/>
+                      <a:prstDash val="solid"/>
+                    </a:lnBlToTr>
+                  </a:tcPr>
+                </a:tc>
+                <a:tc>
+                  <a:txBody>
+                    <a:bodyPr/>
+                    <a:lstStyle/>
+                    <a:p>
+                      <a:pPr marL="0" marR="0" lvl="0" indent="0" algn="ctr" defTabSz="914400" rtl="0" eaLnBrk="1" fontAlgn="b" latinLnBrk="0" hangingPunct="1">
+                        <a:lnSpc>
+                          <a:spcPct val="100000"/>
+                        </a:lnSpc>
+                        <a:spcBef>
+                          <a:spcPts val="0"/>
+                        </a:spcBef>
+                        <a:spcAft>
+                          <a:spcPts val="0"/>
+                        </a:spcAft>
+                        <a:buClrTx/>
+                        <a:buSzTx/>
+                        <a:buFontTx/>
+                        <a:buNone/>
+                        <a:tabLst/>
+                        <a:defRPr/>
+                      </a:pPr>
+                      <a:r>
+                        <a:rPr kumimoji="0" lang="fr-FR" sz="1400" b="0" i="0" u="none" strike="noStrike" kern="1200" cap="none" spc="0" normalizeH="0" baseline="0" noProof="0" dirty="0">
+                          <a:ln>
+                            <a:noFill/>
+                          </a:ln>
+                          <a:solidFill>
+                            <a:srgbClr val="065A82"/>
+                          </a:solidFill>
+                          <a:effectLst/>
+                          <a:uLnTx/>
+                          <a:uFillTx/>
+                          <a:latin typeface="Aptos Narrow" panose="020B0004020202020204" pitchFamily="34" charset="0"/>
+                          <a:ea typeface="+mn-ea"/>
+                          <a:cs typeface="+mn-cs"/>
+                        </a:rPr>
+                        <a:t>5,9</a:t>
+                      </a:r>
+                    </a:p>
+                  </a:txBody>
+                  <a:tcPr marL="7620" marR="7620" marT="7620" marB="0" anchor="ctr">
+                    <a:lnL w="12700" cmpd="sng">
+                      <a:noFill/>
+                    </a:lnL>
+                    <a:lnR w="12700" cmpd="sng">
+                      <a:noFill/>
+                    </a:lnR>
+                    <a:lnT w="12700" cmpd="sng">
+                      <a:noFill/>
+                    </a:lnT>
+                    <a:lnB w="12700" cap="flat" cmpd="sng" algn="ctr">
+                      <a:noFill/>
+                      <a:prstDash val="solid"/>
+                      <a:round/>
+                      <a:headEnd type="none" w="med" len="med"/>
+                      <a:tailEnd type="none" w="med" len="med"/>
+                    </a:lnB>
+                    <a:lnTlToBr w="12700" cmpd="sng">
+                      <a:noFill/>
+                      <a:prstDash val="solid"/>
+                    </a:lnTlToBr>
+                    <a:lnBlToTr w="12700" cmpd="sng">
+                      <a:noFill/>
+                      <a:prstDash val="solid"/>
+                    </a:lnBlToTr>
+                  </a:tcPr>
+                </a:tc>
+                <a:tc>
+                  <a:txBody>
+                    <a:bodyPr/>
+                    <a:lstStyle/>
+                    <a:p>
+                      <a:pPr marL="0" marR="0" lvl="0" indent="0" algn="ctr" defTabSz="914400" rtl="0" eaLnBrk="1" fontAlgn="b" latinLnBrk="0" hangingPunct="1">
+                        <a:lnSpc>
+                          <a:spcPct val="100000"/>
+                        </a:lnSpc>
+                        <a:spcBef>
+                          <a:spcPts val="0"/>
+                        </a:spcBef>
+                        <a:spcAft>
+                          <a:spcPts val="0"/>
+                        </a:spcAft>
+                        <a:buClrTx/>
+                        <a:buSzTx/>
+                        <a:buFontTx/>
+                        <a:buNone/>
+                        <a:tabLst/>
+                        <a:defRPr/>
+                      </a:pPr>
+                      <a:r>
+                        <a:rPr kumimoji="0" lang="fr-FR" sz="1400" b="0" i="0" u="none" strike="noStrike" kern="1200" cap="none" spc="0" normalizeH="0" baseline="0" noProof="0" dirty="0">
+                          <a:ln>
+                            <a:noFill/>
+                          </a:ln>
+                          <a:solidFill>
+                            <a:srgbClr val="065A82"/>
+                          </a:solidFill>
+                          <a:effectLst/>
+                          <a:uLnTx/>
+                          <a:uFillTx/>
+                          <a:latin typeface="Aptos Narrow" panose="020B0004020202020204" pitchFamily="34" charset="0"/>
+                          <a:ea typeface="+mn-ea"/>
+                          <a:cs typeface="+mn-cs"/>
+                        </a:rPr>
+                        <a:t>8,0</a:t>
+                      </a:r>
+                    </a:p>
+                  </a:txBody>
+                  <a:tcPr marL="7620" marR="7620" marT="7620" marB="0" anchor="ctr">
+                    <a:lnL w="12700" cmpd="sng">
+                      <a:noFill/>
+                    </a:lnL>
+                    <a:lnR w="12700" cap="flat" cmpd="sng" algn="ctr">
+                      <a:solidFill>
+                        <a:schemeClr val="tx1"/>
+                      </a:solidFill>
+                      <a:prstDash val="solid"/>
+                      <a:round/>
+                      <a:headEnd type="none" w="med" len="med"/>
+                      <a:tailEnd type="none" w="med" len="med"/>
+                    </a:lnR>
+                    <a:lnT w="12700" cmpd="sng">
+                      <a:noFill/>
+                    </a:lnT>
+                    <a:lnB w="12700" cap="flat" cmpd="sng" algn="ctr">
+                      <a:noFill/>
+                      <a:prstDash val="solid"/>
+                      <a:round/>
+                      <a:headEnd type="none" w="med" len="med"/>
+                      <a:tailEnd type="none" w="med" len="med"/>
+                    </a:lnB>
+                    <a:lnTlToBr w="12700" cmpd="sng">
+                      <a:noFill/>
+                      <a:prstDash val="solid"/>
+                    </a:lnTlToBr>
+                    <a:lnBlToTr w="12700" cmpd="sng">
+                      <a:noFill/>
+                      <a:prstDash val="solid"/>
+                    </a:lnBlToTr>
+                  </a:tcPr>
+                </a:tc>
+                <a:extLst>
+                  <a:ext uri="{0D108BD9-81ED-4DB2-BD59-A6C34878D82A}">
+                    <a16:rowId xmlns:a16="http://schemas.microsoft.com/office/drawing/2014/main" val="524926384"/>
+                  </a:ext>
+                </a:extLst>
+              </a:tr>
+              <a:tr h="325639">
+                <a:tc>
+                  <a:txBody>
+                    <a:bodyPr/>
+                    <a:lstStyle/>
+                    <a:p>
+                      <a:pPr algn="ctr" fontAlgn="b">
+                        <a:buNone/>
+                      </a:pPr>
+                      <a:r>
+                        <a:rPr lang="fr-FR" sz="1400" b="1" i="0" u="none" strike="noStrike" dirty="0">
+                          <a:solidFill>
+                            <a:srgbClr val="065A82"/>
+                          </a:solidFill>
+                          <a:effectLst/>
+                          <a:latin typeface="Cambria" panose="02040503050406030204" pitchFamily="18" charset="0"/>
+                          <a:ea typeface="Cambria" panose="02040503050406030204" pitchFamily="18" charset="0"/>
+                        </a:rPr>
+                        <a:t>Achats Local</a:t>
+                      </a:r>
+                    </a:p>
+                  </a:txBody>
+                  <a:tcPr marL="7620" marR="7620" marT="7620" marB="0" anchor="ctr">
+                    <a:lnL w="12700" cap="flat" cmpd="sng" algn="ctr">
+                      <a:solidFill>
+                        <a:schemeClr val="tx1"/>
+                      </a:solidFill>
+                      <a:prstDash val="solid"/>
+                      <a:round/>
+                      <a:headEnd type="none" w="med" len="med"/>
+                      <a:tailEnd type="none" w="med" len="med"/>
+                    </a:lnL>
+                    <a:lnR w="12700" cmpd="sng">
+                      <a:noFill/>
+                    </a:lnR>
+                    <a:lnT w="12700" cmpd="sng">
+                      <a:noFill/>
+                    </a:lnT>
+                    <a:lnB w="12700" cap="flat" cmpd="sng" algn="ctr">
+                      <a:noFill/>
+                      <a:prstDash val="solid"/>
+                      <a:round/>
+                      <a:headEnd type="none" w="med" len="med"/>
+                      <a:tailEnd type="none" w="med" len="med"/>
+                    </a:lnB>
+                    <a:lnTlToBr w="12700" cmpd="sng">
+                      <a:noFill/>
+                      <a:prstDash val="solid"/>
+                    </a:lnTlToBr>
+                    <a:lnBlToTr w="12700" cmpd="sng">
+                      <a:noFill/>
+                      <a:prstDash val="solid"/>
+                    </a:lnBlToTr>
+                  </a:tcPr>
+                </a:tc>
+                <a:tc>
+                  <a:txBody>
+                    <a:bodyPr/>
+                    <a:lstStyle/>
+                    <a:p>
+                      <a:pPr marL="0" marR="0" lvl="0" indent="0" algn="ctr" defTabSz="914400" rtl="0" eaLnBrk="1" fontAlgn="b" latinLnBrk="0" hangingPunct="1">
+                        <a:lnSpc>
+                          <a:spcPct val="100000"/>
+                        </a:lnSpc>
+                        <a:spcBef>
+                          <a:spcPts val="0"/>
+                        </a:spcBef>
+                        <a:spcAft>
+                          <a:spcPts val="0"/>
+                        </a:spcAft>
+                        <a:buClrTx/>
+                        <a:buSzTx/>
+                        <a:buFontTx/>
+                        <a:buNone/>
+                        <a:tabLst/>
+                        <a:defRPr/>
+                      </a:pPr>
+                      <a:r>
+                        <a:rPr kumimoji="0" lang="fr-FR" sz="1400" b="0" i="0" u="none" strike="noStrike" kern="1200" cap="none" spc="0" normalizeH="0" baseline="0" noProof="0" dirty="0">
+                          <a:ln>
+                            <a:noFill/>
+                          </a:ln>
+                          <a:solidFill>
+                            <a:srgbClr val="065A82"/>
+                          </a:solidFill>
+                          <a:effectLst/>
+                          <a:uLnTx/>
+                          <a:uFillTx/>
+                          <a:latin typeface="Aptos Narrow" panose="020B0004020202020204" pitchFamily="34" charset="0"/>
+                          <a:ea typeface="+mn-ea"/>
+                          <a:cs typeface="+mn-cs"/>
+                        </a:rPr>
+                        <a:t>135,6</a:t>
+                      </a:r>
+                    </a:p>
+                  </a:txBody>
+                  <a:tcPr marL="7620" marR="7620" marT="7620" marB="0" anchor="ctr">
+                    <a:lnL w="12700" cmpd="sng">
+                      <a:noFill/>
+                    </a:lnL>
+                    <a:lnR w="12700" cmpd="sng">
+                      <a:noFill/>
+                    </a:lnR>
+                    <a:lnT w="12700" cmpd="sng">
+                      <a:noFill/>
+                    </a:lnT>
+                    <a:lnB w="12700" cap="flat" cmpd="sng" algn="ctr">
+                      <a:noFill/>
+                      <a:prstDash val="solid"/>
+                      <a:round/>
+                      <a:headEnd type="none" w="med" len="med"/>
+                      <a:tailEnd type="none" w="med" len="med"/>
+                    </a:lnB>
+                    <a:lnTlToBr w="12700" cmpd="sng">
+                      <a:noFill/>
+                      <a:prstDash val="solid"/>
+                    </a:lnTlToBr>
+                    <a:lnBlToTr w="12700" cmpd="sng">
+                      <a:noFill/>
+                      <a:prstDash val="solid"/>
+                    </a:lnBlToTr>
+                  </a:tcPr>
+                </a:tc>
+                <a:tc>
+                  <a:txBody>
+                    <a:bodyPr/>
+                    <a:lstStyle/>
+                    <a:p>
+                      <a:pPr marL="0" marR="0" lvl="0" indent="0" algn="ctr" defTabSz="914400" rtl="0" eaLnBrk="1" fontAlgn="b" latinLnBrk="0" hangingPunct="1">
+                        <a:lnSpc>
+                          <a:spcPct val="100000"/>
+                        </a:lnSpc>
+                        <a:spcBef>
+                          <a:spcPts val="0"/>
+                        </a:spcBef>
+                        <a:spcAft>
+                          <a:spcPts val="0"/>
+                        </a:spcAft>
+                        <a:buClrTx/>
+                        <a:buSzTx/>
+                        <a:buFontTx/>
+                        <a:buNone/>
+                        <a:tabLst/>
+                        <a:defRPr/>
+                      </a:pPr>
+                      <a:r>
+                        <a:rPr kumimoji="0" lang="fr-FR" sz="1400" b="0" i="0" u="none" strike="noStrike" kern="1200" cap="none" spc="0" normalizeH="0" baseline="0" noProof="0" dirty="0">
+                          <a:ln>
+                            <a:noFill/>
+                          </a:ln>
+                          <a:solidFill>
+                            <a:srgbClr val="065A82"/>
+                          </a:solidFill>
+                          <a:effectLst/>
+                          <a:uLnTx/>
+                          <a:uFillTx/>
+                          <a:latin typeface="Aptos Narrow" panose="020B0004020202020204" pitchFamily="34" charset="0"/>
+                          <a:ea typeface="+mn-ea"/>
+                          <a:cs typeface="+mn-cs"/>
+                        </a:rPr>
+                        <a:t>1,5</a:t>
+                      </a:r>
+                    </a:p>
+                  </a:txBody>
+                  <a:tcPr marL="7620" marR="7620" marT="7620" marB="0" anchor="ctr">
+                    <a:lnL w="12700" cmpd="sng">
+                      <a:noFill/>
+                    </a:lnL>
+                    <a:lnR w="12700" cmpd="sng">
+                      <a:noFill/>
+                    </a:lnR>
+                    <a:lnT w="12700" cmpd="sng">
+                      <a:noFill/>
+                    </a:lnT>
+                    <a:lnB w="12700" cap="flat" cmpd="sng" algn="ctr">
+                      <a:noFill/>
+                      <a:prstDash val="solid"/>
+                      <a:round/>
+                      <a:headEnd type="none" w="med" len="med"/>
+                      <a:tailEnd type="none" w="med" len="med"/>
+                    </a:lnB>
+                    <a:lnTlToBr w="12700" cmpd="sng">
+                      <a:noFill/>
+                      <a:prstDash val="solid"/>
+                    </a:lnTlToBr>
+                    <a:lnBlToTr w="12700" cmpd="sng">
+                      <a:noFill/>
+                      <a:prstDash val="solid"/>
+                    </a:lnBlToTr>
+                  </a:tcPr>
+                </a:tc>
+                <a:tc>
+                  <a:txBody>
+                    <a:bodyPr/>
+                    <a:lstStyle/>
+                    <a:p>
+                      <a:pPr marL="0" marR="0" lvl="0" indent="0" algn="ctr" defTabSz="914400" rtl="0" eaLnBrk="1" fontAlgn="b" latinLnBrk="0" hangingPunct="1">
+                        <a:lnSpc>
+                          <a:spcPct val="100000"/>
+                        </a:lnSpc>
+                        <a:spcBef>
+                          <a:spcPts val="0"/>
+                        </a:spcBef>
+                        <a:spcAft>
+                          <a:spcPts val="0"/>
+                        </a:spcAft>
+                        <a:buClrTx/>
+                        <a:buSzTx/>
+                        <a:buFontTx/>
+                        <a:buNone/>
+                        <a:tabLst/>
+                        <a:defRPr/>
+                      </a:pPr>
+                      <a:r>
+                        <a:rPr kumimoji="0" lang="fr-FR" sz="1400" b="0" i="0" u="none" strike="noStrike" kern="1200" cap="none" spc="0" normalizeH="0" baseline="0" noProof="0" dirty="0">
+                          <a:ln>
+                            <a:noFill/>
+                          </a:ln>
+                          <a:solidFill>
+                            <a:srgbClr val="065A82"/>
+                          </a:solidFill>
+                          <a:effectLst/>
+                          <a:uLnTx/>
+                          <a:uFillTx/>
+                          <a:latin typeface="Aptos Narrow" panose="020B0004020202020204" pitchFamily="34" charset="0"/>
+                          <a:ea typeface="+mn-ea"/>
+                          <a:cs typeface="+mn-cs"/>
+                        </a:rPr>
+                        <a:t>7,0</a:t>
+                      </a:r>
+                    </a:p>
+                  </a:txBody>
+                  <a:tcPr marL="7620" marR="7620" marT="7620" marB="0" anchor="ctr">
+                    <a:lnL w="12700" cmpd="sng">
+                      <a:noFill/>
+                    </a:lnL>
+                    <a:lnR w="12700" cap="flat" cmpd="sng" algn="ctr">
+                      <a:solidFill>
+                        <a:schemeClr val="tx1"/>
+                      </a:solidFill>
+                      <a:prstDash val="solid"/>
+                      <a:round/>
+                      <a:headEnd type="none" w="med" len="med"/>
+                      <a:tailEnd type="none" w="med" len="med"/>
+                    </a:lnR>
+                    <a:lnT w="12700" cmpd="sng">
+                      <a:noFill/>
+                    </a:lnT>
+                    <a:lnB w="12700" cap="flat" cmpd="sng" algn="ctr">
+                      <a:noFill/>
+                      <a:prstDash val="solid"/>
+                      <a:round/>
+                      <a:headEnd type="none" w="med" len="med"/>
+                      <a:tailEnd type="none" w="med" len="med"/>
+                    </a:lnB>
+                    <a:lnTlToBr w="12700" cmpd="sng">
+                      <a:noFill/>
+                      <a:prstDash val="solid"/>
+                    </a:lnTlToBr>
+                    <a:lnBlToTr w="12700" cmpd="sng">
+                      <a:noFill/>
+                      <a:prstDash val="solid"/>
+                    </a:lnBlToTr>
+                  </a:tcPr>
+                </a:tc>
+                <a:extLst>
+                  <a:ext uri="{0D108BD9-81ED-4DB2-BD59-A6C34878D82A}">
+                    <a16:rowId xmlns:a16="http://schemas.microsoft.com/office/drawing/2014/main" val="2148493327"/>
+                  </a:ext>
+                </a:extLst>
+              </a:tr>
+              <a:tr h="325639">
+                <a:tc>
+                  <a:txBody>
+                    <a:bodyPr/>
+                    <a:lstStyle/>
+                    <a:p>
+                      <a:pPr algn="ctr" fontAlgn="b">
+                        <a:buNone/>
+                      </a:pPr>
+                      <a:r>
+                        <a:rPr lang="fr-FR" sz="1400" b="1" i="0" u="none" strike="noStrike" dirty="0">
+                          <a:solidFill>
+                            <a:srgbClr val="065A82"/>
+                          </a:solidFill>
+                          <a:effectLst/>
+                          <a:latin typeface="Cambria" panose="02040503050406030204" pitchFamily="18" charset="0"/>
+                          <a:ea typeface="Cambria" panose="02040503050406030204" pitchFamily="18" charset="0"/>
+                        </a:rPr>
+                        <a:t>Disque d'Entretien</a:t>
+                      </a:r>
+                    </a:p>
+                  </a:txBody>
+                  <a:tcPr marL="7620" marR="7620" marT="7620" marB="0" anchor="ctr">
+                    <a:lnL w="12700" cap="flat" cmpd="sng" algn="ctr">
+                      <a:solidFill>
+                        <a:schemeClr val="tx1"/>
+                      </a:solidFill>
+                      <a:prstDash val="solid"/>
+                      <a:round/>
+                      <a:headEnd type="none" w="med" len="med"/>
+                      <a:tailEnd type="none" w="med" len="med"/>
+                    </a:lnL>
+                    <a:lnR w="12700" cmpd="sng">
+                      <a:noFill/>
+                    </a:lnR>
+                    <a:lnT w="12700" cmpd="sng">
+                      <a:noFill/>
+                    </a:lnT>
+                    <a:lnB w="12700" cap="flat" cmpd="sng" algn="ctr">
+                      <a:noFill/>
+                      <a:prstDash val="solid"/>
+                      <a:round/>
+                      <a:headEnd type="none" w="med" len="med"/>
+                      <a:tailEnd type="none" w="med" len="med"/>
+                    </a:lnB>
+                    <a:lnTlToBr w="12700" cmpd="sng">
+                      <a:noFill/>
+                      <a:prstDash val="solid"/>
+                    </a:lnTlToBr>
+                    <a:lnBlToTr w="12700" cmpd="sng">
+                      <a:noFill/>
+                      <a:prstDash val="solid"/>
+                    </a:lnBlToTr>
+                  </a:tcPr>
+                </a:tc>
+                <a:tc>
+                  <a:txBody>
+                    <a:bodyPr/>
+                    <a:lstStyle/>
+                    <a:p>
+                      <a:pPr marL="0" marR="0" lvl="0" indent="0" algn="ctr" defTabSz="914400" rtl="0" eaLnBrk="1" fontAlgn="b" latinLnBrk="0" hangingPunct="1">
+                        <a:lnSpc>
+                          <a:spcPct val="100000"/>
+                        </a:lnSpc>
+                        <a:spcBef>
+                          <a:spcPts val="0"/>
+                        </a:spcBef>
+                        <a:spcAft>
+                          <a:spcPts val="0"/>
+                        </a:spcAft>
+                        <a:buClrTx/>
+                        <a:buSzTx/>
+                        <a:buFontTx/>
+                        <a:buNone/>
+                        <a:tabLst/>
+                        <a:defRPr/>
+                      </a:pPr>
+                      <a:r>
+                        <a:rPr kumimoji="0" lang="fr-FR" sz="1400" b="0" i="0" u="none" strike="noStrike" kern="1200" cap="none" spc="0" normalizeH="0" baseline="0" noProof="0" dirty="0">
+                          <a:ln>
+                            <a:noFill/>
+                          </a:ln>
+                          <a:solidFill>
+                            <a:srgbClr val="065A82"/>
+                          </a:solidFill>
+                          <a:effectLst/>
+                          <a:uLnTx/>
+                          <a:uFillTx/>
+                          <a:latin typeface="Aptos Narrow" panose="020B0004020202020204" pitchFamily="34" charset="0"/>
+                          <a:ea typeface="+mn-ea"/>
+                          <a:cs typeface="+mn-cs"/>
+                        </a:rPr>
+                        <a:t>210,9</a:t>
+                      </a:r>
+                    </a:p>
+                  </a:txBody>
+                  <a:tcPr marL="7620" marR="7620" marT="7620" marB="0" anchor="ctr">
+                    <a:lnL w="12700" cmpd="sng">
+                      <a:noFill/>
+                    </a:lnL>
+                    <a:lnR w="12700" cmpd="sng">
+                      <a:noFill/>
+                    </a:lnR>
+                    <a:lnT w="12700" cmpd="sng">
+                      <a:noFill/>
+                    </a:lnT>
+                    <a:lnB w="12700" cap="flat" cmpd="sng" algn="ctr">
+                      <a:noFill/>
+                      <a:prstDash val="solid"/>
+                      <a:round/>
+                      <a:headEnd type="none" w="med" len="med"/>
+                      <a:tailEnd type="none" w="med" len="med"/>
+                    </a:lnB>
+                    <a:lnTlToBr w="12700" cmpd="sng">
+                      <a:noFill/>
+                      <a:prstDash val="solid"/>
+                    </a:lnTlToBr>
+                    <a:lnBlToTr w="12700" cmpd="sng">
+                      <a:noFill/>
+                      <a:prstDash val="solid"/>
+                    </a:lnBlToTr>
+                  </a:tcPr>
+                </a:tc>
+                <a:tc>
+                  <a:txBody>
+                    <a:bodyPr/>
+                    <a:lstStyle/>
+                    <a:p>
+                      <a:pPr marL="0" marR="0" lvl="0" indent="0" algn="ctr" defTabSz="914400" rtl="0" eaLnBrk="1" fontAlgn="b" latinLnBrk="0" hangingPunct="1">
+                        <a:lnSpc>
+                          <a:spcPct val="100000"/>
+                        </a:lnSpc>
+                        <a:spcBef>
+                          <a:spcPts val="0"/>
+                        </a:spcBef>
+                        <a:spcAft>
+                          <a:spcPts val="0"/>
+                        </a:spcAft>
+                        <a:buClrTx/>
+                        <a:buSzTx/>
+                        <a:buFontTx/>
+                        <a:buNone/>
+                        <a:tabLst/>
+                        <a:defRPr/>
+                      </a:pPr>
+                      <a:r>
+                        <a:rPr kumimoji="0" lang="fr-FR" sz="1400" b="0" i="0" u="none" strike="noStrike" kern="1200" cap="none" spc="0" normalizeH="0" baseline="0" noProof="0" dirty="0">
+                          <a:ln>
+                            <a:noFill/>
+                          </a:ln>
+                          <a:solidFill>
+                            <a:srgbClr val="065A82"/>
+                          </a:solidFill>
+                          <a:effectLst/>
+                          <a:uLnTx/>
+                          <a:uFillTx/>
+                          <a:latin typeface="Aptos Narrow" panose="020B0004020202020204" pitchFamily="34" charset="0"/>
+                          <a:ea typeface="+mn-ea"/>
+                          <a:cs typeface="+mn-cs"/>
+                        </a:rPr>
+                        <a:t>9,0</a:t>
+                      </a:r>
+                    </a:p>
+                  </a:txBody>
+                  <a:tcPr marL="7620" marR="7620" marT="7620" marB="0" anchor="ctr">
+                    <a:lnL w="12700" cmpd="sng">
+                      <a:noFill/>
+                    </a:lnL>
+                    <a:lnR w="12700" cmpd="sng">
+                      <a:noFill/>
+                    </a:lnR>
+                    <a:lnT w="12700" cmpd="sng">
+                      <a:noFill/>
+                    </a:lnT>
+                    <a:lnB w="12700" cap="flat" cmpd="sng" algn="ctr">
+                      <a:noFill/>
+                      <a:prstDash val="solid"/>
+                      <a:round/>
+                      <a:headEnd type="none" w="med" len="med"/>
+                      <a:tailEnd type="none" w="med" len="med"/>
+                    </a:lnB>
+                    <a:lnTlToBr w="12700" cmpd="sng">
+                      <a:noFill/>
+                      <a:prstDash val="solid"/>
+                    </a:lnTlToBr>
+                    <a:lnBlToTr w="12700" cmpd="sng">
+                      <a:noFill/>
+                      <a:prstDash val="solid"/>
+                    </a:lnBlToTr>
+                  </a:tcPr>
+                </a:tc>
+                <a:tc>
+                  <a:txBody>
+                    <a:bodyPr/>
+                    <a:lstStyle/>
+                    <a:p>
+                      <a:pPr marL="0" marR="0" lvl="0" indent="0" algn="ctr" defTabSz="914400" rtl="0" eaLnBrk="1" fontAlgn="b" latinLnBrk="0" hangingPunct="1">
+                        <a:lnSpc>
+                          <a:spcPct val="100000"/>
+                        </a:lnSpc>
+                        <a:spcBef>
+                          <a:spcPts val="0"/>
+                        </a:spcBef>
+                        <a:spcAft>
+                          <a:spcPts val="0"/>
+                        </a:spcAft>
+                        <a:buClrTx/>
+                        <a:buSzTx/>
+                        <a:buFontTx/>
+                        <a:buNone/>
+                        <a:tabLst/>
+                        <a:defRPr/>
+                      </a:pPr>
+                      <a:r>
+                        <a:rPr kumimoji="0" lang="fr-FR" sz="1400" b="0" i="0" u="none" strike="noStrike" kern="1200" cap="none" spc="0" normalizeH="0" baseline="0" noProof="0" dirty="0">
+                          <a:ln>
+                            <a:noFill/>
+                          </a:ln>
+                          <a:solidFill>
+                            <a:srgbClr val="065A82"/>
+                          </a:solidFill>
+                          <a:effectLst/>
+                          <a:uLnTx/>
+                          <a:uFillTx/>
+                          <a:latin typeface="Aptos Narrow" panose="020B0004020202020204" pitchFamily="34" charset="0"/>
+                          <a:ea typeface="+mn-ea"/>
+                          <a:cs typeface="+mn-cs"/>
+                        </a:rPr>
+                        <a:t>3,2</a:t>
+                      </a:r>
+                    </a:p>
+                  </a:txBody>
+                  <a:tcPr marL="7620" marR="7620" marT="7620" marB="0" anchor="ctr">
+                    <a:lnL w="12700" cmpd="sng">
+                      <a:noFill/>
+                    </a:lnL>
+                    <a:lnR w="12700" cap="flat" cmpd="sng" algn="ctr">
+                      <a:solidFill>
+                        <a:schemeClr val="tx1"/>
+                      </a:solidFill>
+                      <a:prstDash val="solid"/>
+                      <a:round/>
+                      <a:headEnd type="none" w="med" len="med"/>
+                      <a:tailEnd type="none" w="med" len="med"/>
+                    </a:lnR>
+                    <a:lnT w="12700" cmpd="sng">
+                      <a:noFill/>
+                    </a:lnT>
+                    <a:lnB w="12700" cap="flat" cmpd="sng" algn="ctr">
+                      <a:noFill/>
+                      <a:prstDash val="solid"/>
+                      <a:round/>
+                      <a:headEnd type="none" w="med" len="med"/>
+                      <a:tailEnd type="none" w="med" len="med"/>
+                    </a:lnB>
+                    <a:lnTlToBr w="12700" cmpd="sng">
+                      <a:noFill/>
+                      <a:prstDash val="solid"/>
+                    </a:lnTlToBr>
+                    <a:lnBlToTr w="12700" cmpd="sng">
+                      <a:noFill/>
+                      <a:prstDash val="solid"/>
+                    </a:lnBlToTr>
+                  </a:tcPr>
+                </a:tc>
+                <a:extLst>
+                  <a:ext uri="{0D108BD9-81ED-4DB2-BD59-A6C34878D82A}">
+                    <a16:rowId xmlns:a16="http://schemas.microsoft.com/office/drawing/2014/main" val="194641906"/>
+                  </a:ext>
+                </a:extLst>
+              </a:tr>
+              <a:tr h="325639">
+                <a:tc>
+                  <a:txBody>
+                    <a:bodyPr/>
+                    <a:lstStyle/>
+                    <a:p>
+                      <a:pPr algn="ctr" fontAlgn="b">
+                        <a:buNone/>
+                      </a:pPr>
+                      <a:r>
+                        <a:rPr lang="fr-FR" sz="1400" b="1" i="0" u="none" strike="noStrike" dirty="0">
+                          <a:solidFill>
+                            <a:srgbClr val="065A82"/>
+                          </a:solidFill>
+                          <a:effectLst/>
+                          <a:latin typeface="Cambria" panose="02040503050406030204" pitchFamily="18" charset="0"/>
+                          <a:ea typeface="Cambria" panose="02040503050406030204" pitchFamily="18" charset="0"/>
+                        </a:rPr>
+                        <a:t>TOT</a:t>
+                      </a:r>
+                    </a:p>
+                  </a:txBody>
+                  <a:tcPr marL="7620" marR="7620" marT="7620" marB="0" anchor="ctr">
+                    <a:lnL w="12700" cap="flat" cmpd="sng" algn="ctr">
+                      <a:solidFill>
+                        <a:schemeClr val="tx1"/>
+                      </a:solidFill>
+                      <a:prstDash val="solid"/>
+                      <a:round/>
+                      <a:headEnd type="none" w="med" len="med"/>
+                      <a:tailEnd type="none" w="med" len="med"/>
+                    </a:lnL>
+                    <a:lnR w="12700" cmpd="sng">
+                      <a:noFill/>
+                    </a:lnR>
+                    <a:lnT w="12700" cmpd="sng">
+                      <a:noFill/>
+                    </a:lnT>
+                    <a:lnB w="12700" cap="flat" cmpd="sng" algn="ctr">
+                      <a:solidFill>
+                        <a:schemeClr val="tx1"/>
+                      </a:solidFill>
+                      <a:prstDash val="solid"/>
+                      <a:round/>
+                      <a:headEnd type="none" w="med" len="med"/>
+                      <a:tailEnd type="none" w="med" len="med"/>
+                    </a:lnB>
+                    <a:lnTlToBr w="12700" cmpd="sng">
+                      <a:noFill/>
+                      <a:prstDash val="solid"/>
+                    </a:lnTlToBr>
+                    <a:lnBlToTr w="12700" cmpd="sng">
+                      <a:noFill/>
+                      <a:prstDash val="solid"/>
+                    </a:lnBlToTr>
+                  </a:tcPr>
+                </a:tc>
+                <a:tc>
+                  <a:txBody>
+                    <a:bodyPr/>
+                    <a:lstStyle/>
+                    <a:p>
+                      <a:pPr marL="0" marR="0" lvl="0" indent="0" algn="ctr" defTabSz="914400" rtl="0" eaLnBrk="1" fontAlgn="b" latinLnBrk="0" hangingPunct="1">
+                        <a:lnSpc>
+                          <a:spcPct val="100000"/>
+                        </a:lnSpc>
+                        <a:spcBef>
+                          <a:spcPts val="0"/>
+                        </a:spcBef>
+                        <a:spcAft>
+                          <a:spcPts val="0"/>
+                        </a:spcAft>
+                        <a:buClrTx/>
+                        <a:buSzTx/>
+                        <a:buFontTx/>
+                        <a:buNone/>
+                        <a:tabLst/>
+                        <a:defRPr/>
+                      </a:pPr>
+                      <a:r>
+                        <a:rPr kumimoji="0" lang="fr-FR" sz="1400" b="0" i="0" u="none" strike="noStrike" kern="1200" cap="none" spc="0" normalizeH="0" baseline="0" noProof="0" dirty="0">
+                          <a:ln>
+                            <a:noFill/>
+                          </a:ln>
+                          <a:solidFill>
+                            <a:srgbClr val="065A82"/>
+                          </a:solidFill>
+                          <a:effectLst/>
+                          <a:uLnTx/>
+                          <a:uFillTx/>
+                          <a:latin typeface="Aptos Narrow" panose="020B0004020202020204" pitchFamily="34" charset="0"/>
+                          <a:ea typeface="+mn-ea"/>
+                          <a:cs typeface="+mn-cs"/>
+                        </a:rPr>
+                        <a:t>685</a:t>
+                      </a:r>
+                    </a:p>
+                  </a:txBody>
+                  <a:tcPr marL="7620" marR="7620" marT="7620" marB="0" anchor="ctr">
+                    <a:lnL w="12700" cmpd="sng">
+                      <a:noFill/>
+                    </a:lnL>
+                    <a:lnR w="12700" cmpd="sng">
+                      <a:noFill/>
+                    </a:lnR>
+                    <a:lnT w="12700" cmpd="sng">
+                      <a:noFill/>
+                    </a:lnT>
+                    <a:lnB w="12700" cap="flat" cmpd="sng" algn="ctr">
+                      <a:solidFill>
+                        <a:schemeClr val="tx1"/>
+                      </a:solidFill>
+                      <a:prstDash val="solid"/>
+                      <a:round/>
+                      <a:headEnd type="none" w="med" len="med"/>
+                      <a:tailEnd type="none" w="med" len="med"/>
+                    </a:lnB>
+                    <a:lnTlToBr w="12700" cmpd="sng">
+                      <a:noFill/>
+                      <a:prstDash val="solid"/>
+                    </a:lnTlToBr>
+                    <a:lnBlToTr w="12700" cmpd="sng">
+                      <a:noFill/>
+                      <a:prstDash val="solid"/>
+                    </a:lnBlToTr>
+                  </a:tcPr>
+                </a:tc>
+                <a:tc>
+                  <a:txBody>
+                    <a:bodyPr/>
+                    <a:lstStyle/>
+                    <a:p>
+                      <a:pPr marL="0" marR="0" lvl="0" indent="0" algn="ctr" defTabSz="914400" rtl="0" eaLnBrk="1" fontAlgn="b" latinLnBrk="0" hangingPunct="1">
+                        <a:lnSpc>
+                          <a:spcPct val="100000"/>
+                        </a:lnSpc>
+                        <a:spcBef>
+                          <a:spcPts val="0"/>
+                        </a:spcBef>
+                        <a:spcAft>
+                          <a:spcPts val="0"/>
+                        </a:spcAft>
+                        <a:buClrTx/>
+                        <a:buSzTx/>
+                        <a:buFontTx/>
+                        <a:buNone/>
+                        <a:tabLst/>
+                        <a:defRPr/>
+                      </a:pPr>
+                      <a:r>
+                        <a:rPr kumimoji="0" lang="fr-FR" sz="1400" b="0" i="0" u="none" strike="noStrike" kern="1200" cap="none" spc="0" normalizeH="0" baseline="0" noProof="0" dirty="0">
+                          <a:ln>
+                            <a:noFill/>
+                          </a:ln>
+                          <a:solidFill>
+                            <a:srgbClr val="065A82"/>
+                          </a:solidFill>
+                          <a:effectLst/>
+                          <a:uLnTx/>
+                          <a:uFillTx/>
+                          <a:latin typeface="Aptos Narrow" panose="020B0004020202020204" pitchFamily="34" charset="0"/>
+                          <a:ea typeface="+mn-ea"/>
+                          <a:cs typeface="+mn-cs"/>
+                        </a:rPr>
+                        <a:t>64</a:t>
+                      </a:r>
+                    </a:p>
+                  </a:txBody>
+                  <a:tcPr marL="7620" marR="7620" marT="7620" marB="0" anchor="ctr">
+                    <a:lnL w="12700" cmpd="sng">
+                      <a:noFill/>
+                    </a:lnL>
+                    <a:lnR w="12700" cmpd="sng">
+                      <a:noFill/>
+                    </a:lnR>
+                    <a:lnT w="12700" cmpd="sng">
+                      <a:noFill/>
+                    </a:lnT>
+                    <a:lnB w="12700" cap="flat" cmpd="sng" algn="ctr">
+                      <a:solidFill>
+                        <a:schemeClr val="tx1"/>
+                      </a:solidFill>
+                      <a:prstDash val="solid"/>
+                      <a:round/>
+                      <a:headEnd type="none" w="med" len="med"/>
+                      <a:tailEnd type="none" w="med" len="med"/>
+                    </a:lnB>
+                    <a:lnTlToBr w="12700" cmpd="sng">
+                      <a:noFill/>
+                      <a:prstDash val="solid"/>
+                    </a:lnTlToBr>
+                    <a:lnBlToTr w="12700" cmpd="sng">
+                      <a:noFill/>
+                      <a:prstDash val="solid"/>
+                    </a:lnBlToTr>
+                  </a:tcPr>
+                </a:tc>
+                <a:tc>
+                  <a:txBody>
+                    <a:bodyPr/>
+                    <a:lstStyle/>
+                    <a:p>
+                      <a:pPr marL="0" marR="0" lvl="0" indent="0" algn="ctr" defTabSz="914400" rtl="0" eaLnBrk="1" fontAlgn="b" latinLnBrk="0" hangingPunct="1">
+                        <a:lnSpc>
+                          <a:spcPct val="100000"/>
+                        </a:lnSpc>
+                        <a:spcBef>
+                          <a:spcPts val="0"/>
+                        </a:spcBef>
+                        <a:spcAft>
+                          <a:spcPts val="0"/>
+                        </a:spcAft>
+                        <a:buClrTx/>
+                        <a:buSzTx/>
+                        <a:buFontTx/>
+                        <a:buNone/>
+                        <a:tabLst/>
+                        <a:defRPr/>
+                      </a:pPr>
+                      <a:r>
+                        <a:rPr kumimoji="0" lang="fr-FR" sz="1400" b="0" i="0" u="none" strike="noStrike" kern="1200" cap="none" spc="0" normalizeH="0" baseline="0" noProof="0" dirty="0">
+                          <a:ln>
+                            <a:noFill/>
+                          </a:ln>
+                          <a:solidFill>
+                            <a:srgbClr val="065A82"/>
+                          </a:solidFill>
+                          <a:effectLst/>
+                          <a:uLnTx/>
+                          <a:uFillTx/>
+                          <a:latin typeface="Aptos Narrow" panose="020B0004020202020204" pitchFamily="34" charset="0"/>
+                          <a:ea typeface="+mn-ea"/>
+                          <a:cs typeface="+mn-cs"/>
+                        </a:rPr>
+                        <a:t>749</a:t>
+                      </a:r>
+                    </a:p>
+                  </a:txBody>
+                  <a:tcPr marL="7620" marR="7620" marT="7620" marB="0" anchor="ctr">
+                    <a:lnL w="12700" cmpd="sng">
+                      <a:noFill/>
+                    </a:lnL>
+                    <a:lnR w="12700" cap="flat" cmpd="sng" algn="ctr">
+                      <a:solidFill>
+                        <a:schemeClr val="tx1"/>
+                      </a:solidFill>
+                      <a:prstDash val="solid"/>
+                      <a:round/>
+                      <a:headEnd type="none" w="med" len="med"/>
+                      <a:tailEnd type="none" w="med" len="med"/>
+                    </a:lnR>
+                    <a:lnT w="12700" cmpd="sng">
+                      <a:noFill/>
+                    </a:lnT>
+                    <a:lnB w="12700" cap="flat" cmpd="sng" algn="ctr">
+                      <a:solidFill>
+                        <a:schemeClr val="tx1"/>
+                      </a:solidFill>
+                      <a:prstDash val="solid"/>
+                      <a:round/>
+                      <a:headEnd type="none" w="med" len="med"/>
+                      <a:tailEnd type="none" w="med" len="med"/>
+                    </a:lnB>
+                    <a:lnTlToBr w="12700" cmpd="sng">
+                      <a:noFill/>
+                      <a:prstDash val="solid"/>
+                    </a:lnTlToBr>
+                    <a:lnBlToTr w="12700" cmpd="sng">
+                      <a:noFill/>
+                      <a:prstDash val="solid"/>
+                    </a:lnBlToTr>
+                  </a:tcPr>
+                </a:tc>
+                <a:extLst>
+                  <a:ext uri="{0D108BD9-81ED-4DB2-BD59-A6C34878D82A}">
+                    <a16:rowId xmlns:a16="http://schemas.microsoft.com/office/drawing/2014/main" val="3280060081"/>
+                  </a:ext>
+                </a:extLst>
+              </a:tr>
+            </a:tbl>
+          </a:graphicData>
+        </a:graphic>
+      </p:graphicFrame>
+      <p:sp>
+        <p:nvSpPr>
+          <p:cNvPr id="14" name="Shape 4">
+            <a:extLst>
+              <a:ext uri="{FF2B5EF4-FFF2-40B4-BE49-F238E27FC236}">
+                <a16:creationId xmlns:a16="http://schemas.microsoft.com/office/drawing/2014/main" id="{61A6422C-A83B-F091-72DF-F193D91A884D}"/>
+              </a:ext>
+            </a:extLst>
+          </p:cNvPr>
+          <p:cNvSpPr/>
+          <p:nvPr/>
+        </p:nvSpPr>
+        <p:spPr>
+          <a:xfrm>
+            <a:off x="502920" y="4059936"/>
             <a:ext cx="5394960" cy="2286000"/>
           </a:xfrm>
           <a:prstGeom prst="roundRect">
@@ -9540,19 +12196,25 @@
           <a:bodyPr/>
           <a:lstStyle/>
           <a:p>
-            <a:endParaRPr lang="fr-RE"/>
-          </a:p>
-        </p:txBody>
-      </p:sp>
-      <p:sp>
-        <p:nvSpPr>
-          <p:cNvPr id="14" name="Shape 12"/>
+            <a:endParaRPr lang="fr-RE" dirty="0"/>
+          </a:p>
+        </p:txBody>
+      </p:sp>
+      <p:sp>
+        <p:nvSpPr>
+          <p:cNvPr id="16" name="Shape 5">
+            <a:extLst>
+              <a:ext uri="{FF2B5EF4-FFF2-40B4-BE49-F238E27FC236}">
+                <a16:creationId xmlns:a16="http://schemas.microsoft.com/office/drawing/2014/main" id="{3F5E79D8-C952-0F49-7964-934097FA7421}"/>
+              </a:ext>
+            </a:extLst>
+          </p:cNvPr>
           <p:cNvSpPr/>
           <p:nvPr/>
         </p:nvSpPr>
         <p:spPr>
           <a:xfrm>
-            <a:off x="6446520" y="1773936"/>
+            <a:off x="731520" y="4325112"/>
             <a:ext cx="146304" cy="146304"/>
           </a:xfrm>
           <a:prstGeom prst="ellipse">
@@ -9573,13 +12235,19 @@
       </p:sp>
       <p:sp>
         <p:nvSpPr>
-          <p:cNvPr id="15" name="Text 13"/>
+          <p:cNvPr id="18" name="Text 6">
+            <a:extLst>
+              <a:ext uri="{FF2B5EF4-FFF2-40B4-BE49-F238E27FC236}">
+                <a16:creationId xmlns:a16="http://schemas.microsoft.com/office/drawing/2014/main" id="{02B9A903-A4F1-76B4-76BD-B67125641E3C}"/>
+              </a:ext>
+            </a:extLst>
+          </p:cNvPr>
           <p:cNvSpPr/>
           <p:nvPr/>
         </p:nvSpPr>
         <p:spPr>
           <a:xfrm>
-            <a:off x="6675120" y="1673352"/>
+            <a:off x="960120" y="4224528"/>
             <a:ext cx="4754880" cy="384048"/>
           </a:xfrm>
           <a:prstGeom prst="rect">
@@ -9604,7 +12272,7 @@
                 <a:ea typeface="Calibri" pitchFamily="34" charset="-122"/>
                 <a:cs typeface="Calibri" pitchFamily="34" charset="-120"/>
               </a:rPr>
-              <a:t>Commandes </a:t>
+              <a:t>Articles à </a:t>
             </a:r>
             <a:r>
               <a:rPr lang="en-US" sz="1300" b="1" dirty="0" err="1">
@@ -9615,18 +12283,7 @@
                 <a:ea typeface="Calibri" pitchFamily="34" charset="-122"/>
                 <a:cs typeface="Calibri" pitchFamily="34" charset="-120"/>
               </a:rPr>
-              <a:t>fournisseur</a:t>
-            </a:r>
-            <a:r>
-              <a:rPr lang="en-US" sz="1300" b="1" dirty="0">
-                <a:solidFill>
-                  <a:srgbClr val="2B3A42"/>
-                </a:solidFill>
-                <a:latin typeface="Calibri" pitchFamily="34" charset="0"/>
-                <a:ea typeface="Calibri" pitchFamily="34" charset="-122"/>
-                <a:cs typeface="Calibri" pitchFamily="34" charset="-120"/>
-              </a:rPr>
-              <a:t> recues</a:t>
+              <a:t>épuisement</a:t>
             </a:r>
             <a:endParaRPr lang="en-US" sz="1300" dirty="0"/>
           </a:p>
@@ -9634,49 +12291,10 @@
       </p:sp>
       <p:sp>
         <p:nvSpPr>
-          <p:cNvPr id="16" name="Text 14"/>
-          <p:cNvSpPr/>
-          <p:nvPr/>
-        </p:nvSpPr>
-        <p:spPr>
-          <a:xfrm>
-            <a:off x="6446520" y="2112264"/>
-            <a:ext cx="3456432" cy="1517904"/>
-          </a:xfrm>
-          <a:prstGeom prst="rect">
-            <a:avLst/>
-          </a:prstGeom>
-          <a:noFill/>
-          <a:ln/>
-        </p:spPr>
-        <p:txBody>
-          <a:bodyPr wrap="square" lIns="0" tIns="0" rIns="0" bIns="0" rtlCol="0" anchor="ctr"/>
-          <a:lstStyle/>
-          <a:p>
-            <a:pPr marL="0" indent="0" algn="l">
-              <a:buNone/>
-            </a:pPr>
-            <a:r>
-              <a:rPr lang="en-US" sz="1500" i="1" dirty="0">
-                <a:solidFill>
-                  <a:srgbClr val="8A9BA3"/>
-                </a:solidFill>
-                <a:latin typeface="Calibri" pitchFamily="34" charset="0"/>
-                <a:ea typeface="Calibri" pitchFamily="34" charset="-122"/>
-                <a:cs typeface="Calibri" pitchFamily="34" charset="-120"/>
-              </a:rPr>
-              <a:t>à collecter</a:t>
-            </a:r>
-            <a:endParaRPr lang="en-US" sz="1500" dirty="0"/>
-          </a:p>
-        </p:txBody>
-      </p:sp>
-      <p:sp>
-        <p:nvSpPr>
-          <p:cNvPr id="20" name="Shape 4">
+          <p:cNvPr id="20" name="Text 7">
             <a:extLst>
               <a:ext uri="{FF2B5EF4-FFF2-40B4-BE49-F238E27FC236}">
-                <a16:creationId xmlns:a16="http://schemas.microsoft.com/office/drawing/2014/main" id="{EB98D277-67AA-F4E4-5FD0-7D449990ABC0}"/>
+                <a16:creationId xmlns:a16="http://schemas.microsoft.com/office/drawing/2014/main" id="{E5BDFBDA-E770-FAFC-445B-DED38DD83619}"/>
               </a:ext>
             </a:extLst>
           </p:cNvPr>
@@ -9685,132 +12303,7 @@
         </p:nvSpPr>
         <p:spPr>
           <a:xfrm>
-            <a:off x="502920" y="4151376"/>
-            <a:ext cx="5394960" cy="2286000"/>
-          </a:xfrm>
-          <a:prstGeom prst="roundRect">
-            <a:avLst>
-              <a:gd name="adj" fmla="val 3200"/>
-            </a:avLst>
-          </a:prstGeom>
-          <a:solidFill>
-            <a:srgbClr val="F2F7F8"/>
-          </a:solidFill>
-          <a:ln w="12700">
-            <a:solidFill>
-              <a:srgbClr val="DCE7E9"/>
-            </a:solidFill>
-            <a:prstDash val="solid"/>
-          </a:ln>
-          <a:effectLst>
-            <a:outerShdw blurRad="76200" dist="38100" dir="5400000" algn="bl" rotWithShape="0">
-              <a:srgbClr val="9AB2B6">
-                <a:alpha val="35000"/>
-              </a:srgbClr>
-            </a:outerShdw>
-          </a:effectLst>
-        </p:spPr>
-        <p:txBody>
-          <a:bodyPr/>
-          <a:lstStyle/>
-          <a:p>
-            <a:endParaRPr lang="fr-RE"/>
-          </a:p>
-        </p:txBody>
-      </p:sp>
-      <p:sp>
-        <p:nvSpPr>
-          <p:cNvPr id="22" name="Shape 5">
-            <a:extLst>
-              <a:ext uri="{FF2B5EF4-FFF2-40B4-BE49-F238E27FC236}">
-                <a16:creationId xmlns:a16="http://schemas.microsoft.com/office/drawing/2014/main" id="{D44F991B-2587-77FA-3B61-78D835529A70}"/>
-              </a:ext>
-            </a:extLst>
-          </p:cNvPr>
-          <p:cNvSpPr/>
-          <p:nvPr/>
-        </p:nvSpPr>
-        <p:spPr>
-          <a:xfrm>
-            <a:off x="731520" y="4416552"/>
-            <a:ext cx="146304" cy="146304"/>
-          </a:xfrm>
-          <a:prstGeom prst="ellipse">
-            <a:avLst/>
-          </a:prstGeom>
-          <a:solidFill>
-            <a:srgbClr val="2A6F4E"/>
-          </a:solidFill>
-          <a:ln/>
-        </p:spPr>
-        <p:txBody>
-          <a:bodyPr/>
-          <a:lstStyle/>
-          <a:p>
-            <a:endParaRPr lang="fr-RE"/>
-          </a:p>
-        </p:txBody>
-      </p:sp>
-      <p:sp>
-        <p:nvSpPr>
-          <p:cNvPr id="24" name="Text 6">
-            <a:extLst>
-              <a:ext uri="{FF2B5EF4-FFF2-40B4-BE49-F238E27FC236}">
-                <a16:creationId xmlns:a16="http://schemas.microsoft.com/office/drawing/2014/main" id="{4E9A281F-6682-B130-8536-C8A5904BF425}"/>
-              </a:ext>
-            </a:extLst>
-          </p:cNvPr>
-          <p:cNvSpPr/>
-          <p:nvPr/>
-        </p:nvSpPr>
-        <p:spPr>
-          <a:xfrm>
-            <a:off x="960120" y="4315968"/>
-            <a:ext cx="4754880" cy="384048"/>
-          </a:xfrm>
-          <a:prstGeom prst="rect">
-            <a:avLst/>
-          </a:prstGeom>
-          <a:noFill/>
-          <a:ln/>
-        </p:spPr>
-        <p:txBody>
-          <a:bodyPr wrap="square" lIns="0" tIns="0" rIns="0" bIns="0" rtlCol="0" anchor="ctr"/>
-          <a:lstStyle/>
-          <a:p>
-            <a:pPr marL="0" indent="0" algn="l">
-              <a:buNone/>
-            </a:pPr>
-            <a:r>
-              <a:rPr lang="en-US" sz="1300" b="1" dirty="0">
-                <a:solidFill>
-                  <a:srgbClr val="2B3A42"/>
-                </a:solidFill>
-                <a:latin typeface="Calibri" pitchFamily="34" charset="0"/>
-                <a:ea typeface="Calibri" pitchFamily="34" charset="-122"/>
-                <a:cs typeface="Calibri" pitchFamily="34" charset="-120"/>
-              </a:rPr>
-              <a:t>Couverture de stock</a:t>
-            </a:r>
-            <a:endParaRPr lang="en-US" sz="1300" dirty="0"/>
-          </a:p>
-        </p:txBody>
-      </p:sp>
-      <p:sp>
-        <p:nvSpPr>
-          <p:cNvPr id="26" name="Text 7">
-            <a:extLst>
-              <a:ext uri="{FF2B5EF4-FFF2-40B4-BE49-F238E27FC236}">
-                <a16:creationId xmlns:a16="http://schemas.microsoft.com/office/drawing/2014/main" id="{C63A95BE-8B1E-0F39-74D6-D4687D287FCA}"/>
-              </a:ext>
-            </a:extLst>
-          </p:cNvPr>
-          <p:cNvSpPr/>
-          <p:nvPr/>
-        </p:nvSpPr>
-        <p:spPr>
-          <a:xfrm>
-            <a:off x="731520" y="4754880"/>
+            <a:off x="731520" y="4663440"/>
             <a:ext cx="3456432" cy="1298448"/>
           </a:xfrm>
           <a:prstGeom prst="rect">
@@ -9823,30 +12316,122 @@
           <a:bodyPr wrap="square" lIns="0" tIns="0" rIns="0" bIns="0" rtlCol="0" anchor="ctr"/>
           <a:lstStyle/>
           <a:p>
-            <a:pPr marL="0" indent="0" algn="l">
-              <a:buNone/>
-            </a:pPr>
-            <a:r>
-              <a:rPr lang="en-US" sz="1500" i="1" dirty="0">
-                <a:solidFill>
-                  <a:srgbClr val="8A9BA3"/>
-                </a:solidFill>
-                <a:latin typeface="Calibri" pitchFamily="34" charset="0"/>
-                <a:ea typeface="Calibri" pitchFamily="34" charset="-122"/>
-                <a:cs typeface="Calibri" pitchFamily="34" charset="-120"/>
-              </a:rPr>
-              <a:t>à collecter</a:t>
-            </a:r>
             <a:endParaRPr lang="en-US" sz="1500" dirty="0"/>
           </a:p>
         </p:txBody>
       </p:sp>
-      <p:sp>
-        <p:nvSpPr>
-          <p:cNvPr id="28" name="Shape 8">
+      <p:grpSp>
+        <p:nvGrpSpPr>
+          <p:cNvPr id="30" name="Groupe 29">
             <a:extLst>
               <a:ext uri="{FF2B5EF4-FFF2-40B4-BE49-F238E27FC236}">
-                <a16:creationId xmlns:a16="http://schemas.microsoft.com/office/drawing/2014/main" id="{F86AC5A8-999E-6928-E92C-9EFB6FF3834C}"/>
+                <a16:creationId xmlns:a16="http://schemas.microsoft.com/office/drawing/2014/main" id="{BA528B8C-27C3-9DA5-9ABA-6A4033058951}"/>
+              </a:ext>
+            </a:extLst>
+          </p:cNvPr>
+          <p:cNvGrpSpPr/>
+          <p:nvPr/>
+        </p:nvGrpSpPr>
+        <p:grpSpPr>
+          <a:xfrm>
+            <a:off x="4617656" y="4902966"/>
+            <a:ext cx="662509" cy="512064"/>
+            <a:chOff x="4297680" y="5056632"/>
+            <a:chExt cx="662509" cy="512064"/>
+          </a:xfrm>
+        </p:grpSpPr>
+        <p:sp>
+          <p:nvSpPr>
+            <p:cNvPr id="22" name="Shape 8">
+              <a:extLst>
+                <a:ext uri="{FF2B5EF4-FFF2-40B4-BE49-F238E27FC236}">
+                  <a16:creationId xmlns:a16="http://schemas.microsoft.com/office/drawing/2014/main" id="{359A9F30-EE5D-2466-EB81-9FC1462DA7EA}"/>
+                </a:ext>
+              </a:extLst>
+            </p:cNvPr>
+            <p:cNvSpPr/>
+            <p:nvPr/>
+          </p:nvSpPr>
+          <p:spPr>
+            <a:xfrm>
+              <a:off x="4297680" y="5056632"/>
+              <a:ext cx="662509" cy="512064"/>
+            </a:xfrm>
+            <a:prstGeom prst="roundRect">
+              <a:avLst>
+                <a:gd name="adj" fmla="val 8929"/>
+              </a:avLst>
+            </a:prstGeom>
+            <a:solidFill>
+              <a:srgbClr val="FFFFFF"/>
+            </a:solidFill>
+            <a:ln w="12700">
+              <a:solidFill>
+                <a:srgbClr val="DCE7E9"/>
+              </a:solidFill>
+              <a:prstDash val="solid"/>
+            </a:ln>
+          </p:spPr>
+          <p:txBody>
+            <a:bodyPr/>
+            <a:lstStyle/>
+            <a:p>
+              <a:endParaRPr lang="fr-RE"/>
+            </a:p>
+          </p:txBody>
+        </p:sp>
+        <p:sp>
+          <p:nvSpPr>
+            <p:cNvPr id="24" name="Text 9">
+              <a:extLst>
+                <a:ext uri="{FF2B5EF4-FFF2-40B4-BE49-F238E27FC236}">
+                  <a16:creationId xmlns:a16="http://schemas.microsoft.com/office/drawing/2014/main" id="{7DEB943D-6F47-EA30-ADBE-69522B08D108}"/>
+                </a:ext>
+              </a:extLst>
+            </p:cNvPr>
+            <p:cNvSpPr/>
+            <p:nvPr/>
+          </p:nvSpPr>
+          <p:spPr>
+            <a:xfrm>
+              <a:off x="4297680" y="5099073"/>
+              <a:ext cx="662509" cy="219456"/>
+            </a:xfrm>
+            <a:prstGeom prst="rect">
+              <a:avLst/>
+            </a:prstGeom>
+            <a:noFill/>
+            <a:ln/>
+          </p:spPr>
+          <p:txBody>
+            <a:bodyPr wrap="square" lIns="0" tIns="0" rIns="0" bIns="0" rtlCol="0" anchor="ctr"/>
+            <a:lstStyle/>
+            <a:p>
+              <a:pPr marL="0" indent="0" algn="ctr">
+                <a:buNone/>
+              </a:pPr>
+              <a:r>
+                <a:rPr lang="en-US" sz="950" i="1" dirty="0">
+                  <a:solidFill>
+                    <a:srgbClr val="8A9BA3"/>
+                  </a:solidFill>
+                  <a:latin typeface="Calibri" pitchFamily="34" charset="0"/>
+                  <a:ea typeface="Calibri" pitchFamily="34" charset="-122"/>
+                  <a:cs typeface="Calibri" pitchFamily="34" charset="-120"/>
+                </a:rPr>
+                <a:t>vs Mois-1</a:t>
+              </a:r>
+              <a:endParaRPr lang="en-US" sz="950" dirty="0"/>
+            </a:p>
+          </p:txBody>
+        </p:sp>
+      </p:grpSp>
+      <p:sp>
+        <p:nvSpPr>
+          <p:cNvPr id="26" name="Text 10">
+            <a:extLst>
+              <a:ext uri="{FF2B5EF4-FFF2-40B4-BE49-F238E27FC236}">
+                <a16:creationId xmlns:a16="http://schemas.microsoft.com/office/drawing/2014/main" id="{62A2CCC8-D049-5339-954C-A89622E6C2D7}"/>
               </a:ext>
             </a:extLst>
           </p:cNvPr>
@@ -9855,92 +12440,7 @@
         </p:nvSpPr>
         <p:spPr>
           <a:xfrm>
-            <a:off x="4297680" y="5148072"/>
-            <a:ext cx="1371600" cy="512064"/>
-          </a:xfrm>
-          <a:prstGeom prst="roundRect">
-            <a:avLst>
-              <a:gd name="adj" fmla="val 8929"/>
-            </a:avLst>
-          </a:prstGeom>
-          <a:solidFill>
-            <a:srgbClr val="FFFFFF"/>
-          </a:solidFill>
-          <a:ln w="12700">
-            <a:solidFill>
-              <a:srgbClr val="DCE7E9"/>
-            </a:solidFill>
-            <a:prstDash val="solid"/>
-          </a:ln>
-        </p:spPr>
-        <p:txBody>
-          <a:bodyPr/>
-          <a:lstStyle/>
-          <a:p>
-            <a:endParaRPr lang="fr-RE"/>
-          </a:p>
-        </p:txBody>
-      </p:sp>
-      <p:sp>
-        <p:nvSpPr>
-          <p:cNvPr id="30" name="Text 9">
-            <a:extLst>
-              <a:ext uri="{FF2B5EF4-FFF2-40B4-BE49-F238E27FC236}">
-                <a16:creationId xmlns:a16="http://schemas.microsoft.com/office/drawing/2014/main" id="{B630D70E-B6C0-32FC-D44E-6A57ACFEC787}"/>
-              </a:ext>
-            </a:extLst>
-          </p:cNvPr>
-          <p:cNvSpPr/>
-          <p:nvPr/>
-        </p:nvSpPr>
-        <p:spPr>
-          <a:xfrm>
-            <a:off x="4297680" y="5148072"/>
-            <a:ext cx="1371600" cy="512064"/>
-          </a:xfrm>
-          <a:prstGeom prst="rect">
-            <a:avLst/>
-          </a:prstGeom>
-          <a:noFill/>
-          <a:ln/>
-        </p:spPr>
-        <p:txBody>
-          <a:bodyPr wrap="square" lIns="0" tIns="0" rIns="0" bIns="0" rtlCol="0" anchor="ctr"/>
-          <a:lstStyle/>
-          <a:p>
-            <a:pPr marL="0" indent="0" algn="ctr">
-              <a:buNone/>
-            </a:pPr>
-            <a:r>
-              <a:rPr lang="en-US" sz="950" i="1" dirty="0">
-                <a:solidFill>
-                  <a:srgbClr val="8A9BA3"/>
-                </a:solidFill>
-                <a:latin typeface="Calibri" pitchFamily="34" charset="0"/>
-                <a:ea typeface="Calibri" pitchFamily="34" charset="-122"/>
-                <a:cs typeface="Calibri" pitchFamily="34" charset="-120"/>
-              </a:rPr>
-              <a:t>% vs N-1</a:t>
-            </a:r>
-            <a:endParaRPr lang="en-US" sz="950" dirty="0"/>
-          </a:p>
-        </p:txBody>
-      </p:sp>
-      <p:sp>
-        <p:nvSpPr>
-          <p:cNvPr id="32" name="Text 10">
-            <a:extLst>
-              <a:ext uri="{FF2B5EF4-FFF2-40B4-BE49-F238E27FC236}">
-                <a16:creationId xmlns:a16="http://schemas.microsoft.com/office/drawing/2014/main" id="{CFB98F48-A4B4-CD1F-D271-EBD5B93E0B18}"/>
-              </a:ext>
-            </a:extLst>
-          </p:cNvPr>
-          <p:cNvSpPr/>
-          <p:nvPr/>
-        </p:nvSpPr>
-        <p:spPr>
-          <a:xfrm>
-            <a:off x="749808" y="6089904"/>
+            <a:off x="749808" y="5998464"/>
             <a:ext cx="4937760" cy="219456"/>
           </a:xfrm>
           <a:prstGeom prst="rect">
@@ -9965,236 +12465,10 @@
                 <a:ea typeface="Calibri" pitchFamily="34" charset="-122"/>
                 <a:cs typeface="Calibri" pitchFamily="34" charset="-120"/>
               </a:rPr>
-              <a:t>par catégorie</a:t>
-            </a:r>
-            <a:endParaRPr lang="en-US" sz="1050" dirty="0"/>
-          </a:p>
-        </p:txBody>
-      </p:sp>
-      <p:sp>
-        <p:nvSpPr>
-          <p:cNvPr id="18" name="Shape 11">
-            <a:extLst>
-              <a:ext uri="{FF2B5EF4-FFF2-40B4-BE49-F238E27FC236}">
-                <a16:creationId xmlns:a16="http://schemas.microsoft.com/office/drawing/2014/main" id="{5B62FBC4-8E47-5578-86F4-333B710B61B0}"/>
-              </a:ext>
-            </a:extLst>
-          </p:cNvPr>
-          <p:cNvSpPr/>
-          <p:nvPr/>
-        </p:nvSpPr>
-        <p:spPr>
-          <a:xfrm>
-            <a:off x="6217920" y="4151376"/>
-            <a:ext cx="5394960" cy="2286000"/>
-          </a:xfrm>
-          <a:prstGeom prst="roundRect">
-            <a:avLst>
-              <a:gd name="adj" fmla="val 3200"/>
-            </a:avLst>
-          </a:prstGeom>
-          <a:solidFill>
-            <a:srgbClr val="F2F7F8"/>
-          </a:solidFill>
-          <a:ln w="12700">
-            <a:solidFill>
-              <a:srgbClr val="DCE7E9"/>
-            </a:solidFill>
-            <a:prstDash val="solid"/>
-          </a:ln>
-          <a:effectLst>
-            <a:outerShdw blurRad="76200" dist="38100" dir="5400000" algn="bl" rotWithShape="0">
-              <a:srgbClr val="9AB2B6">
-                <a:alpha val="35000"/>
-              </a:srgbClr>
-            </a:outerShdw>
-          </a:effectLst>
-        </p:spPr>
-        <p:txBody>
-          <a:bodyPr/>
-          <a:lstStyle/>
-          <a:p>
-            <a:endParaRPr lang="fr-RE"/>
-          </a:p>
-        </p:txBody>
-      </p:sp>
-      <p:sp>
-        <p:nvSpPr>
-          <p:cNvPr id="21" name="Shape 12">
-            <a:extLst>
-              <a:ext uri="{FF2B5EF4-FFF2-40B4-BE49-F238E27FC236}">
-                <a16:creationId xmlns:a16="http://schemas.microsoft.com/office/drawing/2014/main" id="{96BE284D-BA90-E34E-96FB-9F6FF63B195D}"/>
-              </a:ext>
-            </a:extLst>
-          </p:cNvPr>
-          <p:cNvSpPr/>
-          <p:nvPr/>
-        </p:nvSpPr>
-        <p:spPr>
-          <a:xfrm>
-            <a:off x="6446520" y="4416552"/>
-            <a:ext cx="146304" cy="146304"/>
-          </a:xfrm>
-          <a:prstGeom prst="ellipse">
-            <a:avLst/>
-          </a:prstGeom>
-          <a:solidFill>
-            <a:srgbClr val="2A6F4E"/>
-          </a:solidFill>
-          <a:ln/>
-        </p:spPr>
-        <p:txBody>
-          <a:bodyPr/>
-          <a:lstStyle/>
-          <a:p>
-            <a:endParaRPr lang="fr-RE"/>
-          </a:p>
-        </p:txBody>
-      </p:sp>
-      <p:sp>
-        <p:nvSpPr>
-          <p:cNvPr id="25" name="Text 13">
-            <a:extLst>
-              <a:ext uri="{FF2B5EF4-FFF2-40B4-BE49-F238E27FC236}">
-                <a16:creationId xmlns:a16="http://schemas.microsoft.com/office/drawing/2014/main" id="{666DBC1C-6457-46D2-122B-518F4541E944}"/>
-              </a:ext>
-            </a:extLst>
-          </p:cNvPr>
-          <p:cNvSpPr/>
-          <p:nvPr/>
-        </p:nvSpPr>
-        <p:spPr>
-          <a:xfrm>
-            <a:off x="6675120" y="4315968"/>
-            <a:ext cx="4754880" cy="384048"/>
-          </a:xfrm>
-          <a:prstGeom prst="rect">
-            <a:avLst/>
-          </a:prstGeom>
-          <a:noFill/>
-          <a:ln/>
-        </p:spPr>
-        <p:txBody>
-          <a:bodyPr wrap="square" lIns="0" tIns="0" rIns="0" bIns="0" rtlCol="0" anchor="ctr"/>
-          <a:lstStyle/>
-          <a:p>
-            <a:pPr marL="0" indent="0" algn="l">
-              <a:buNone/>
-            </a:pPr>
-            <a:r>
-              <a:rPr lang="en-US" sz="1300" b="1" dirty="0">
-                <a:solidFill>
-                  <a:srgbClr val="2B3A42"/>
-                </a:solidFill>
-                <a:latin typeface="Calibri" pitchFamily="34" charset="0"/>
-                <a:ea typeface="Calibri" pitchFamily="34" charset="-122"/>
-                <a:cs typeface="Calibri" pitchFamily="34" charset="-120"/>
-              </a:rPr>
-              <a:t>Commandes </a:t>
-            </a:r>
-            <a:r>
-              <a:rPr lang="en-US" sz="1300" b="1" dirty="0" err="1">
-                <a:solidFill>
-                  <a:srgbClr val="2B3A42"/>
-                </a:solidFill>
-                <a:latin typeface="Calibri" pitchFamily="34" charset="0"/>
-                <a:ea typeface="Calibri" pitchFamily="34" charset="-122"/>
-                <a:cs typeface="Calibri" pitchFamily="34" charset="-120"/>
-              </a:rPr>
-              <a:t>fournisseur</a:t>
-            </a:r>
-            <a:r>
-              <a:rPr lang="en-US" sz="1300" b="1" dirty="0">
-                <a:solidFill>
-                  <a:srgbClr val="2B3A42"/>
-                </a:solidFill>
-                <a:latin typeface="Calibri" pitchFamily="34" charset="0"/>
-                <a:ea typeface="Calibri" pitchFamily="34" charset="-122"/>
-                <a:cs typeface="Calibri" pitchFamily="34" charset="-120"/>
-              </a:rPr>
-              <a:t> </a:t>
-            </a:r>
-            <a:r>
-              <a:rPr lang="en-US" sz="1300" b="1" dirty="0" err="1">
-                <a:solidFill>
-                  <a:srgbClr val="2B3A42"/>
-                </a:solidFill>
-                <a:latin typeface="Calibri" pitchFamily="34" charset="0"/>
-                <a:ea typeface="Calibri" pitchFamily="34" charset="-122"/>
-                <a:cs typeface="Calibri" pitchFamily="34" charset="-120"/>
-              </a:rPr>
-              <a:t>passées</a:t>
-            </a:r>
-            <a:endParaRPr lang="en-US" sz="1300" dirty="0"/>
-          </a:p>
-        </p:txBody>
-      </p:sp>
-      <p:sp>
-        <p:nvSpPr>
-          <p:cNvPr id="29" name="Text 14">
-            <a:extLst>
-              <a:ext uri="{FF2B5EF4-FFF2-40B4-BE49-F238E27FC236}">
-                <a16:creationId xmlns:a16="http://schemas.microsoft.com/office/drawing/2014/main" id="{E18DCD80-8144-26DB-AB6C-4C04E88A088A}"/>
-              </a:ext>
-            </a:extLst>
-          </p:cNvPr>
-          <p:cNvSpPr/>
-          <p:nvPr/>
-        </p:nvSpPr>
-        <p:spPr>
-          <a:xfrm>
-            <a:off x="6446520" y="4754880"/>
-            <a:ext cx="3456432" cy="1517904"/>
-          </a:xfrm>
-          <a:prstGeom prst="rect">
-            <a:avLst/>
-          </a:prstGeom>
-          <a:noFill/>
-          <a:ln/>
-        </p:spPr>
-        <p:txBody>
-          <a:bodyPr wrap="square" lIns="0" tIns="0" rIns="0" bIns="0" rtlCol="0" anchor="ctr"/>
-          <a:lstStyle/>
-          <a:p>
-            <a:pPr marL="0" indent="0" algn="l">
-              <a:buNone/>
-            </a:pPr>
-            <a:endParaRPr lang="en-US" sz="1500" dirty="0"/>
-          </a:p>
-        </p:txBody>
-      </p:sp>
-      <p:sp>
-        <p:nvSpPr>
-          <p:cNvPr id="31" name="Text 14">
-            <a:extLst>
-              <a:ext uri="{FF2B5EF4-FFF2-40B4-BE49-F238E27FC236}">
-                <a16:creationId xmlns:a16="http://schemas.microsoft.com/office/drawing/2014/main" id="{CE7C155D-90A5-4FF3-4412-D4A8F2D05356}"/>
-              </a:ext>
-            </a:extLst>
-          </p:cNvPr>
-          <p:cNvSpPr/>
-          <p:nvPr/>
-        </p:nvSpPr>
-        <p:spPr>
-          <a:xfrm>
-            <a:off x="6435020" y="4723186"/>
-            <a:ext cx="3456432" cy="1517904"/>
-          </a:xfrm>
-          <a:prstGeom prst="rect">
-            <a:avLst/>
-          </a:prstGeom>
-          <a:noFill/>
-          <a:ln/>
-        </p:spPr>
-        <p:txBody>
-          <a:bodyPr wrap="square" lIns="0" tIns="0" rIns="0" bIns="0" rtlCol="0" anchor="ctr"/>
-          <a:lstStyle/>
-          <a:p>
-            <a:pPr marL="0" indent="0" algn="l">
-              <a:buNone/>
-            </a:pPr>
-            <a:r>
-              <a:rPr lang="en-US" sz="1500" i="1" dirty="0">
+              <a:t>Stock / </a:t>
+            </a:r>
+            <a:r>
+              <a:rPr lang="en-US" sz="1050" i="1" dirty="0" err="1">
                 <a:solidFill>
                   <a:srgbClr val="8A9BA3"/>
                 </a:solidFill>
@@ -10202,18 +12476,183 @@
                 <a:ea typeface="Calibri" pitchFamily="34" charset="-122"/>
                 <a:cs typeface="Calibri" pitchFamily="34" charset="-120"/>
               </a:rPr>
-              <a:t>à collecter</a:t>
-            </a:r>
-            <a:endParaRPr lang="en-US" sz="1500" dirty="0"/>
-          </a:p>
-        </p:txBody>
-      </p:sp>
-      <p:sp>
-        <p:nvSpPr>
-          <p:cNvPr id="34" name="Text 17">
+              <a:t>Inventaires</a:t>
+            </a:r>
+            <a:r>
+              <a:rPr lang="en-US" sz="1050" i="1" dirty="0">
+                <a:solidFill>
+                  <a:srgbClr val="8A9BA3"/>
+                </a:solidFill>
+                <a:latin typeface="Calibri" pitchFamily="34" charset="0"/>
+                <a:ea typeface="Calibri" pitchFamily="34" charset="-122"/>
+                <a:cs typeface="Calibri" pitchFamily="34" charset="-120"/>
+              </a:rPr>
+              <a:t> / Depot + Showroom / </a:t>
+            </a:r>
+            <a:r>
+              <a:rPr lang="en-US" sz="1050" i="1" dirty="0" err="1">
+                <a:solidFill>
+                  <a:srgbClr val="8A9BA3"/>
+                </a:solidFill>
+                <a:latin typeface="Calibri" pitchFamily="34" charset="0"/>
+                <a:ea typeface="Calibri" pitchFamily="34" charset="-122"/>
+                <a:cs typeface="Calibri" pitchFamily="34" charset="-120"/>
+              </a:rPr>
+              <a:t>Familles</a:t>
+            </a:r>
+            <a:r>
+              <a:rPr lang="en-US" sz="1050" i="1" dirty="0">
+                <a:solidFill>
+                  <a:srgbClr val="8A9BA3"/>
+                </a:solidFill>
+                <a:latin typeface="Calibri" pitchFamily="34" charset="0"/>
+                <a:ea typeface="Calibri" pitchFamily="34" charset="-122"/>
+                <a:cs typeface="Calibri" pitchFamily="34" charset="-120"/>
+              </a:rPr>
+              <a:t> = </a:t>
+            </a:r>
+            <a:r>
+              <a:rPr lang="en-US" sz="1050" i="1" dirty="0" err="1">
+                <a:solidFill>
+                  <a:srgbClr val="8A9BA3"/>
+                </a:solidFill>
+                <a:latin typeface="Calibri" pitchFamily="34" charset="0"/>
+                <a:ea typeface="Calibri" pitchFamily="34" charset="-122"/>
+                <a:cs typeface="Calibri" pitchFamily="34" charset="-120"/>
+              </a:rPr>
+              <a:t>Accessoires</a:t>
+            </a:r>
+            <a:r>
+              <a:rPr lang="en-US" sz="1050" i="1" dirty="0">
+                <a:solidFill>
+                  <a:srgbClr val="8A9BA3"/>
+                </a:solidFill>
+                <a:latin typeface="Calibri" pitchFamily="34" charset="0"/>
+                <a:ea typeface="Calibri" pitchFamily="34" charset="-122"/>
+                <a:cs typeface="Calibri" pitchFamily="34" charset="-120"/>
+              </a:rPr>
+              <a:t> Manuel + </a:t>
+            </a:r>
+            <a:r>
+              <a:rPr lang="en-US" sz="1050" i="1" dirty="0" err="1">
+                <a:solidFill>
+                  <a:srgbClr val="8A9BA3"/>
+                </a:solidFill>
+                <a:latin typeface="Calibri" pitchFamily="34" charset="0"/>
+                <a:ea typeface="Calibri" pitchFamily="34" charset="-122"/>
+                <a:cs typeface="Calibri" pitchFamily="34" charset="-120"/>
+              </a:rPr>
+              <a:t>Achats</a:t>
+            </a:r>
+            <a:r>
+              <a:rPr lang="en-US" sz="1050" i="1" dirty="0">
+                <a:solidFill>
+                  <a:srgbClr val="8A9BA3"/>
+                </a:solidFill>
+                <a:latin typeface="Calibri" pitchFamily="34" charset="0"/>
+                <a:ea typeface="Calibri" pitchFamily="34" charset="-122"/>
+                <a:cs typeface="Calibri" pitchFamily="34" charset="-120"/>
+              </a:rPr>
+              <a:t> Local + </a:t>
+            </a:r>
+            <a:r>
+              <a:rPr lang="en-US" sz="1050" i="1" dirty="0" err="1">
+                <a:solidFill>
+                  <a:srgbClr val="8A9BA3"/>
+                </a:solidFill>
+                <a:latin typeface="Calibri" pitchFamily="34" charset="0"/>
+                <a:ea typeface="Calibri" pitchFamily="34" charset="-122"/>
+                <a:cs typeface="Calibri" pitchFamily="34" charset="-120"/>
+              </a:rPr>
+              <a:t>Brosserie</a:t>
+            </a:r>
+            <a:r>
+              <a:rPr lang="en-US" sz="1050" i="1" dirty="0">
+                <a:solidFill>
+                  <a:srgbClr val="8A9BA3"/>
+                </a:solidFill>
+                <a:latin typeface="Calibri" pitchFamily="34" charset="0"/>
+                <a:ea typeface="Calibri" pitchFamily="34" charset="-122"/>
+                <a:cs typeface="Calibri" pitchFamily="34" charset="-120"/>
+              </a:rPr>
+              <a:t> + Disque </a:t>
+            </a:r>
+            <a:r>
+              <a:rPr lang="en-US" sz="1050" i="1" dirty="0" err="1">
+                <a:solidFill>
+                  <a:srgbClr val="8A9BA3"/>
+                </a:solidFill>
+                <a:latin typeface="Calibri" pitchFamily="34" charset="0"/>
+                <a:ea typeface="Calibri" pitchFamily="34" charset="-122"/>
+                <a:cs typeface="Calibri" pitchFamily="34" charset="-120"/>
+              </a:rPr>
+              <a:t>d’entretien</a:t>
+            </a:r>
+            <a:r>
+              <a:rPr lang="en-US" sz="1050" i="1" dirty="0">
+                <a:solidFill>
+                  <a:srgbClr val="8A9BA3"/>
+                </a:solidFill>
+                <a:latin typeface="Calibri" pitchFamily="34" charset="0"/>
+                <a:ea typeface="Calibri" pitchFamily="34" charset="-122"/>
+                <a:cs typeface="Calibri" pitchFamily="34" charset="-120"/>
+              </a:rPr>
+              <a:t> + Matériel Manuel + Papier + </a:t>
+            </a:r>
+            <a:r>
+              <a:rPr lang="en-US" sz="1050" i="1" dirty="0" err="1">
+                <a:solidFill>
+                  <a:srgbClr val="8A9BA3"/>
+                </a:solidFill>
+                <a:latin typeface="Calibri" pitchFamily="34" charset="0"/>
+                <a:ea typeface="Calibri" pitchFamily="34" charset="-122"/>
+                <a:cs typeface="Calibri" pitchFamily="34" charset="-120"/>
+              </a:rPr>
+              <a:t>Produits</a:t>
+            </a:r>
+            <a:r>
+              <a:rPr lang="en-US" sz="1050" i="1" dirty="0">
+                <a:solidFill>
+                  <a:srgbClr val="8A9BA3"/>
+                </a:solidFill>
+                <a:latin typeface="Calibri" pitchFamily="34" charset="0"/>
+                <a:ea typeface="Calibri" pitchFamily="34" charset="-122"/>
+                <a:cs typeface="Calibri" pitchFamily="34" charset="-120"/>
+              </a:rPr>
+              <a:t> de </a:t>
+            </a:r>
+            <a:r>
+              <a:rPr lang="en-US" sz="1050" i="1" dirty="0" err="1">
+                <a:solidFill>
+                  <a:srgbClr val="8A9BA3"/>
+                </a:solidFill>
+                <a:latin typeface="Calibri" pitchFamily="34" charset="0"/>
+                <a:ea typeface="Calibri" pitchFamily="34" charset="-122"/>
+                <a:cs typeface="Calibri" pitchFamily="34" charset="-120"/>
+              </a:rPr>
+              <a:t>Nettoyage</a:t>
+            </a:r>
+            <a:r>
+              <a:rPr lang="en-US" sz="1050" i="1" dirty="0">
+                <a:solidFill>
+                  <a:srgbClr val="8A9BA3"/>
+                </a:solidFill>
+                <a:latin typeface="Calibri" pitchFamily="34" charset="0"/>
+                <a:ea typeface="Calibri" pitchFamily="34" charset="-122"/>
+                <a:cs typeface="Calibri" pitchFamily="34" charset="-120"/>
+              </a:rPr>
+              <a:t> </a:t>
+            </a:r>
+            <a:endParaRPr lang="en-US" sz="1050" dirty="0"/>
+          </a:p>
+        </p:txBody>
+      </p:sp>
+      <p:sp>
+        <p:nvSpPr>
+          <p:cNvPr id="29" name="Text 17">
             <a:extLst>
               <a:ext uri="{FF2B5EF4-FFF2-40B4-BE49-F238E27FC236}">
-                <a16:creationId xmlns:a16="http://schemas.microsoft.com/office/drawing/2014/main" id="{59266B79-C43D-98A0-AAC4-CC53BA089B0A}"/>
+                <a16:creationId xmlns:a16="http://schemas.microsoft.com/office/drawing/2014/main" id="{9EAC97E0-FF05-C408-7450-FDF865EBC0C4}"/>
               </a:ext>
             </a:extLst>
           </p:cNvPr>
@@ -10222,8 +12661,8 @@
         </p:nvSpPr>
         <p:spPr>
           <a:xfrm>
-            <a:off x="960120" y="2356392"/>
-            <a:ext cx="1263737" cy="530352"/>
+            <a:off x="1426464" y="4818888"/>
+            <a:ext cx="797394" cy="530352"/>
           </a:xfrm>
           <a:prstGeom prst="rect">
             <a:avLst/>
@@ -10246,8 +12685,184 @@
                 <a:ea typeface="Cambria" pitchFamily="34" charset="-122"/>
                 <a:cs typeface="Cambria" pitchFamily="34" charset="-120"/>
               </a:rPr>
-              <a:t>539 k€</a:t>
-            </a:r>
+              <a:t>213 u</a:t>
+            </a:r>
+          </a:p>
+        </p:txBody>
+      </p:sp>
+      <p:sp>
+        <p:nvSpPr>
+          <p:cNvPr id="32" name="Text 22">
+            <a:extLst>
+              <a:ext uri="{FF2B5EF4-FFF2-40B4-BE49-F238E27FC236}">
+                <a16:creationId xmlns:a16="http://schemas.microsoft.com/office/drawing/2014/main" id="{EE2CB505-9D4F-583F-BD76-EA61FCC54D34}"/>
+              </a:ext>
+            </a:extLst>
+          </p:cNvPr>
+          <p:cNvSpPr/>
+          <p:nvPr/>
+        </p:nvSpPr>
+        <p:spPr>
+          <a:xfrm>
+            <a:off x="2543005" y="4595980"/>
+            <a:ext cx="1177398" cy="557325"/>
+          </a:xfrm>
+          <a:prstGeom prst="rect">
+            <a:avLst/>
+          </a:prstGeom>
+          <a:noFill/>
+          <a:ln/>
+        </p:spPr>
+        <p:txBody>
+          <a:bodyPr wrap="square" lIns="0" tIns="0" rIns="0" bIns="0" rtlCol="0" anchor="ctr">
+            <a:normAutofit/>
+          </a:bodyPr>
+          <a:lstStyle/>
+          <a:p>
+            <a:pPr marL="0" indent="0" algn="l">
+              <a:buNone/>
+            </a:pPr>
+            <a:r>
+              <a:rPr lang="en-US" sz="1200" dirty="0" err="1">
+                <a:solidFill>
+                  <a:srgbClr val="1C7293"/>
+                </a:solidFill>
+                <a:latin typeface="Cambria" pitchFamily="34" charset="0"/>
+                <a:ea typeface="Cambria" pitchFamily="34" charset="-122"/>
+              </a:rPr>
+              <a:t>Dont</a:t>
+            </a:r>
+            <a:r>
+              <a:rPr lang="en-US" sz="1200" dirty="0">
+                <a:solidFill>
+                  <a:srgbClr val="1C7293"/>
+                </a:solidFill>
+                <a:latin typeface="Cambria" pitchFamily="34" charset="0"/>
+                <a:ea typeface="Cambria" pitchFamily="34" charset="-122"/>
+              </a:rPr>
+              <a:t> Ventes 2026</a:t>
+            </a:r>
+          </a:p>
+          <a:p>
+            <a:pPr marL="0" indent="0" algn="l">
+              <a:buNone/>
+            </a:pPr>
+            <a:r>
+              <a:rPr lang="en-US" sz="1200" dirty="0">
+                <a:solidFill>
+                  <a:srgbClr val="1C7293"/>
+                </a:solidFill>
+                <a:latin typeface="Cambria" pitchFamily="34" charset="0"/>
+                <a:ea typeface="Cambria" pitchFamily="34" charset="-122"/>
+              </a:rPr>
+              <a:t>31%</a:t>
+            </a:r>
+            <a:endParaRPr lang="en-US" sz="1200" dirty="0"/>
+          </a:p>
+        </p:txBody>
+      </p:sp>
+      <p:sp>
+        <p:nvSpPr>
+          <p:cNvPr id="35" name="Text 22">
+            <a:extLst>
+              <a:ext uri="{FF2B5EF4-FFF2-40B4-BE49-F238E27FC236}">
+                <a16:creationId xmlns:a16="http://schemas.microsoft.com/office/drawing/2014/main" id="{27916381-A7C4-CF0B-56C7-DFD9A508FB82}"/>
+              </a:ext>
+            </a:extLst>
+          </p:cNvPr>
+          <p:cNvSpPr/>
+          <p:nvPr/>
+        </p:nvSpPr>
+        <p:spPr>
+          <a:xfrm>
+            <a:off x="2543004" y="5180047"/>
+            <a:ext cx="1485532" cy="557325"/>
+          </a:xfrm>
+          <a:prstGeom prst="rect">
+            <a:avLst/>
+          </a:prstGeom>
+          <a:noFill/>
+          <a:ln/>
+        </p:spPr>
+        <p:txBody>
+          <a:bodyPr wrap="square" lIns="0" tIns="0" rIns="0" bIns="0" rtlCol="0" anchor="ctr">
+            <a:normAutofit/>
+          </a:bodyPr>
+          <a:lstStyle/>
+          <a:p>
+            <a:pPr marL="0" indent="0" algn="l">
+              <a:buNone/>
+            </a:pPr>
+            <a:r>
+              <a:rPr lang="en-US" sz="1200" dirty="0" err="1">
+                <a:solidFill>
+                  <a:srgbClr val="1C7293"/>
+                </a:solidFill>
+                <a:latin typeface="Cambria" pitchFamily="34" charset="0"/>
+                <a:ea typeface="Cambria" pitchFamily="34" charset="-122"/>
+              </a:rPr>
+              <a:t>Dont</a:t>
+            </a:r>
+            <a:r>
+              <a:rPr lang="en-US" sz="1200" dirty="0">
+                <a:solidFill>
+                  <a:srgbClr val="1C7293"/>
+                </a:solidFill>
+                <a:latin typeface="Cambria" pitchFamily="34" charset="0"/>
+                <a:ea typeface="Cambria" pitchFamily="34" charset="-122"/>
+              </a:rPr>
+              <a:t> </a:t>
+            </a:r>
+            <a:r>
+              <a:rPr lang="en-US" sz="1200" dirty="0" err="1">
+                <a:solidFill>
+                  <a:srgbClr val="1C7293"/>
+                </a:solidFill>
+                <a:latin typeface="Cambria" pitchFamily="34" charset="0"/>
+                <a:ea typeface="Cambria" pitchFamily="34" charset="-122"/>
+              </a:rPr>
+              <a:t>dispo</a:t>
+            </a:r>
+            <a:r>
+              <a:rPr lang="en-US" sz="1200" dirty="0">
+                <a:solidFill>
+                  <a:srgbClr val="1C7293"/>
+                </a:solidFill>
+                <a:latin typeface="Cambria" pitchFamily="34" charset="0"/>
+                <a:ea typeface="Cambria" pitchFamily="34" charset="-122"/>
+              </a:rPr>
+              <a:t> = </a:t>
+            </a:r>
+            <a:r>
+              <a:rPr lang="en-US" sz="1200" dirty="0" err="1">
+                <a:solidFill>
+                  <a:srgbClr val="1C7293"/>
+                </a:solidFill>
+                <a:latin typeface="Cambria" pitchFamily="34" charset="0"/>
+                <a:ea typeface="Cambria" pitchFamily="34" charset="-122"/>
+              </a:rPr>
+              <a:t>stockée</a:t>
+            </a:r>
+            <a:br>
+              <a:rPr lang="en-US" sz="1200" dirty="0">
+                <a:solidFill>
+                  <a:srgbClr val="1C7293"/>
+                </a:solidFill>
+                <a:latin typeface="Cambria" pitchFamily="34" charset="0"/>
+                <a:ea typeface="Cambria" pitchFamily="34" charset="-122"/>
+              </a:rPr>
+            </a:br>
+            <a:r>
+              <a:rPr lang="en-US" sz="1200" dirty="0">
+                <a:solidFill>
+                  <a:srgbClr val="1C7293"/>
+                </a:solidFill>
+                <a:latin typeface="Cambria" pitchFamily="34" charset="0"/>
+                <a:ea typeface="Cambria" pitchFamily="34" charset="-122"/>
+              </a:rPr>
+              <a:t>70%</a:t>
+            </a:r>
+            <a:endParaRPr lang="en-US" sz="1200" dirty="0"/>
           </a:p>
         </p:txBody>
       </p:sp>

</xml_diff>

<commit_message>
Fix EBC/SAV swap bug, wire Productivite Mois-1, color-code productivite row, wire clients distincts Mois-1
Bug fix: the EBC/SAV delta shapes in the SAV template are positioned in
reverse shape-id order (the lower id is SAV's box, not EBC's). This was
silently swapped in Main d'oeuvre N-1, Deplacement N-1, and Nombre
d'interventions Mois-1 since they were first built - caught by cross-
checking shape positions after adding the new Productivite Mois-1 block,
which uses the same layout pattern. Fixed all four.

New: Productivite row in the SAV table is now green (>=50%) / red (<50%).
Productivite gets its own Mois-1 evolution block (new shapes in the
template), read from the previous month's deck like Nb interventions.
Livraison & Compta's "clients distincts" (factures >=60j) now reads its
Mois-1 from the previous deck instead of always showing n/a.

Co-Authored-By: Claude Sonnet 5 <noreply@anthropic.com>
</commit_message>
<xml_diff>
--- a/templates/KPI_SAV_Achat.pptx
+++ b/templates/KPI_SAV_Achat.pptx
@@ -8859,6 +8859,576 @@
           </a:p>
         </p:txBody>
       </p:sp>
+      <p:sp>
+        <p:nvSpPr>
+          <p:cNvPr id="36" name="Shape 4">
+            <a:extLst>
+              <a:ext uri="{FF2B5EF4-FFF2-40B4-BE49-F238E27FC236}">
+                <a16:creationId xmlns:a16="http://schemas.microsoft.com/office/drawing/2014/main" id="{4D40D798-9668-8433-5115-3FDE6E1AC8B3}"/>
+              </a:ext>
+            </a:extLst>
+          </p:cNvPr>
+          <p:cNvSpPr/>
+          <p:nvPr/>
+        </p:nvSpPr>
+        <p:spPr>
+          <a:xfrm>
+            <a:off x="8105224" y="4323760"/>
+            <a:ext cx="3200299" cy="1473898"/>
+          </a:xfrm>
+          <a:prstGeom prst="roundRect">
+            <a:avLst>
+              <a:gd name="adj" fmla="val 3200"/>
+            </a:avLst>
+          </a:prstGeom>
+          <a:solidFill>
+            <a:srgbClr val="F2F7F8"/>
+          </a:solidFill>
+          <a:ln w="12700">
+            <a:solidFill>
+              <a:srgbClr val="DCE7E9"/>
+            </a:solidFill>
+            <a:prstDash val="solid"/>
+          </a:ln>
+          <a:effectLst>
+            <a:outerShdw blurRad="76200" dist="38100" dir="5400000" algn="bl" rotWithShape="0">
+              <a:srgbClr val="9AB2B6">
+                <a:alpha val="35000"/>
+              </a:srgbClr>
+            </a:outerShdw>
+          </a:effectLst>
+        </p:spPr>
+        <p:txBody>
+          <a:bodyPr/>
+          <a:lstStyle/>
+          <a:p>
+            <a:endParaRPr lang="fr-RE"/>
+          </a:p>
+        </p:txBody>
+      </p:sp>
+      <p:sp>
+        <p:nvSpPr>
+          <p:cNvPr id="37" name="Shape 5">
+            <a:extLst>
+              <a:ext uri="{FF2B5EF4-FFF2-40B4-BE49-F238E27FC236}">
+                <a16:creationId xmlns:a16="http://schemas.microsoft.com/office/drawing/2014/main" id="{E8CF90BA-6D88-AF7C-0D85-34ED94EB5129}"/>
+              </a:ext>
+            </a:extLst>
+          </p:cNvPr>
+          <p:cNvSpPr/>
+          <p:nvPr/>
+        </p:nvSpPr>
+        <p:spPr>
+          <a:xfrm>
+            <a:off x="8183574" y="4488150"/>
+            <a:ext cx="146304" cy="146304"/>
+          </a:xfrm>
+          <a:prstGeom prst="ellipse">
+            <a:avLst/>
+          </a:prstGeom>
+          <a:solidFill>
+            <a:srgbClr val="C1666B"/>
+          </a:solidFill>
+          <a:ln/>
+        </p:spPr>
+        <p:txBody>
+          <a:bodyPr/>
+          <a:lstStyle/>
+          <a:p>
+            <a:endParaRPr lang="fr-RE"/>
+          </a:p>
+        </p:txBody>
+      </p:sp>
+      <p:sp>
+        <p:nvSpPr>
+          <p:cNvPr id="38" name="Text 6">
+            <a:extLst>
+              <a:ext uri="{FF2B5EF4-FFF2-40B4-BE49-F238E27FC236}">
+                <a16:creationId xmlns:a16="http://schemas.microsoft.com/office/drawing/2014/main" id="{D1B7A1D1-3494-8147-21D7-6D2C08A38413}"/>
+              </a:ext>
+            </a:extLst>
+          </p:cNvPr>
+          <p:cNvSpPr/>
+          <p:nvPr/>
+        </p:nvSpPr>
+        <p:spPr>
+          <a:xfrm>
+            <a:off x="8412174" y="4369278"/>
+            <a:ext cx="2090804" cy="384048"/>
+          </a:xfrm>
+          <a:prstGeom prst="rect">
+            <a:avLst/>
+          </a:prstGeom>
+          <a:noFill/>
+          <a:ln/>
+        </p:spPr>
+        <p:txBody>
+          <a:bodyPr wrap="square" lIns="0" tIns="0" rIns="0" bIns="0" rtlCol="0" anchor="ctr"/>
+          <a:lstStyle/>
+          <a:p>
+            <a:pPr marL="0" indent="0" algn="l">
+              <a:buNone/>
+            </a:pPr>
+            <a:r>
+              <a:rPr lang="en-US" sz="1300" b="1" dirty="0" err="1">
+                <a:solidFill>
+                  <a:srgbClr val="2B3A42"/>
+                </a:solidFill>
+                <a:latin typeface="Calibri" pitchFamily="34" charset="0"/>
+                <a:ea typeface="Calibri" pitchFamily="34" charset="-122"/>
+                <a:cs typeface="Calibri" pitchFamily="34" charset="-120"/>
+              </a:rPr>
+              <a:t>Productivité</a:t>
+            </a:r>
+            <a:r>
+              <a:rPr lang="en-US" sz="1300" b="1" dirty="0">
+                <a:solidFill>
+                  <a:srgbClr val="2B3A42"/>
+                </a:solidFill>
+                <a:latin typeface="Calibri" pitchFamily="34" charset="0"/>
+                <a:ea typeface="Calibri" pitchFamily="34" charset="-122"/>
+                <a:cs typeface="Calibri" pitchFamily="34" charset="-120"/>
+              </a:rPr>
+              <a:t> (fiches inter)</a:t>
+            </a:r>
+            <a:endParaRPr lang="en-US" sz="1300" dirty="0"/>
+          </a:p>
+        </p:txBody>
+      </p:sp>
+      <p:grpSp>
+        <p:nvGrpSpPr>
+          <p:cNvPr id="39" name="Groupe 38">
+            <a:extLst>
+              <a:ext uri="{FF2B5EF4-FFF2-40B4-BE49-F238E27FC236}">
+                <a16:creationId xmlns:a16="http://schemas.microsoft.com/office/drawing/2014/main" id="{2372B9B6-726B-1EF3-A941-A65355E52248}"/>
+              </a:ext>
+            </a:extLst>
+          </p:cNvPr>
+          <p:cNvGrpSpPr/>
+          <p:nvPr/>
+        </p:nvGrpSpPr>
+        <p:grpSpPr>
+          <a:xfrm>
+            <a:off x="8300374" y="5086892"/>
+            <a:ext cx="920142" cy="544328"/>
+            <a:chOff x="2548416" y="5497637"/>
+            <a:chExt cx="920142" cy="544328"/>
+          </a:xfrm>
+        </p:grpSpPr>
+        <p:sp>
+          <p:nvSpPr>
+            <p:cNvPr id="40" name="Shape 8">
+              <a:extLst>
+                <a:ext uri="{FF2B5EF4-FFF2-40B4-BE49-F238E27FC236}">
+                  <a16:creationId xmlns:a16="http://schemas.microsoft.com/office/drawing/2014/main" id="{09BA2BE4-3991-5055-BA94-F0921E9178D7}"/>
+                </a:ext>
+              </a:extLst>
+            </p:cNvPr>
+            <p:cNvSpPr/>
+            <p:nvPr/>
+          </p:nvSpPr>
+          <p:spPr>
+            <a:xfrm>
+              <a:off x="2555258" y="5529901"/>
+              <a:ext cx="913300" cy="512064"/>
+            </a:xfrm>
+            <a:prstGeom prst="roundRect">
+              <a:avLst>
+                <a:gd name="adj" fmla="val 8929"/>
+              </a:avLst>
+            </a:prstGeom>
+            <a:solidFill>
+              <a:srgbClr val="FFFFFF"/>
+            </a:solidFill>
+            <a:ln w="12700">
+              <a:solidFill>
+                <a:srgbClr val="DCE7E9"/>
+              </a:solidFill>
+              <a:prstDash val="solid"/>
+            </a:ln>
+          </p:spPr>
+          <p:txBody>
+            <a:bodyPr/>
+            <a:lstStyle/>
+            <a:p>
+              <a:endParaRPr lang="fr-RE" sz="2400"/>
+            </a:p>
+          </p:txBody>
+        </p:sp>
+        <p:sp>
+          <p:nvSpPr>
+            <p:cNvPr id="41" name="Text 9">
+              <a:extLst>
+                <a:ext uri="{FF2B5EF4-FFF2-40B4-BE49-F238E27FC236}">
+                  <a16:creationId xmlns:a16="http://schemas.microsoft.com/office/drawing/2014/main" id="{D20D2FD3-A6CE-D7C1-B8B3-D4CD8129EB8D}"/>
+                </a:ext>
+              </a:extLst>
+            </p:cNvPr>
+            <p:cNvSpPr/>
+            <p:nvPr/>
+          </p:nvSpPr>
+          <p:spPr>
+            <a:xfrm>
+              <a:off x="2548416" y="5497637"/>
+              <a:ext cx="887253" cy="512064"/>
+            </a:xfrm>
+            <a:prstGeom prst="rect">
+              <a:avLst/>
+            </a:prstGeom>
+            <a:noFill/>
+            <a:ln/>
+          </p:spPr>
+          <p:txBody>
+            <a:bodyPr wrap="square" lIns="0" tIns="0" rIns="0" bIns="0" rtlCol="0" anchor="ctr"/>
+            <a:lstStyle/>
+            <a:p>
+              <a:pPr algn="ctr"/>
+              <a:r>
+                <a:rPr lang="en-US" sz="1050" i="1" dirty="0" err="1">
+                  <a:solidFill>
+                    <a:srgbClr val="8A9BA3"/>
+                  </a:solidFill>
+                  <a:latin typeface="Calibri" pitchFamily="34" charset="0"/>
+                  <a:ea typeface="Calibri" pitchFamily="34" charset="-122"/>
+                  <a:cs typeface="Calibri" pitchFamily="34" charset="-120"/>
+                </a:rPr>
+                <a:t>Mois</a:t>
+              </a:r>
+              <a:r>
+                <a:rPr lang="en-US" sz="1050" i="1" dirty="0">
+                  <a:solidFill>
+                    <a:srgbClr val="8A9BA3"/>
+                  </a:solidFill>
+                  <a:latin typeface="Calibri" pitchFamily="34" charset="0"/>
+                  <a:ea typeface="Calibri" pitchFamily="34" charset="-122"/>
+                  <a:cs typeface="Calibri" pitchFamily="34" charset="-120"/>
+                </a:rPr>
+                <a:t> -1 :</a:t>
+              </a:r>
+              <a:br>
+                <a:rPr lang="en-US" sz="1050" i="1" dirty="0">
+                  <a:solidFill>
+                    <a:srgbClr val="8A9BA3"/>
+                  </a:solidFill>
+                  <a:latin typeface="Calibri" pitchFamily="34" charset="0"/>
+                  <a:ea typeface="Calibri" pitchFamily="34" charset="-122"/>
+                  <a:cs typeface="Calibri" pitchFamily="34" charset="-120"/>
+                </a:rPr>
+              </a:br>
+              <a:endParaRPr lang="en-US" sz="1600" dirty="0"/>
+            </a:p>
+          </p:txBody>
+        </p:sp>
+      </p:grpSp>
+      <p:sp>
+        <p:nvSpPr>
+          <p:cNvPr id="42" name="Text 17">
+            <a:extLst>
+              <a:ext uri="{FF2B5EF4-FFF2-40B4-BE49-F238E27FC236}">
+                <a16:creationId xmlns:a16="http://schemas.microsoft.com/office/drawing/2014/main" id="{F3400FE5-3AB0-1F92-9D40-E22D53332BFA}"/>
+              </a:ext>
+            </a:extLst>
+          </p:cNvPr>
+          <p:cNvSpPr/>
+          <p:nvPr/>
+        </p:nvSpPr>
+        <p:spPr>
+          <a:xfrm>
+            <a:off x="8470705" y="4651216"/>
+            <a:ext cx="1030529" cy="530352"/>
+          </a:xfrm>
+          <a:prstGeom prst="rect">
+            <a:avLst/>
+          </a:prstGeom>
+          <a:noFill/>
+          <a:ln/>
+        </p:spPr>
+        <p:txBody>
+          <a:bodyPr wrap="square" lIns="0" tIns="0" rIns="0" bIns="0" rtlCol="0" anchor="ctr">
+            <a:normAutofit/>
+          </a:bodyPr>
+          <a:lstStyle/>
+          <a:p>
+            <a:pPr marL="0" indent="0" algn="l">
+              <a:buNone/>
+            </a:pPr>
+            <a:r>
+              <a:rPr lang="en-US" sz="2400" b="1" dirty="0">
+                <a:solidFill>
+                  <a:srgbClr val="0E7C86"/>
+                </a:solidFill>
+              </a:rPr>
+              <a:t>41 %</a:t>
+            </a:r>
+          </a:p>
+        </p:txBody>
+      </p:sp>
+      <p:grpSp>
+        <p:nvGrpSpPr>
+          <p:cNvPr id="43" name="Groupe 42">
+            <a:extLst>
+              <a:ext uri="{FF2B5EF4-FFF2-40B4-BE49-F238E27FC236}">
+                <a16:creationId xmlns:a16="http://schemas.microsoft.com/office/drawing/2014/main" id="{EF724247-1C4A-9B80-C0C0-C51E47FF985B}"/>
+              </a:ext>
+            </a:extLst>
+          </p:cNvPr>
+          <p:cNvGrpSpPr/>
+          <p:nvPr/>
+        </p:nvGrpSpPr>
+        <p:grpSpPr>
+          <a:xfrm>
+            <a:off x="9461872" y="4709941"/>
+            <a:ext cx="1738184" cy="1001040"/>
+            <a:chOff x="5216308" y="1993366"/>
+            <a:chExt cx="1738184" cy="1001040"/>
+          </a:xfrm>
+        </p:grpSpPr>
+        <p:sp>
+          <p:nvSpPr>
+            <p:cNvPr id="44" name="Shape 23">
+              <a:extLst>
+                <a:ext uri="{FF2B5EF4-FFF2-40B4-BE49-F238E27FC236}">
+                  <a16:creationId xmlns:a16="http://schemas.microsoft.com/office/drawing/2014/main" id="{89A1BCF0-72D6-F354-641F-A83A88CA1A2E}"/>
+                </a:ext>
+              </a:extLst>
+            </p:cNvPr>
+            <p:cNvSpPr/>
+            <p:nvPr/>
+          </p:nvSpPr>
+          <p:spPr>
+            <a:xfrm>
+              <a:off x="5216308" y="1993366"/>
+              <a:ext cx="1738184" cy="889075"/>
+            </a:xfrm>
+            <a:prstGeom prst="roundRect">
+              <a:avLst>
+                <a:gd name="adj" fmla="val 8929"/>
+              </a:avLst>
+            </a:prstGeom>
+            <a:solidFill>
+              <a:srgbClr val="FFFFFF"/>
+            </a:solidFill>
+            <a:ln w="12700">
+              <a:solidFill>
+                <a:srgbClr val="DCE7E9"/>
+              </a:solidFill>
+              <a:prstDash val="solid"/>
+            </a:ln>
+          </p:spPr>
+          <p:txBody>
+            <a:bodyPr/>
+            <a:lstStyle/>
+            <a:p>
+              <a:endParaRPr lang="fr-RE" sz="2800"/>
+            </a:p>
+          </p:txBody>
+        </p:sp>
+        <p:grpSp>
+          <p:nvGrpSpPr>
+            <p:cNvPr id="45" name="Groupe 44">
+              <a:extLst>
+                <a:ext uri="{FF2B5EF4-FFF2-40B4-BE49-F238E27FC236}">
+                  <a16:creationId xmlns:a16="http://schemas.microsoft.com/office/drawing/2014/main" id="{34B827B4-7CF5-FE8A-892F-2AEE3D8D95B4}"/>
+                </a:ext>
+              </a:extLst>
+            </p:cNvPr>
+            <p:cNvGrpSpPr/>
+            <p:nvPr/>
+          </p:nvGrpSpPr>
+          <p:grpSpPr>
+            <a:xfrm>
+              <a:off x="5250138" y="1993366"/>
+              <a:ext cx="1614152" cy="1001040"/>
+              <a:chOff x="5250138" y="1993366"/>
+              <a:chExt cx="1614152" cy="1001040"/>
+            </a:xfrm>
+          </p:grpSpPr>
+          <p:sp>
+            <p:nvSpPr>
+              <p:cNvPr id="47" name="Text 24">
+                <a:extLst>
+                  <a:ext uri="{FF2B5EF4-FFF2-40B4-BE49-F238E27FC236}">
+                    <a16:creationId xmlns:a16="http://schemas.microsoft.com/office/drawing/2014/main" id="{002DACB8-3760-A058-FBA5-AEF466340D4C}"/>
+                  </a:ext>
+                </a:extLst>
+              </p:cNvPr>
+              <p:cNvSpPr/>
+              <p:nvPr/>
+            </p:nvSpPr>
+            <p:spPr>
+              <a:xfrm>
+                <a:off x="6010199" y="2392045"/>
+                <a:ext cx="854091" cy="602361"/>
+              </a:xfrm>
+              <a:prstGeom prst="rect">
+                <a:avLst/>
+              </a:prstGeom>
+              <a:noFill/>
+              <a:ln/>
+            </p:spPr>
+            <p:txBody>
+              <a:bodyPr wrap="square" lIns="0" tIns="0" rIns="0" bIns="0" rtlCol="0" anchor="t"/>
+              <a:lstStyle/>
+              <a:p>
+                <a:pPr marL="0" indent="0" algn="ctr">
+                  <a:lnSpc>
+                    <a:spcPct val="95000"/>
+                  </a:lnSpc>
+                  <a:buNone/>
+                </a:pPr>
+                <a:r>
+                  <a:rPr lang="en-US" sz="1050" dirty="0">
+                    <a:solidFill>
+                      <a:srgbClr val="8A9BA3"/>
+                    </a:solidFill>
+                  </a:rPr>
+                  <a:t>Mois-1 :</a:t>
+                </a:r>
+                <a:endParaRPr lang="en-US" sz="1050" dirty="0"/>
+              </a:p>
+            </p:txBody>
+          </p:sp>
+          <p:sp>
+            <p:nvSpPr>
+              <p:cNvPr id="52" name="Text 22">
+                <a:extLst>
+                  <a:ext uri="{FF2B5EF4-FFF2-40B4-BE49-F238E27FC236}">
+                    <a16:creationId xmlns:a16="http://schemas.microsoft.com/office/drawing/2014/main" id="{E0D09A5F-0BB8-6C53-423A-C4AF0C2178C9}"/>
+                  </a:ext>
+                </a:extLst>
+              </p:cNvPr>
+              <p:cNvSpPr/>
+              <p:nvPr/>
+            </p:nvSpPr>
+            <p:spPr>
+              <a:xfrm>
+                <a:off x="5281902" y="2014106"/>
+                <a:ext cx="880623" cy="557325"/>
+              </a:xfrm>
+              <a:prstGeom prst="rect">
+                <a:avLst/>
+              </a:prstGeom>
+              <a:noFill/>
+              <a:ln/>
+            </p:spPr>
+            <p:txBody>
+              <a:bodyPr wrap="square" lIns="0" tIns="0" rIns="0" bIns="0" rtlCol="0" anchor="ctr">
+                <a:normAutofit/>
+              </a:bodyPr>
+              <a:lstStyle/>
+              <a:p>
+                <a:pPr marL="0" indent="0" algn="l">
+                  <a:buNone/>
+                </a:pPr>
+                <a:r>
+                  <a:rPr lang="en-US" sz="1400" b="1" dirty="0">
+                    <a:solidFill>
+                      <a:srgbClr val="1C7293"/>
+                    </a:solidFill>
+                    <a:latin typeface="Cambria" pitchFamily="34" charset="0"/>
+                    <a:ea typeface="Cambria" pitchFamily="34" charset="-122"/>
+                    <a:cs typeface="Cambria" pitchFamily="34" charset="-120"/>
+                  </a:rPr>
+                  <a:t>53% EBC</a:t>
+                </a:r>
+                <a:endParaRPr lang="en-US" sz="1400" dirty="0"/>
+              </a:p>
+            </p:txBody>
+          </p:sp>
+          <p:sp>
+            <p:nvSpPr>
+              <p:cNvPr id="56" name="Text 22">
+                <a:extLst>
+                  <a:ext uri="{FF2B5EF4-FFF2-40B4-BE49-F238E27FC236}">
+                    <a16:creationId xmlns:a16="http://schemas.microsoft.com/office/drawing/2014/main" id="{F6CB40C5-5677-3930-2ED0-A3EE8C20E311}"/>
+                  </a:ext>
+                </a:extLst>
+              </p:cNvPr>
+              <p:cNvSpPr/>
+              <p:nvPr/>
+            </p:nvSpPr>
+            <p:spPr>
+              <a:xfrm>
+                <a:off x="5250138" y="2387513"/>
+                <a:ext cx="863659" cy="557325"/>
+              </a:xfrm>
+              <a:prstGeom prst="rect">
+                <a:avLst/>
+              </a:prstGeom>
+              <a:noFill/>
+              <a:ln/>
+            </p:spPr>
+            <p:txBody>
+              <a:bodyPr wrap="square" lIns="0" tIns="0" rIns="0" bIns="0" rtlCol="0" anchor="ctr">
+                <a:normAutofit/>
+              </a:bodyPr>
+              <a:lstStyle/>
+              <a:p>
+                <a:pPr marL="0" indent="0" algn="l">
+                  <a:buNone/>
+                </a:pPr>
+                <a:r>
+                  <a:rPr lang="en-US" sz="1400" b="1" dirty="0">
+                    <a:solidFill>
+                      <a:srgbClr val="1C7293"/>
+                    </a:solidFill>
+                    <a:latin typeface="Cambria" pitchFamily="34" charset="0"/>
+                    <a:ea typeface="Cambria" pitchFamily="34" charset="-122"/>
+                    <a:cs typeface="Cambria" pitchFamily="34" charset="-120"/>
+                  </a:rPr>
+                  <a:t>28% SAV</a:t>
+                </a:r>
+                <a:endParaRPr lang="en-US" sz="1400" dirty="0"/>
+              </a:p>
+            </p:txBody>
+          </p:sp>
+          <p:sp>
+            <p:nvSpPr>
+              <p:cNvPr id="58" name="Text 24">
+                <a:extLst>
+                  <a:ext uri="{FF2B5EF4-FFF2-40B4-BE49-F238E27FC236}">
+                    <a16:creationId xmlns:a16="http://schemas.microsoft.com/office/drawing/2014/main" id="{AC252112-0F0D-D648-7247-C6C922B67BBE}"/>
+                  </a:ext>
+                </a:extLst>
+              </p:cNvPr>
+              <p:cNvSpPr/>
+              <p:nvPr/>
+            </p:nvSpPr>
+            <p:spPr>
+              <a:xfrm>
+                <a:off x="5999622" y="1993366"/>
+                <a:ext cx="854091" cy="602361"/>
+              </a:xfrm>
+              <a:prstGeom prst="rect">
+                <a:avLst/>
+              </a:prstGeom>
+              <a:noFill/>
+              <a:ln/>
+            </p:spPr>
+            <p:txBody>
+              <a:bodyPr wrap="square" lIns="0" tIns="0" rIns="0" bIns="0" rtlCol="0" anchor="t"/>
+              <a:lstStyle/>
+              <a:p>
+                <a:pPr marL="0" indent="0" algn="ctr">
+                  <a:lnSpc>
+                    <a:spcPct val="95000"/>
+                  </a:lnSpc>
+                  <a:buNone/>
+                </a:pPr>
+                <a:r>
+                  <a:rPr lang="en-US" sz="1050" dirty="0">
+                    <a:solidFill>
+                      <a:srgbClr val="8A9BA3"/>
+                    </a:solidFill>
+                  </a:rPr>
+                  <a:t>Mois-1 :</a:t>
+                </a:r>
+                <a:endParaRPr lang="en-US" sz="1050" dirty="0"/>
+              </a:p>
+            </p:txBody>
+          </p:sp>
+        </p:grpSp>
+      </p:grpSp>
     </p:spTree>
   </p:cSld>
   <p:clrMapOvr>
@@ -9223,8 +9793,8 @@
         </p:nvSpPr>
         <p:spPr>
           <a:xfrm>
-            <a:off x="4297680" y="2505456"/>
-            <a:ext cx="1371600" cy="512064"/>
+            <a:off x="4028536" y="2356392"/>
+            <a:ext cx="1640744" cy="661128"/>
           </a:xfrm>
           <a:prstGeom prst="roundRect">
             <a:avLst>
@@ -9257,8 +9827,8 @@
         </p:nvSpPr>
         <p:spPr>
           <a:xfrm>
-            <a:off x="4297680" y="2505456"/>
-            <a:ext cx="1371600" cy="512064"/>
+            <a:off x="4105656" y="2505456"/>
+            <a:ext cx="1563624" cy="512064"/>
           </a:xfrm>
           <a:prstGeom prst="rect">
             <a:avLst/>
@@ -9267,7 +9837,7 @@
           <a:ln/>
         </p:spPr>
         <p:txBody>
-          <a:bodyPr wrap="square" lIns="0" tIns="0" rIns="0" bIns="0" rtlCol="0" anchor="ctr"/>
+          <a:bodyPr wrap="square" lIns="0" tIns="0" rIns="0" bIns="0" rtlCol="0" anchor="t"/>
           <a:lstStyle/>
           <a:p>
             <a:pPr marL="0" indent="0" algn="ctr">
@@ -12320,112 +12890,6 @@
           </a:p>
         </p:txBody>
       </p:sp>
-      <p:grpSp>
-        <p:nvGrpSpPr>
-          <p:cNvPr id="30" name="Groupe 29">
-            <a:extLst>
-              <a:ext uri="{FF2B5EF4-FFF2-40B4-BE49-F238E27FC236}">
-                <a16:creationId xmlns:a16="http://schemas.microsoft.com/office/drawing/2014/main" id="{BA528B8C-27C3-9DA5-9ABA-6A4033058951}"/>
-              </a:ext>
-            </a:extLst>
-          </p:cNvPr>
-          <p:cNvGrpSpPr/>
-          <p:nvPr/>
-        </p:nvGrpSpPr>
-        <p:grpSpPr>
-          <a:xfrm>
-            <a:off x="4617656" y="4902966"/>
-            <a:ext cx="662509" cy="512064"/>
-            <a:chOff x="4297680" y="5056632"/>
-            <a:chExt cx="662509" cy="512064"/>
-          </a:xfrm>
-        </p:grpSpPr>
-        <p:sp>
-          <p:nvSpPr>
-            <p:cNvPr id="22" name="Shape 8">
-              <a:extLst>
-                <a:ext uri="{FF2B5EF4-FFF2-40B4-BE49-F238E27FC236}">
-                  <a16:creationId xmlns:a16="http://schemas.microsoft.com/office/drawing/2014/main" id="{359A9F30-EE5D-2466-EB81-9FC1462DA7EA}"/>
-                </a:ext>
-              </a:extLst>
-            </p:cNvPr>
-            <p:cNvSpPr/>
-            <p:nvPr/>
-          </p:nvSpPr>
-          <p:spPr>
-            <a:xfrm>
-              <a:off x="4297680" y="5056632"/>
-              <a:ext cx="662509" cy="512064"/>
-            </a:xfrm>
-            <a:prstGeom prst="roundRect">
-              <a:avLst>
-                <a:gd name="adj" fmla="val 8929"/>
-              </a:avLst>
-            </a:prstGeom>
-            <a:solidFill>
-              <a:srgbClr val="FFFFFF"/>
-            </a:solidFill>
-            <a:ln w="12700">
-              <a:solidFill>
-                <a:srgbClr val="DCE7E9"/>
-              </a:solidFill>
-              <a:prstDash val="solid"/>
-            </a:ln>
-          </p:spPr>
-          <p:txBody>
-            <a:bodyPr/>
-            <a:lstStyle/>
-            <a:p>
-              <a:endParaRPr lang="fr-RE"/>
-            </a:p>
-          </p:txBody>
-        </p:sp>
-        <p:sp>
-          <p:nvSpPr>
-            <p:cNvPr id="24" name="Text 9">
-              <a:extLst>
-                <a:ext uri="{FF2B5EF4-FFF2-40B4-BE49-F238E27FC236}">
-                  <a16:creationId xmlns:a16="http://schemas.microsoft.com/office/drawing/2014/main" id="{7DEB943D-6F47-EA30-ADBE-69522B08D108}"/>
-                </a:ext>
-              </a:extLst>
-            </p:cNvPr>
-            <p:cNvSpPr/>
-            <p:nvPr/>
-          </p:nvSpPr>
-          <p:spPr>
-            <a:xfrm>
-              <a:off x="4297680" y="5099073"/>
-              <a:ext cx="662509" cy="219456"/>
-            </a:xfrm>
-            <a:prstGeom prst="rect">
-              <a:avLst/>
-            </a:prstGeom>
-            <a:noFill/>
-            <a:ln/>
-          </p:spPr>
-          <p:txBody>
-            <a:bodyPr wrap="square" lIns="0" tIns="0" rIns="0" bIns="0" rtlCol="0" anchor="ctr"/>
-            <a:lstStyle/>
-            <a:p>
-              <a:pPr marL="0" indent="0" algn="ctr">
-                <a:buNone/>
-              </a:pPr>
-              <a:r>
-                <a:rPr lang="en-US" sz="950" i="1" dirty="0">
-                  <a:solidFill>
-                    <a:srgbClr val="8A9BA3"/>
-                  </a:solidFill>
-                  <a:latin typeface="Calibri" pitchFamily="34" charset="0"/>
-                  <a:ea typeface="Calibri" pitchFamily="34" charset="-122"/>
-                  <a:cs typeface="Calibri" pitchFamily="34" charset="-120"/>
-                </a:rPr>
-                <a:t>vs Mois-1</a:t>
-              </a:r>
-              <a:endParaRPr lang="en-US" sz="950" dirty="0"/>
-            </a:p>
-          </p:txBody>
-        </p:sp>
-      </p:grpSp>
       <p:sp>
         <p:nvSpPr>
           <p:cNvPr id="26" name="Text 10">
@@ -12440,8 +12904,8 @@
         </p:nvSpPr>
         <p:spPr>
           <a:xfrm>
-            <a:off x="749808" y="5998464"/>
-            <a:ext cx="4937760" cy="219456"/>
+            <a:off x="749808" y="5865847"/>
+            <a:ext cx="4937760" cy="352073"/>
           </a:xfrm>
           <a:prstGeom prst="rect">
             <a:avLst/>
@@ -12456,83 +12920,6 @@
             <a:pPr marL="0" indent="0" algn="l">
               <a:buNone/>
             </a:pPr>
-            <a:r>
-              <a:rPr lang="en-US" sz="1050" i="1" dirty="0">
-                <a:solidFill>
-                  <a:srgbClr val="8A9BA3"/>
-                </a:solidFill>
-                <a:latin typeface="Calibri" pitchFamily="34" charset="0"/>
-                <a:ea typeface="Calibri" pitchFamily="34" charset="-122"/>
-                <a:cs typeface="Calibri" pitchFamily="34" charset="-120"/>
-              </a:rPr>
-              <a:t>Stock / </a:t>
-            </a:r>
-            <a:r>
-              <a:rPr lang="en-US" sz="1050" i="1" dirty="0" err="1">
-                <a:solidFill>
-                  <a:srgbClr val="8A9BA3"/>
-                </a:solidFill>
-                <a:latin typeface="Calibri" pitchFamily="34" charset="0"/>
-                <a:ea typeface="Calibri" pitchFamily="34" charset="-122"/>
-                <a:cs typeface="Calibri" pitchFamily="34" charset="-120"/>
-              </a:rPr>
-              <a:t>Inventaires</a:t>
-            </a:r>
-            <a:r>
-              <a:rPr lang="en-US" sz="1050" i="1" dirty="0">
-                <a:solidFill>
-                  <a:srgbClr val="8A9BA3"/>
-                </a:solidFill>
-                <a:latin typeface="Calibri" pitchFamily="34" charset="0"/>
-                <a:ea typeface="Calibri" pitchFamily="34" charset="-122"/>
-                <a:cs typeface="Calibri" pitchFamily="34" charset="-120"/>
-              </a:rPr>
-              <a:t> / Depot + Showroom / </a:t>
-            </a:r>
-            <a:r>
-              <a:rPr lang="en-US" sz="1050" i="1" dirty="0" err="1">
-                <a:solidFill>
-                  <a:srgbClr val="8A9BA3"/>
-                </a:solidFill>
-                <a:latin typeface="Calibri" pitchFamily="34" charset="0"/>
-                <a:ea typeface="Calibri" pitchFamily="34" charset="-122"/>
-                <a:cs typeface="Calibri" pitchFamily="34" charset="-120"/>
-              </a:rPr>
-              <a:t>Familles</a:t>
-            </a:r>
-            <a:r>
-              <a:rPr lang="en-US" sz="1050" i="1" dirty="0">
-                <a:solidFill>
-                  <a:srgbClr val="8A9BA3"/>
-                </a:solidFill>
-                <a:latin typeface="Calibri" pitchFamily="34" charset="0"/>
-                <a:ea typeface="Calibri" pitchFamily="34" charset="-122"/>
-                <a:cs typeface="Calibri" pitchFamily="34" charset="-120"/>
-              </a:rPr>
-              <a:t> = </a:t>
-            </a:r>
-            <a:r>
-              <a:rPr lang="en-US" sz="1050" i="1" dirty="0" err="1">
-                <a:solidFill>
-                  <a:srgbClr val="8A9BA3"/>
-                </a:solidFill>
-                <a:latin typeface="Calibri" pitchFamily="34" charset="0"/>
-                <a:ea typeface="Calibri" pitchFamily="34" charset="-122"/>
-                <a:cs typeface="Calibri" pitchFamily="34" charset="-120"/>
-              </a:rPr>
-              <a:t>Accessoires</a:t>
-            </a:r>
-            <a:r>
-              <a:rPr lang="en-US" sz="1050" i="1" dirty="0">
-                <a:solidFill>
-                  <a:srgbClr val="8A9BA3"/>
-                </a:solidFill>
-                <a:latin typeface="Calibri" pitchFamily="34" charset="0"/>
-                <a:ea typeface="Calibri" pitchFamily="34" charset="-122"/>
-                <a:cs typeface="Calibri" pitchFamily="34" charset="-120"/>
-              </a:rPr>
-              <a:t> Manuel + </a:t>
-            </a:r>
             <a:r>
               <a:rPr lang="en-US" sz="1050" i="1" dirty="0" err="1">
                 <a:solidFill>
@@ -12553,7 +12940,7 @@
                 <a:ea typeface="Calibri" pitchFamily="34" charset="-122"/>
                 <a:cs typeface="Calibri" pitchFamily="34" charset="-120"/>
               </a:rPr>
-              <a:t> Local + </a:t>
+              <a:t> / Articles / Dispo = à </a:t>
             </a:r>
             <a:r>
               <a:rPr lang="en-US" sz="1050" i="1" dirty="0" err="1">
@@ -12564,7 +12951,7 @@
                 <a:ea typeface="Calibri" pitchFamily="34" charset="-122"/>
                 <a:cs typeface="Calibri" pitchFamily="34" charset="-120"/>
               </a:rPr>
-              <a:t>Brosserie</a:t>
+              <a:t>épuisement</a:t>
             </a:r>
             <a:r>
               <a:rPr lang="en-US" sz="1050" i="1" dirty="0">
@@ -12575,7 +12962,7 @@
                 <a:ea typeface="Calibri" pitchFamily="34" charset="-122"/>
                 <a:cs typeface="Calibri" pitchFamily="34" charset="-120"/>
               </a:rPr>
-              <a:t> + Disque </a:t>
+              <a:t> / ventilation </a:t>
             </a:r>
             <a:r>
               <a:rPr lang="en-US" sz="1050" i="1" dirty="0" err="1">
@@ -12586,7 +12973,7 @@
                 <a:ea typeface="Calibri" pitchFamily="34" charset="-122"/>
                 <a:cs typeface="Calibri" pitchFamily="34" charset="-120"/>
               </a:rPr>
-              <a:t>d’entretien</a:t>
+              <a:t>selon</a:t>
             </a:r>
             <a:r>
               <a:rPr lang="en-US" sz="1050" i="1" dirty="0">
@@ -12597,7 +12984,7 @@
                 <a:ea typeface="Calibri" pitchFamily="34" charset="-122"/>
                 <a:cs typeface="Calibri" pitchFamily="34" charset="-120"/>
               </a:rPr>
-              <a:t> + Matériel Manuel + Papier + </a:t>
+              <a:t> Ventes 2026 </a:t>
             </a:r>
             <a:r>
               <a:rPr lang="en-US" sz="1050" i="1" dirty="0" err="1">
@@ -12608,29 +12995,7 @@
                 <a:ea typeface="Calibri" pitchFamily="34" charset="-122"/>
                 <a:cs typeface="Calibri" pitchFamily="34" charset="-120"/>
               </a:rPr>
-              <a:t>Produits</a:t>
-            </a:r>
-            <a:r>
-              <a:rPr lang="en-US" sz="1050" i="1" dirty="0">
-                <a:solidFill>
-                  <a:srgbClr val="8A9BA3"/>
-                </a:solidFill>
-                <a:latin typeface="Calibri" pitchFamily="34" charset="0"/>
-                <a:ea typeface="Calibri" pitchFamily="34" charset="-122"/>
-                <a:cs typeface="Calibri" pitchFamily="34" charset="-120"/>
-              </a:rPr>
-              <a:t> de </a:t>
-            </a:r>
-            <a:r>
-              <a:rPr lang="en-US" sz="1050" i="1" dirty="0" err="1">
-                <a:solidFill>
-                  <a:srgbClr val="8A9BA3"/>
-                </a:solidFill>
-                <a:latin typeface="Calibri" pitchFamily="34" charset="0"/>
-                <a:ea typeface="Calibri" pitchFamily="34" charset="-122"/>
-                <a:cs typeface="Calibri" pitchFamily="34" charset="-120"/>
-              </a:rPr>
-              <a:t>Nettoyage</a:t>
+              <a:t>ou</a:t>
             </a:r>
             <a:r>
               <a:rPr lang="en-US" sz="1050" i="1" dirty="0">
@@ -12642,6 +13007,17 @@
                 <a:cs typeface="Calibri" pitchFamily="34" charset="-120"/>
               </a:rPr>
               <a:t> </a:t>
+            </a:r>
+            <a:r>
+              <a:rPr lang="en-US" sz="1050" i="1" dirty="0" err="1">
+                <a:solidFill>
+                  <a:srgbClr val="8A9BA3"/>
+                </a:solidFill>
+                <a:latin typeface="Calibri" pitchFamily="34" charset="0"/>
+                <a:ea typeface="Calibri" pitchFamily="34" charset="-122"/>
+                <a:cs typeface="Calibri" pitchFamily="34" charset="-120"/>
+              </a:rPr>
+              <a:t>dispo</a:t>
             </a:r>
             <a:endParaRPr lang="en-US" sz="1050" dirty="0"/>
           </a:p>
@@ -12841,7 +13217,7 @@
                 <a:latin typeface="Cambria" pitchFamily="34" charset="0"/>
                 <a:ea typeface="Cambria" pitchFamily="34" charset="-122"/>
               </a:rPr>
-              <a:t>stockée</a:t>
+              <a:t>stockés</a:t>
             </a:r>
             <a:br>
               <a:rPr lang="en-US" sz="1200" dirty="0">
@@ -12863,6 +13239,91 @@
               <a:t>70%</a:t>
             </a:r>
             <a:endParaRPr lang="en-US" sz="1200" dirty="0"/>
+          </a:p>
+        </p:txBody>
+      </p:sp>
+      <p:sp>
+        <p:nvSpPr>
+          <p:cNvPr id="15" name="Shape 8">
+            <a:extLst>
+              <a:ext uri="{FF2B5EF4-FFF2-40B4-BE49-F238E27FC236}">
+                <a16:creationId xmlns:a16="http://schemas.microsoft.com/office/drawing/2014/main" id="{78F60EBA-A6AF-6D61-F1F4-94D8A54F9F56}"/>
+              </a:ext>
+            </a:extLst>
+          </p:cNvPr>
+          <p:cNvSpPr/>
+          <p:nvPr/>
+        </p:nvSpPr>
+        <p:spPr>
+          <a:xfrm>
+            <a:off x="4046824" y="4822741"/>
+            <a:ext cx="1640744" cy="661128"/>
+          </a:xfrm>
+          <a:prstGeom prst="roundRect">
+            <a:avLst>
+              <a:gd name="adj" fmla="val 8929"/>
+            </a:avLst>
+          </a:prstGeom>
+          <a:solidFill>
+            <a:srgbClr val="FFFFFF"/>
+          </a:solidFill>
+          <a:ln w="12700">
+            <a:solidFill>
+              <a:srgbClr val="DCE7E9"/>
+            </a:solidFill>
+            <a:prstDash val="solid"/>
+          </a:ln>
+        </p:spPr>
+        <p:txBody>
+          <a:bodyPr/>
+          <a:lstStyle/>
+          <a:p>
+            <a:endParaRPr lang="fr-RE"/>
+          </a:p>
+        </p:txBody>
+      </p:sp>
+      <p:sp>
+        <p:nvSpPr>
+          <p:cNvPr id="19" name="Text 9">
+            <a:extLst>
+              <a:ext uri="{FF2B5EF4-FFF2-40B4-BE49-F238E27FC236}">
+                <a16:creationId xmlns:a16="http://schemas.microsoft.com/office/drawing/2014/main" id="{27553DDD-F805-9B22-206E-E7BA35AB6E84}"/>
+              </a:ext>
+            </a:extLst>
+          </p:cNvPr>
+          <p:cNvSpPr/>
+          <p:nvPr/>
+        </p:nvSpPr>
+        <p:spPr>
+          <a:xfrm>
+            <a:off x="4027329" y="4910644"/>
+            <a:ext cx="1563624" cy="512064"/>
+          </a:xfrm>
+          <a:prstGeom prst="rect">
+            <a:avLst/>
+          </a:prstGeom>
+          <a:noFill/>
+          <a:ln/>
+        </p:spPr>
+        <p:txBody>
+          <a:bodyPr wrap="square" lIns="0" tIns="0" rIns="0" bIns="0" rtlCol="0" anchor="t"/>
+          <a:lstStyle/>
+          <a:p>
+            <a:pPr marL="0" indent="0" algn="ctr">
+              <a:buNone/>
+            </a:pPr>
+            <a:r>
+              <a:rPr lang="en-US" sz="950" i="1" dirty="0">
+                <a:solidFill>
+                  <a:srgbClr val="8A9BA3"/>
+                </a:solidFill>
+                <a:latin typeface="Calibri" pitchFamily="34" charset="0"/>
+                <a:ea typeface="Calibri" pitchFamily="34" charset="-122"/>
+                <a:cs typeface="Calibri" pitchFamily="34" charset="-120"/>
+              </a:rPr>
+              <a:t>vs Mois-1</a:t>
+            </a:r>
+            <a:endParaRPr lang="en-US" sz="950" dirty="0"/>
           </a:p>
         </p:txBody>
       </p:sp>

</xml_diff>